<commit_message>
feat: Muallif (Abduraxmonov Bexruz) slaydi va rasmi prezentatsiyaga qoshildi
</commit_message>
<xml_diff>
--- a/KiberQoriqchi_Prezentatsiya.pptx
+++ b/KiberQoriqchi_Prezentatsiya.pptx
@@ -17,9 +17,10 @@
     <p:sldId id="265" r:id="rId11"/>
     <p:sldId id="266" r:id="rId12"/>
     <p:sldId id="267" r:id="rId13"/>
+    <p:sldId id="268" r:id="rId14"/>
   </p:sldIdLst>
   <p:notesMasterIdLst>
-    <p:notesMasterId r:id="rId14"/>
+    <p:notesMasterId r:id="rId15"/>
   </p:notesMasterIdLst>
   <p:sldSz cx="9144000" cy="5143500"/>
   <p:notesSz cx="5143500" cy="9144000"/>
@@ -801,6 +802,94 @@
             <a:fld id="{F7021451-1387-4CA6-816F-3879F97B5CBC}" type="slidenum">
               <a:rPr lang="en-US"/>
               <a:t>12</a:t>
+            </a:fld>
+            <a:endParaRPr lang="en-US"/>
+          </a:p>
+        </p:txBody>
+      </p:sp>
+    </p:spTree>
+    <p:extLst>
+      <p:ext uri="{BB962C8B-B14F-4D97-AF65-F5344CB8AC3E}">
+        <p14:creationId xmlns:p14="http://schemas.microsoft.com/office/powerpoint/2010/main" val="1024086991"/>
+      </p:ext>
+    </p:extLst>
+  </p:cSld>
+  <p:clrMapOvr>
+    <a:masterClrMapping/>
+  </p:clrMapOvr>
+</p:notes>
+</file>
+
+<file path=ppt/notesSlides/notesSlide13.xml><?xml version="1.0" encoding="utf-8"?>
+<p:notes xmlns:a="http://schemas.openxmlformats.org/drawingml/2006/main" xmlns:r="http://schemas.openxmlformats.org/officeDocument/2006/relationships" xmlns:p="http://schemas.openxmlformats.org/presentationml/2006/main">
+  <p:cSld>
+    <p:spTree>
+      <p:nvGrpSpPr>
+        <p:cNvPr id="1" name=""/>
+        <p:cNvGrpSpPr/>
+        <p:nvPr/>
+      </p:nvGrpSpPr>
+      <p:grpSpPr>
+        <a:xfrm>
+          <a:off x="0" y="0"/>
+          <a:ext cx="0" cy="0"/>
+          <a:chOff x="0" y="0"/>
+          <a:chExt cx="0" cy="0"/>
+        </a:xfrm>
+      </p:grpSpPr>
+      <p:sp>
+        <p:nvSpPr>
+          <p:cNvPr id="2" name="Slide Image Placeholder 1"/>
+          <p:cNvSpPr>
+            <a:spLocks noGrp="1" noRot="1" noChangeAspect="1"/>
+          </p:cNvSpPr>
+          <p:nvPr>
+            <p:ph type="sldImg"/>
+          </p:nvPr>
+        </p:nvSpPr>
+        <p:spPr/>
+      </p:sp>
+      <p:sp>
+        <p:nvSpPr>
+          <p:cNvPr id="3" name="Notes Placeholder 2"/>
+          <p:cNvSpPr>
+            <a:spLocks noGrp="1"/>
+          </p:cNvSpPr>
+          <p:nvPr>
+            <p:ph type="body" idx="1"/>
+          </p:nvPr>
+        </p:nvSpPr>
+        <p:spPr/>
+        <p:txBody>
+          <a:bodyPr/>
+          <a:lstStyle/>
+          <a:p>
+            <a:r>
+              <a:rPr lang="en-US" dirty="0"/>
+              <a:t/>
+            </a:r>
+            <a:endParaRPr lang="en-US" dirty="0"/>
+          </a:p>
+        </p:txBody>
+      </p:sp>
+      <p:sp>
+        <p:nvSpPr>
+          <p:cNvPr id="4" name="Slide Number Placeholder 3"/>
+          <p:cNvSpPr>
+            <a:spLocks noGrp="1"/>
+          </p:cNvSpPr>
+          <p:nvPr>
+            <p:ph type="sldNum" sz="quarter" idx="10"/>
+          </p:nvPr>
+        </p:nvSpPr>
+        <p:spPr/>
+        <p:txBody>
+          <a:bodyPr/>
+          <a:lstStyle/>
+          <a:p>
+            <a:fld id="{F7021451-1387-4CA6-816F-3879F97B5CBC}" type="slidenum">
+              <a:rPr lang="en-US"/>
+              <a:t>13</a:t>
             </a:fld>
             <a:endParaRPr lang="en-US"/>
           </a:p>
@@ -2116,7 +2205,7 @@
                   <a:srgbClr val="10B981"/>
                 </a:solidFill>
               </a:rPr>
-              <a:t>✔ 100% O‘zbek tilida   ✔ Jonli Laboratoriyalar   ✔ APK Skaneri</a:t>
+              <a:t>Muallif: Abduraxmonov Bexruz   |   100% O‘zbek tilida</a:t>
             </a:r>
             <a:endParaRPr lang="en-US" sz="1100" dirty="0"/>
           </a:p>
@@ -2294,7 +2383,7 @@
                   <a:srgbClr val="059669"/>
                 </a:solidFill>
               </a:rPr>
-              <a:t>SLAYD 10 / 12</a:t>
+              <a:t>SLAYD 10 / 13</a:t>
             </a:r>
             <a:endParaRPr lang="en-US" sz="950" dirty="0"/>
           </a:p>
@@ -2330,7 +2419,7 @@
                   <a:srgbClr val="0F172A"/>
                 </a:solidFill>
               </a:rPr>
-              <a:t>Kamchiliklar va Rivojlantirish Rejalari</a:t>
+              <a:t>Afzalliklari: KiberQoriqchi nega ustun?</a:t>
             </a:r>
             <a:endParaRPr lang="en-US" sz="2000" dirty="0"/>
           </a:p>
@@ -2366,7 +2455,7 @@
                   <a:srgbClr val="475569"/>
                 </a:solidFill>
               </a:rPr>
-              <a:t>Haqiqiy holatni ochiq baholash va kelajakdagi takomillashtirish bosqichlari</a:t>
+              <a:t>Saytning haqiqiy imkoniyatlariga asoslangan asosiy raqobat ustunliklari</a:t>
             </a:r>
             <a:endParaRPr lang="en-US" sz="1100" dirty="0"/>
           </a:p>
@@ -2399,7 +2488,7 @@
       </p:sp>
       <p:pic>
         <p:nvPicPr>
-          <p:cNvPr id="7" name="Image 0" descr="C:\Users\User\Desktop\kiber xavfsizlik boyicha sayt\public\screenshots\12_casestudy.png">    </p:cNvPr>
+          <p:cNvPr id="7" name="Image 0" descr="C:\Users\User\Desktop\kiber xavfsizlik boyicha sayt\public\screenshots\07_leaderboard.png">    </p:cNvPr>
           <p:cNvPicPr>
             <a:picLocks noChangeAspect="1"/>
           </p:cNvPicPr>
@@ -2451,7 +2540,7 @@
                   <a:srgbClr val="BAE6FD"/>
                 </a:solidFill>
               </a:rPr>
-              <a:t>📸 "Hodisalar Tahlili" (Case Study) — kiber-hujumlar tahlili</a:t>
+              <a:t>📸 "Leaderboard" — jonli reyting va musobaqa tizimi</a:t>
             </a:r>
             <a:endParaRPr lang="en-US" sz="900" dirty="0"/>
           </a:p>
@@ -2466,161 +2555,7 @@
         <p:spPr>
           <a:xfrm>
             <a:off x="4846320" y="1325880"/>
-            <a:ext cx="3749040" cy="1645920"/>
-          </a:xfrm>
-          <a:prstGeom prst="roundRect">
-            <a:avLst/>
-          </a:prstGeom>
-          <a:solidFill>
-            <a:srgbClr val="FFFFFF"/>
-          </a:solidFill>
-          <a:ln w="19050">
-            <a:solidFill>
-              <a:srgbClr val="FCD34D"/>
-            </a:solidFill>
-            <a:prstDash val="solid"/>
-          </a:ln>
-        </p:spPr>
-      </p:sp>
-      <p:sp>
-        <p:nvSpPr>
-          <p:cNvPr id="10" name="Text 7"/>
-          <p:cNvSpPr/>
-          <p:nvPr/>
-        </p:nvSpPr>
-        <p:spPr>
-          <a:xfrm>
-            <a:off x="4983480" y="1417320"/>
-            <a:ext cx="3474720" cy="274320"/>
-          </a:xfrm>
-          <a:prstGeom prst="rect">
-            <a:avLst/>
-          </a:prstGeom>
-          <a:noFill/>
-          <a:ln/>
-        </p:spPr>
-        <p:txBody>
-          <a:bodyPr wrap="square" rtlCol="0" anchor="ctr"/>
-          <a:lstStyle/>
-          <a:p>
-            <a:pPr indent="0" marL="0">
-              <a:buNone/>
-            </a:pPr>
-            <a:r>
-              <a:rPr lang="en-US" sz="1100" b="1" dirty="0">
-                <a:solidFill>
-                  <a:srgbClr val="B45309"/>
-                </a:solidFill>
-              </a:rPr>
-              <a:t>⚠️ Aniqlangan Kamchiliklar (MVP):</a:t>
-            </a:r>
-            <a:endParaRPr lang="en-US" sz="1100" dirty="0"/>
-          </a:p>
-        </p:txBody>
-      </p:sp>
-      <p:sp>
-        <p:nvSpPr>
-          <p:cNvPr id="11" name="Text 8"/>
-          <p:cNvSpPr/>
-          <p:nvPr/>
-        </p:nvSpPr>
-        <p:spPr>
-          <a:xfrm>
-            <a:off x="4983480" y="1737360"/>
-            <a:ext cx="3474720" cy="1143000"/>
-          </a:xfrm>
-          <a:prstGeom prst="rect">
-            <a:avLst/>
-          </a:prstGeom>
-          <a:noFill/>
-          <a:ln/>
-        </p:spPr>
-        <p:txBody>
-          <a:bodyPr wrap="square" rtlCol="0" anchor="ctr"/>
-          <a:lstStyle/>
-          <a:p>
-            <a:pPr indent="0" marL="0">
-              <a:buNone/>
-            </a:pPr>
-            <a:r>
-              <a:rPr lang="en-US" sz="900" b="1" dirty="0">
-                <a:solidFill>
-                  <a:srgbClr val="0F172A"/>
-                </a:solidFill>
-              </a:rPr>
-              <a:t>• Dinamik Server Sandboxing: </a:t>
-            </a:r>
-            <a:pPr indent="0" marL="0">
-              <a:buNone/>
-            </a:pPr>
-            <a:r>
-              <a:rPr lang="en-US" sz="900" dirty="0">
-                <a:solidFill>
-                  <a:srgbClr val="475569"/>
-                </a:solidFill>
-              </a:rPr>
-              <a:t>Hozircha veb-simulyatsiya; to‘liq Docker muhiti zarur.
-</a:t>
-            </a:r>
-            <a:pPr indent="0" marL="0">
-              <a:buNone/>
-            </a:pPr>
-            <a:r>
-              <a:rPr lang="en-US" sz="900" b="1" dirty="0">
-                <a:solidFill>
-                  <a:srgbClr val="0F172A"/>
-                </a:solidFill>
-              </a:rPr>
-              <a:t>• Mahalliy ilova yo‘qligi: </a:t>
-            </a:r>
-            <a:pPr indent="0" marL="0">
-              <a:buNone/>
-            </a:pPr>
-            <a:r>
-              <a:rPr lang="en-US" sz="900" dirty="0">
-                <a:solidFill>
-                  <a:srgbClr val="475569"/>
-                </a:solidFill>
-              </a:rPr>
-              <a:t>Android/iOS ilovasi ishlab chiqilmoqda.
-</a:t>
-            </a:r>
-            <a:pPr indent="0" marL="0">
-              <a:buNone/>
-            </a:pPr>
-            <a:r>
-              <a:rPr lang="en-US" sz="900" b="1" dirty="0">
-                <a:solidFill>
-                  <a:srgbClr val="0F172A"/>
-                </a:solidFill>
-              </a:rPr>
-              <a:t>• Telegram bot: </a:t>
-            </a:r>
-            <a:pPr indent="0" marL="0">
-              <a:buNone/>
-            </a:pPr>
-            <a:r>
-              <a:rPr lang="en-US" sz="900" dirty="0">
-                <a:solidFill>
-                  <a:srgbClr val="475569"/>
-                </a:solidFill>
-              </a:rPr>
-              <a:t>Avtomatik APK tekshiruvchi bot ulanmoqda.</a:t>
-            </a:r>
-            <a:endParaRPr lang="en-US" sz="900" dirty="0"/>
-          </a:p>
-        </p:txBody>
-      </p:sp>
-      <p:sp>
-        <p:nvSpPr>
-          <p:cNvPr id="12" name="Shape 9"/>
-          <p:cNvSpPr/>
-          <p:nvPr/>
-        </p:nvSpPr>
-        <p:spPr>
-          <a:xfrm>
-            <a:off x="4846320" y="3154680"/>
-            <a:ext cx="3749040" cy="1645920"/>
+            <a:ext cx="3749040" cy="749808"/>
           </a:xfrm>
           <a:prstGeom prst="roundRect">
             <a:avLst/>
@@ -2638,13 +2573,110 @@
       </p:sp>
       <p:sp>
         <p:nvSpPr>
+          <p:cNvPr id="10" name="Text 7"/>
+          <p:cNvSpPr/>
+          <p:nvPr/>
+        </p:nvSpPr>
+        <p:spPr>
+          <a:xfrm>
+            <a:off x="4983480" y="1399032"/>
+            <a:ext cx="3474720" cy="274320"/>
+          </a:xfrm>
+          <a:prstGeom prst="rect">
+            <a:avLst/>
+          </a:prstGeom>
+          <a:noFill/>
+          <a:ln/>
+        </p:spPr>
+        <p:txBody>
+          <a:bodyPr wrap="square" rtlCol="0" anchor="ctr"/>
+          <a:lstStyle/>
+          <a:p>
+            <a:pPr indent="0" marL="0">
+              <a:buNone/>
+            </a:pPr>
+            <a:r>
+              <a:rPr lang="en-US" sz="1100" b="1" dirty="0">
+                <a:solidFill>
+                  <a:srgbClr val="059669"/>
+                </a:solidFill>
+              </a:rPr>
+              <a:t>1. 100% Ona Tilimizda</a:t>
+            </a:r>
+            <a:endParaRPr lang="en-US" sz="1100" dirty="0"/>
+          </a:p>
+        </p:txBody>
+      </p:sp>
+      <p:sp>
+        <p:nvSpPr>
+          <p:cNvPr id="11" name="Text 8"/>
+          <p:cNvSpPr/>
+          <p:nvPr/>
+        </p:nvSpPr>
+        <p:spPr>
+          <a:xfrm>
+            <a:off x="4983480" y="1673352"/>
+            <a:ext cx="3474720" cy="347472"/>
+          </a:xfrm>
+          <a:prstGeom prst="rect">
+            <a:avLst/>
+          </a:prstGeom>
+          <a:noFill/>
+          <a:ln/>
+        </p:spPr>
+        <p:txBody>
+          <a:bodyPr wrap="square" rtlCol="0" anchor="ctr"/>
+          <a:lstStyle/>
+          <a:p>
+            <a:pPr indent="0" marL="0">
+              <a:buNone/>
+            </a:pPr>
+            <a:r>
+              <a:rPr lang="en-US" sz="950" dirty="0">
+                <a:solidFill>
+                  <a:srgbClr val="475569"/>
+                </a:solidFill>
+              </a:rPr>
+              <a:t>O‘zbekiston to‘lov tizimlari (Click, Payme, Uzcard) kiber-xavflariga moslangan.</a:t>
+            </a:r>
+            <a:endParaRPr lang="en-US" sz="950" dirty="0"/>
+          </a:p>
+        </p:txBody>
+      </p:sp>
+      <p:sp>
+        <p:nvSpPr>
+          <p:cNvPr id="12" name="Shape 9"/>
+          <p:cNvSpPr/>
+          <p:nvPr/>
+        </p:nvSpPr>
+        <p:spPr>
+          <a:xfrm>
+            <a:off x="4846320" y="2194560"/>
+            <a:ext cx="3749040" cy="749808"/>
+          </a:xfrm>
+          <a:prstGeom prst="roundRect">
+            <a:avLst/>
+          </a:prstGeom>
+          <a:solidFill>
+            <a:srgbClr val="FFFFFF"/>
+          </a:solidFill>
+          <a:ln w="19050">
+            <a:solidFill>
+              <a:srgbClr val="6EE7B7"/>
+            </a:solidFill>
+            <a:prstDash val="solid"/>
+          </a:ln>
+        </p:spPr>
+      </p:sp>
+      <p:sp>
+        <p:nvSpPr>
           <p:cNvPr id="13" name="Text 10"/>
           <p:cNvSpPr/>
           <p:nvPr/>
         </p:nvSpPr>
         <p:spPr>
           <a:xfrm>
-            <a:off x="4983480" y="3246120"/>
+            <a:off x="4983480" y="2267712"/>
             <a:ext cx="3474720" cy="274320"/>
           </a:xfrm>
           <a:prstGeom prst="rect">
@@ -2666,7 +2698,7 @@
                   <a:srgbClr val="059669"/>
                 </a:solidFill>
               </a:rPr>
-              <a:t>🚀 Kelajakdagi Rivojlantirish:</a:t>
+              <a:t>2. Ta'lim + Jonli Himoya</a:t>
             </a:r>
             <a:endParaRPr lang="en-US" sz="1100" dirty="0"/>
           </a:p>
@@ -2680,88 +2712,225 @@
         </p:nvSpPr>
         <p:spPr>
           <a:xfrm>
-            <a:off x="4983480" y="3566160"/>
-            <a:ext cx="3474720" cy="1143000"/>
-          </a:xfrm>
-          <a:prstGeom prst="rect">
-            <a:avLst/>
-          </a:prstGeom>
-          <a:noFill/>
-          <a:ln/>
-        </p:spPr>
-        <p:txBody>
-          <a:bodyPr wrap="square" rtlCol="0" anchor="ctr"/>
-          <a:lstStyle/>
-          <a:p>
-            <a:pPr indent="0" marL="0">
-              <a:buNone/>
-            </a:pPr>
-            <a:r>
-              <a:rPr lang="en-US" sz="900" b="1" dirty="0">
-                <a:solidFill>
-                  <a:srgbClr val="0F172A"/>
-                </a:solidFill>
-              </a:rPr>
-              <a:t>• Telegram Xavfsizlik Boti: </a:t>
-            </a:r>
-            <a:pPr indent="0" marL="0">
-              <a:buNone/>
-            </a:pPr>
-            <a:r>
-              <a:rPr lang="en-US" sz="900" dirty="0">
+            <a:off x="4983480" y="2542032"/>
+            <a:ext cx="3474720" cy="347472"/>
+          </a:xfrm>
+          <a:prstGeom prst="rect">
+            <a:avLst/>
+          </a:prstGeom>
+          <a:noFill/>
+          <a:ln/>
+        </p:spPr>
+        <p:txBody>
+          <a:bodyPr wrap="square" rtlCol="0" anchor="ctr"/>
+          <a:lstStyle/>
+          <a:p>
+            <a:pPr indent="0" marL="0">
+              <a:buNone/>
+            </a:pPr>
+            <a:r>
+              <a:rPr lang="en-US" sz="950" dirty="0">
                 <a:solidFill>
                   <a:srgbClr val="475569"/>
                 </a:solidFill>
               </a:rPr>
-              <a:t>Shubhali faylni botga yuborib 2 soniyada natija olish.
-</a:t>
-            </a:r>
-            <a:pPr indent="0" marL="0">
-              <a:buNone/>
-            </a:pPr>
-            <a:r>
-              <a:rPr lang="en-US" sz="900" b="1" dirty="0">
-                <a:solidFill>
-                  <a:srgbClr val="0F172A"/>
-                </a:solidFill>
-              </a:rPr>
-              <a:t>• B2B Korporativ Audit: </a:t>
-            </a:r>
-            <a:pPr indent="0" marL="0">
-              <a:buNone/>
-            </a:pPr>
-            <a:r>
-              <a:rPr lang="en-US" sz="900" dirty="0">
+              <a:t>Faqat ma'ruza emas — smartfon va fayllarni amalda tekshirish qurollari bor.</a:t>
+            </a:r>
+            <a:endParaRPr lang="en-US" sz="950" dirty="0"/>
+          </a:p>
+        </p:txBody>
+      </p:sp>
+      <p:sp>
+        <p:nvSpPr>
+          <p:cNvPr id="15" name="Shape 12"/>
+          <p:cNvSpPr/>
+          <p:nvPr/>
+        </p:nvSpPr>
+        <p:spPr>
+          <a:xfrm>
+            <a:off x="4846320" y="3063240"/>
+            <a:ext cx="3749040" cy="749808"/>
+          </a:xfrm>
+          <a:prstGeom prst="roundRect">
+            <a:avLst/>
+          </a:prstGeom>
+          <a:solidFill>
+            <a:srgbClr val="FFFFFF"/>
+          </a:solidFill>
+          <a:ln w="19050">
+            <a:solidFill>
+              <a:srgbClr val="6EE7B7"/>
+            </a:solidFill>
+            <a:prstDash val="solid"/>
+          </a:ln>
+        </p:spPr>
+      </p:sp>
+      <p:sp>
+        <p:nvSpPr>
+          <p:cNvPr id="16" name="Text 13"/>
+          <p:cNvSpPr/>
+          <p:nvPr/>
+        </p:nvSpPr>
+        <p:spPr>
+          <a:xfrm>
+            <a:off x="4983480" y="3136392"/>
+            <a:ext cx="3474720" cy="274320"/>
+          </a:xfrm>
+          <a:prstGeom prst="rect">
+            <a:avLst/>
+          </a:prstGeom>
+          <a:noFill/>
+          <a:ln/>
+        </p:spPr>
+        <p:txBody>
+          <a:bodyPr wrap="square" rtlCol="0" anchor="ctr"/>
+          <a:lstStyle/>
+          <a:p>
+            <a:pPr indent="0" marL="0">
+              <a:buNone/>
+            </a:pPr>
+            <a:r>
+              <a:rPr lang="en-US" sz="1100" b="1" dirty="0">
+                <a:solidFill>
+                  <a:srgbClr val="059669"/>
+                </a:solidFill>
+              </a:rPr>
+              <a:t>3. Gamifikatsiya va Musobaqa</a:t>
+            </a:r>
+            <a:endParaRPr lang="en-US" sz="1100" dirty="0"/>
+          </a:p>
+        </p:txBody>
+      </p:sp>
+      <p:sp>
+        <p:nvSpPr>
+          <p:cNvPr id="17" name="Text 14"/>
+          <p:cNvSpPr/>
+          <p:nvPr/>
+        </p:nvSpPr>
+        <p:spPr>
+          <a:xfrm>
+            <a:off x="4983480" y="3410712"/>
+            <a:ext cx="3474720" cy="347472"/>
+          </a:xfrm>
+          <a:prstGeom prst="rect">
+            <a:avLst/>
+          </a:prstGeom>
+          <a:noFill/>
+          <a:ln/>
+        </p:spPr>
+        <p:txBody>
+          <a:bodyPr wrap="square" rtlCol="0" anchor="ctr"/>
+          <a:lstStyle/>
+          <a:p>
+            <a:pPr indent="0" marL="0">
+              <a:buNone/>
+            </a:pPr>
+            <a:r>
+              <a:rPr lang="en-US" sz="950" dirty="0">
                 <a:solidFill>
                   <a:srgbClr val="475569"/>
                 </a:solidFill>
               </a:rPr>
-              <a:t>Banklar va korxonalar uchun fishing simulyatsiyasi.
-</a:t>
-            </a:r>
-            <a:pPr indent="0" marL="0">
-              <a:buNone/>
-            </a:pPr>
-            <a:r>
-              <a:rPr lang="en-US" sz="900" b="1" dirty="0">
-                <a:solidFill>
-                  <a:srgbClr val="0F172A"/>
-                </a:solidFill>
-              </a:rPr>
-              <a:t>• Respublika CTF Musobaqasi: </a:t>
-            </a:r>
-            <a:pPr indent="0" marL="0">
-              <a:buNone/>
-            </a:pPr>
-            <a:r>
-              <a:rPr lang="en-US" sz="900" dirty="0">
+              <a:t>Topshiriqlarni bajarish orqali ballar to‘plab umumiy reytingda ko‘tarilish.</a:t>
+            </a:r>
+            <a:endParaRPr lang="en-US" sz="950" dirty="0"/>
+          </a:p>
+        </p:txBody>
+      </p:sp>
+      <p:sp>
+        <p:nvSpPr>
+          <p:cNvPr id="18" name="Shape 15"/>
+          <p:cNvSpPr/>
+          <p:nvPr/>
+        </p:nvSpPr>
+        <p:spPr>
+          <a:xfrm>
+            <a:off x="4846320" y="3931920"/>
+            <a:ext cx="3749040" cy="749808"/>
+          </a:xfrm>
+          <a:prstGeom prst="roundRect">
+            <a:avLst/>
+          </a:prstGeom>
+          <a:solidFill>
+            <a:srgbClr val="FFFFFF"/>
+          </a:solidFill>
+          <a:ln w="19050">
+            <a:solidFill>
+              <a:srgbClr val="6EE7B7"/>
+            </a:solidFill>
+            <a:prstDash val="solid"/>
+          </a:ln>
+        </p:spPr>
+      </p:sp>
+      <p:sp>
+        <p:nvSpPr>
+          <p:cNvPr id="19" name="Text 16"/>
+          <p:cNvSpPr/>
+          <p:nvPr/>
+        </p:nvSpPr>
+        <p:spPr>
+          <a:xfrm>
+            <a:off x="4983480" y="4005072"/>
+            <a:ext cx="3474720" cy="274320"/>
+          </a:xfrm>
+          <a:prstGeom prst="rect">
+            <a:avLst/>
+          </a:prstGeom>
+          <a:noFill/>
+          <a:ln/>
+        </p:spPr>
+        <p:txBody>
+          <a:bodyPr wrap="square" rtlCol="0" anchor="ctr"/>
+          <a:lstStyle/>
+          <a:p>
+            <a:pPr indent="0" marL="0">
+              <a:buNone/>
+            </a:pPr>
+            <a:r>
+              <a:rPr lang="en-US" sz="1100" b="1" dirty="0">
+                <a:solidFill>
+                  <a:srgbClr val="059669"/>
+                </a:solidFill>
+              </a:rPr>
+              <a:t>4. CyberGuard AI Maslahatchi</a:t>
+            </a:r>
+            <a:endParaRPr lang="en-US" sz="1100" dirty="0"/>
+          </a:p>
+        </p:txBody>
+      </p:sp>
+      <p:sp>
+        <p:nvSpPr>
+          <p:cNvPr id="20" name="Text 17"/>
+          <p:cNvSpPr/>
+          <p:nvPr/>
+        </p:nvSpPr>
+        <p:spPr>
+          <a:xfrm>
+            <a:off x="4983480" y="4279392"/>
+            <a:ext cx="3474720" cy="347472"/>
+          </a:xfrm>
+          <a:prstGeom prst="rect">
+            <a:avLst/>
+          </a:prstGeom>
+          <a:noFill/>
+          <a:ln/>
+        </p:spPr>
+        <p:txBody>
+          <a:bodyPr wrap="square" rtlCol="0" anchor="ctr"/>
+          <a:lstStyle/>
+          <a:p>
+            <a:pPr indent="0" marL="0">
+              <a:buNone/>
+            </a:pPr>
+            <a:r>
+              <a:rPr lang="en-US" sz="950" dirty="0">
                 <a:solidFill>
                   <a:srgbClr val="475569"/>
                 </a:solidFill>
               </a:rPr>
-              <a:t>Yoshlar o‘rtasida kiber-olimpiada o‘tkazish.</a:t>
-            </a:r>
-            <a:endParaRPr lang="en-US" sz="900" dirty="0"/>
+              <a:t>Har qanday kiber-savolga o‘zbek tilida 24/7 tezkor va tushunarli javob.</a:t>
+            </a:r>
+            <a:endParaRPr lang="en-US" sz="950" dirty="0"/>
           </a:p>
         </p:txBody>
       </p:sp>
@@ -2852,7 +3021,7 @@
                   <a:srgbClr val="059669"/>
                 </a:solidFill>
               </a:rPr>
-              <a:t>SLAYD 11 / 12</a:t>
+              <a:t>SLAYD 11 / 13</a:t>
             </a:r>
             <a:endParaRPr lang="en-US" sz="950" dirty="0"/>
           </a:p>
@@ -2888,7 +3057,7 @@
                   <a:srgbClr val="0F172A"/>
                 </a:solidFill>
               </a:rPr>
-              <a:t>Xulosa: Loyiha natijasi va jamiyatga foydasi</a:t>
+              <a:t>Kamchiliklar va Rivojlantirish Rejalari</a:t>
             </a:r>
             <a:endParaRPr lang="en-US" sz="2000" dirty="0"/>
           </a:p>
@@ -2924,7 +3093,7 @@
                   <a:srgbClr val="475569"/>
                 </a:solidFill>
               </a:rPr>
-              <a:t>Kiberxavfsizlik — faqat texnologiya emas, balki to‘g‘ri odatlar va amaliy bilimdir</a:t>
+              <a:t>Haqiqiy holatni ochiq baholash va kelajakdagi takomillashtirish bosqichlari</a:t>
             </a:r>
             <a:endParaRPr lang="en-US" sz="1100" dirty="0"/>
           </a:p>
@@ -2957,7 +3126,7 @@
       </p:sp>
       <p:pic>
         <p:nvPicPr>
-          <p:cNvPr id="7" name="Image 0" descr="C:\Users\User\Desktop\kiber xavfsizlik boyicha sayt\public\screenshots\10_login.png">    </p:cNvPr>
+          <p:cNvPr id="7" name="Image 0" descr="C:\Users\User\Desktop\kiber xavfsizlik boyicha sayt\public\screenshots\12_casestudy.png">    </p:cNvPr>
           <p:cNvPicPr>
             <a:picLocks noChangeAspect="1"/>
           </p:cNvPicPr>
@@ -3009,7 +3178,7 @@
                   <a:srgbClr val="BAE6FD"/>
                 </a:solidFill>
               </a:rPr>
-              <a:t>📸 Ro‘yxatdan o‘tish va shaxsiy kabinet interfeysi</a:t>
+              <a:t>📸 "Hodisalar Tahlili" (Case Study) — real kiber-hujumlar tahlili</a:t>
             </a:r>
             <a:endParaRPr lang="en-US" sz="900" dirty="0"/>
           </a:p>
@@ -3024,7 +3193,161 @@
         <p:spPr>
           <a:xfrm>
             <a:off x="4846320" y="1325880"/>
-            <a:ext cx="3749040" cy="1005840"/>
+            <a:ext cx="3749040" cy="1645920"/>
+          </a:xfrm>
+          <a:prstGeom prst="roundRect">
+            <a:avLst/>
+          </a:prstGeom>
+          <a:solidFill>
+            <a:srgbClr val="FFFFFF"/>
+          </a:solidFill>
+          <a:ln w="19050">
+            <a:solidFill>
+              <a:srgbClr val="FCD34D"/>
+            </a:solidFill>
+            <a:prstDash val="solid"/>
+          </a:ln>
+        </p:spPr>
+      </p:sp>
+      <p:sp>
+        <p:nvSpPr>
+          <p:cNvPr id="10" name="Text 7"/>
+          <p:cNvSpPr/>
+          <p:nvPr/>
+        </p:nvSpPr>
+        <p:spPr>
+          <a:xfrm>
+            <a:off x="4983480" y="1417320"/>
+            <a:ext cx="3474720" cy="274320"/>
+          </a:xfrm>
+          <a:prstGeom prst="rect">
+            <a:avLst/>
+          </a:prstGeom>
+          <a:noFill/>
+          <a:ln/>
+        </p:spPr>
+        <p:txBody>
+          <a:bodyPr wrap="square" rtlCol="0" anchor="ctr"/>
+          <a:lstStyle/>
+          <a:p>
+            <a:pPr indent="0" marL="0">
+              <a:buNone/>
+            </a:pPr>
+            <a:r>
+              <a:rPr lang="en-US" sz="1100" b="1" dirty="0">
+                <a:solidFill>
+                  <a:srgbClr val="B45309"/>
+                </a:solidFill>
+              </a:rPr>
+              <a:t>⚠️ Aniqlangan Kamchiliklar (MVP):</a:t>
+            </a:r>
+            <a:endParaRPr lang="en-US" sz="1100" dirty="0"/>
+          </a:p>
+        </p:txBody>
+      </p:sp>
+      <p:sp>
+        <p:nvSpPr>
+          <p:cNvPr id="11" name="Text 8"/>
+          <p:cNvSpPr/>
+          <p:nvPr/>
+        </p:nvSpPr>
+        <p:spPr>
+          <a:xfrm>
+            <a:off x="4983480" y="1737360"/>
+            <a:ext cx="3474720" cy="1143000"/>
+          </a:xfrm>
+          <a:prstGeom prst="rect">
+            <a:avLst/>
+          </a:prstGeom>
+          <a:noFill/>
+          <a:ln/>
+        </p:spPr>
+        <p:txBody>
+          <a:bodyPr wrap="square" rtlCol="0" anchor="ctr"/>
+          <a:lstStyle/>
+          <a:p>
+            <a:pPr indent="0" marL="0">
+              <a:buNone/>
+            </a:pPr>
+            <a:r>
+              <a:rPr lang="en-US" sz="900" b="1" dirty="0">
+                <a:solidFill>
+                  <a:srgbClr val="0F172A"/>
+                </a:solidFill>
+              </a:rPr>
+              <a:t>• Dinamik Server Sandboxing: </a:t>
+            </a:r>
+            <a:pPr indent="0" marL="0">
+              <a:buNone/>
+            </a:pPr>
+            <a:r>
+              <a:rPr lang="en-US" sz="900" dirty="0">
+                <a:solidFill>
+                  <a:srgbClr val="475569"/>
+                </a:solidFill>
+              </a:rPr>
+              <a:t>Hozircha veb-simulyatsiya; to‘liq Docker muhiti zarur.
+</a:t>
+            </a:r>
+            <a:pPr indent="0" marL="0">
+              <a:buNone/>
+            </a:pPr>
+            <a:r>
+              <a:rPr lang="en-US" sz="900" b="1" dirty="0">
+                <a:solidFill>
+                  <a:srgbClr val="0F172A"/>
+                </a:solidFill>
+              </a:rPr>
+              <a:t>• Mahalliy ilova yo‘qligi: </a:t>
+            </a:r>
+            <a:pPr indent="0" marL="0">
+              <a:buNone/>
+            </a:pPr>
+            <a:r>
+              <a:rPr lang="en-US" sz="900" dirty="0">
+                <a:solidFill>
+                  <a:srgbClr val="475569"/>
+                </a:solidFill>
+              </a:rPr>
+              <a:t>Android/iOS ilovasi ishlab chiqilmoqda.
+</a:t>
+            </a:r>
+            <a:pPr indent="0" marL="0">
+              <a:buNone/>
+            </a:pPr>
+            <a:r>
+              <a:rPr lang="en-US" sz="900" b="1" dirty="0">
+                <a:solidFill>
+                  <a:srgbClr val="0F172A"/>
+                </a:solidFill>
+              </a:rPr>
+              <a:t>• Telegram bot: </a:t>
+            </a:r>
+            <a:pPr indent="0" marL="0">
+              <a:buNone/>
+            </a:pPr>
+            <a:r>
+              <a:rPr lang="en-US" sz="900" dirty="0">
+                <a:solidFill>
+                  <a:srgbClr val="475569"/>
+                </a:solidFill>
+              </a:rPr>
+              <a:t>Avtomatik APK tekshiruvchi bot ulanmoqda.</a:t>
+            </a:r>
+            <a:endParaRPr lang="en-US" sz="900" dirty="0"/>
+          </a:p>
+        </p:txBody>
+      </p:sp>
+      <p:sp>
+        <p:nvSpPr>
+          <p:cNvPr id="12" name="Shape 9"/>
+          <p:cNvSpPr/>
+          <p:nvPr/>
+        </p:nvSpPr>
+        <p:spPr>
+          <a:xfrm>
+            <a:off x="4846320" y="3154680"/>
+            <a:ext cx="3749040" cy="1645920"/>
           </a:xfrm>
           <a:prstGeom prst="roundRect">
             <a:avLst/>
@@ -3042,267 +3365,130 @@
       </p:sp>
       <p:sp>
         <p:nvSpPr>
-          <p:cNvPr id="10" name="Text 7"/>
-          <p:cNvSpPr/>
-          <p:nvPr/>
-        </p:nvSpPr>
-        <p:spPr>
-          <a:xfrm>
-            <a:off x="5029200" y="1417320"/>
-            <a:ext cx="1280160" cy="731520"/>
-          </a:xfrm>
-          <a:prstGeom prst="rect">
-            <a:avLst/>
-          </a:prstGeom>
-          <a:noFill/>
-          <a:ln/>
-        </p:spPr>
-        <p:txBody>
-          <a:bodyPr wrap="square" rtlCol="0" anchor="ctr"/>
-          <a:lstStyle/>
-          <a:p>
-            <a:pPr algn="ctr" indent="0" marL="0">
-              <a:buNone/>
-            </a:pPr>
-            <a:r>
-              <a:rPr lang="en-US" sz="2600" b="1" dirty="0">
+          <p:cNvPr id="13" name="Text 10"/>
+          <p:cNvSpPr/>
+          <p:nvPr/>
+        </p:nvSpPr>
+        <p:spPr>
+          <a:xfrm>
+            <a:off x="4983480" y="3246120"/>
+            <a:ext cx="3474720" cy="274320"/>
+          </a:xfrm>
+          <a:prstGeom prst="rect">
+            <a:avLst/>
+          </a:prstGeom>
+          <a:noFill/>
+          <a:ln/>
+        </p:spPr>
+        <p:txBody>
+          <a:bodyPr wrap="square" rtlCol="0" anchor="ctr"/>
+          <a:lstStyle/>
+          <a:p>
+            <a:pPr indent="0" marL="0">
+              <a:buNone/>
+            </a:pPr>
+            <a:r>
+              <a:rPr lang="en-US" sz="1100" b="1" dirty="0">
                 <a:solidFill>
                   <a:srgbClr val="059669"/>
                 </a:solidFill>
               </a:rPr>
-              <a:t>32M+</a:t>
-            </a:r>
-            <a:endParaRPr lang="en-US" sz="2600" dirty="0"/>
-          </a:p>
-        </p:txBody>
-      </p:sp>
-      <p:sp>
-        <p:nvSpPr>
-          <p:cNvPr id="11" name="Text 8"/>
-          <p:cNvSpPr/>
-          <p:nvPr/>
-        </p:nvSpPr>
-        <p:spPr>
-          <a:xfrm>
-            <a:off x="6400800" y="1463040"/>
-            <a:ext cx="2057400" cy="731520"/>
-          </a:xfrm>
-          <a:prstGeom prst="rect">
-            <a:avLst/>
-          </a:prstGeom>
-          <a:noFill/>
-          <a:ln/>
-        </p:spPr>
-        <p:txBody>
-          <a:bodyPr wrap="square" rtlCol="0" anchor="ctr"/>
-          <a:lstStyle/>
-          <a:p>
-            <a:pPr indent="0" marL="0">
-              <a:buNone/>
-            </a:pPr>
-            <a:r>
-              <a:rPr lang="en-US" sz="1000" dirty="0">
+              <a:t>🚀 Kelajakdagi Rivojlantirish:</a:t>
+            </a:r>
+            <a:endParaRPr lang="en-US" sz="1100" dirty="0"/>
+          </a:p>
+        </p:txBody>
+      </p:sp>
+      <p:sp>
+        <p:nvSpPr>
+          <p:cNvPr id="14" name="Text 11"/>
+          <p:cNvSpPr/>
+          <p:nvPr/>
+        </p:nvSpPr>
+        <p:spPr>
+          <a:xfrm>
+            <a:off x="4983480" y="3566160"/>
+            <a:ext cx="3474720" cy="1143000"/>
+          </a:xfrm>
+          <a:prstGeom prst="rect">
+            <a:avLst/>
+          </a:prstGeom>
+          <a:noFill/>
+          <a:ln/>
+        </p:spPr>
+        <p:txBody>
+          <a:bodyPr wrap="square" rtlCol="0" anchor="ctr"/>
+          <a:lstStyle/>
+          <a:p>
+            <a:pPr indent="0" marL="0">
+              <a:buNone/>
+            </a:pPr>
+            <a:r>
+              <a:rPr lang="en-US" sz="900" b="1" dirty="0">
                 <a:solidFill>
                   <a:srgbClr val="0F172A"/>
                 </a:solidFill>
               </a:rPr>
-              <a:t>Aholi kiber-xavflardan himoyalanish madaniyatiga ega bo‘ladi.</a:t>
-            </a:r>
-            <a:endParaRPr lang="en-US" sz="1000" dirty="0"/>
-          </a:p>
-        </p:txBody>
-      </p:sp>
-      <p:sp>
-        <p:nvSpPr>
-          <p:cNvPr id="12" name="Shape 9"/>
-          <p:cNvSpPr/>
-          <p:nvPr/>
-        </p:nvSpPr>
-        <p:spPr>
-          <a:xfrm>
-            <a:off x="4846320" y="2468880"/>
-            <a:ext cx="3749040" cy="1005840"/>
-          </a:xfrm>
-          <a:prstGeom prst="roundRect">
-            <a:avLst/>
-          </a:prstGeom>
-          <a:solidFill>
-            <a:srgbClr val="FFFFFF"/>
-          </a:solidFill>
-          <a:ln w="19050">
-            <a:solidFill>
-              <a:srgbClr val="6EE7B7"/>
-            </a:solidFill>
-            <a:prstDash val="solid"/>
-          </a:ln>
-        </p:spPr>
-      </p:sp>
-      <p:sp>
-        <p:nvSpPr>
-          <p:cNvPr id="13" name="Text 10"/>
-          <p:cNvSpPr/>
-          <p:nvPr/>
-        </p:nvSpPr>
-        <p:spPr>
-          <a:xfrm>
-            <a:off x="5029200" y="2560320"/>
-            <a:ext cx="1280160" cy="731520"/>
-          </a:xfrm>
-          <a:prstGeom prst="rect">
-            <a:avLst/>
-          </a:prstGeom>
-          <a:noFill/>
-          <a:ln/>
-        </p:spPr>
-        <p:txBody>
-          <a:bodyPr wrap="square" rtlCol="0" anchor="ctr"/>
-          <a:lstStyle/>
-          <a:p>
-            <a:pPr algn="ctr" indent="0" marL="0">
-              <a:buNone/>
-            </a:pPr>
-            <a:r>
-              <a:rPr lang="en-US" sz="2600" b="1" dirty="0">
-                <a:solidFill>
-                  <a:srgbClr val="059669"/>
-                </a:solidFill>
-              </a:rPr>
-              <a:t>1-Click</a:t>
-            </a:r>
-            <a:endParaRPr lang="en-US" sz="2600" dirty="0"/>
-          </a:p>
-        </p:txBody>
-      </p:sp>
-      <p:sp>
-        <p:nvSpPr>
-          <p:cNvPr id="14" name="Text 11"/>
-          <p:cNvSpPr/>
-          <p:nvPr/>
-        </p:nvSpPr>
-        <p:spPr>
-          <a:xfrm>
-            <a:off x="6400800" y="2606040"/>
-            <a:ext cx="2057400" cy="731520"/>
-          </a:xfrm>
-          <a:prstGeom prst="rect">
-            <a:avLst/>
-          </a:prstGeom>
-          <a:noFill/>
-          <a:ln/>
-        </p:spPr>
-        <p:txBody>
-          <a:bodyPr wrap="square" rtlCol="0" anchor="ctr"/>
-          <a:lstStyle/>
-          <a:p>
-            <a:pPr indent="0" marL="0">
-              <a:buNone/>
-            </a:pPr>
-            <a:r>
-              <a:rPr lang="en-US" sz="1000" dirty="0">
+              <a:t>• Telegram Xavfsizlik Boti: </a:t>
+            </a:r>
+            <a:pPr indent="0" marL="0">
+              <a:buNone/>
+            </a:pPr>
+            <a:r>
+              <a:rPr lang="en-US" sz="900" dirty="0">
+                <a:solidFill>
+                  <a:srgbClr val="475569"/>
+                </a:solidFill>
+              </a:rPr>
+              <a:t>Shubhali faylni botga yuborib 2 soniyada natija olish.
+</a:t>
+            </a:r>
+            <a:pPr indent="0" marL="0">
+              <a:buNone/>
+            </a:pPr>
+            <a:r>
+              <a:rPr lang="en-US" sz="900" b="1" dirty="0">
                 <a:solidFill>
                   <a:srgbClr val="0F172A"/>
                 </a:solidFill>
               </a:rPr>
-              <a:t>Smartfon va APK xavfsizligini tekshirish uchun oson milliy yechim.</a:t>
-            </a:r>
-            <a:endParaRPr lang="en-US" sz="1000" dirty="0"/>
-          </a:p>
-        </p:txBody>
-      </p:sp>
-      <p:sp>
-        <p:nvSpPr>
-          <p:cNvPr id="15" name="Shape 12"/>
-          <p:cNvSpPr/>
-          <p:nvPr/>
-        </p:nvSpPr>
-        <p:spPr>
-          <a:xfrm>
-            <a:off x="4846320" y="3611880"/>
-            <a:ext cx="3749040" cy="1005840"/>
-          </a:xfrm>
-          <a:prstGeom prst="roundRect">
-            <a:avLst/>
-          </a:prstGeom>
-          <a:solidFill>
-            <a:srgbClr val="FFFFFF"/>
-          </a:solidFill>
-          <a:ln w="19050">
-            <a:solidFill>
-              <a:srgbClr val="6EE7B7"/>
-            </a:solidFill>
-            <a:prstDash val="solid"/>
-          </a:ln>
-        </p:spPr>
-      </p:sp>
-      <p:sp>
-        <p:nvSpPr>
-          <p:cNvPr id="16" name="Text 13"/>
-          <p:cNvSpPr/>
-          <p:nvPr/>
-        </p:nvSpPr>
-        <p:spPr>
-          <a:xfrm>
-            <a:off x="5029200" y="3703320"/>
-            <a:ext cx="1280160" cy="731520"/>
-          </a:xfrm>
-          <a:prstGeom prst="rect">
-            <a:avLst/>
-          </a:prstGeom>
-          <a:noFill/>
-          <a:ln/>
-        </p:spPr>
-        <p:txBody>
-          <a:bodyPr wrap="square" rtlCol="0" anchor="ctr"/>
-          <a:lstStyle/>
-          <a:p>
-            <a:pPr algn="ctr" indent="0" marL="0">
-              <a:buNone/>
-            </a:pPr>
-            <a:r>
-              <a:rPr lang="en-US" sz="2600" b="1" dirty="0">
-                <a:solidFill>
-                  <a:srgbClr val="059669"/>
-                </a:solidFill>
-              </a:rPr>
-              <a:t>100%</a:t>
-            </a:r>
-            <a:endParaRPr lang="en-US" sz="2600" dirty="0"/>
-          </a:p>
-        </p:txBody>
-      </p:sp>
-      <p:sp>
-        <p:nvSpPr>
-          <p:cNvPr id="17" name="Text 14"/>
-          <p:cNvSpPr/>
-          <p:nvPr/>
-        </p:nvSpPr>
-        <p:spPr>
-          <a:xfrm>
-            <a:off x="6400800" y="3749040"/>
-            <a:ext cx="2057400" cy="731520"/>
-          </a:xfrm>
-          <a:prstGeom prst="rect">
-            <a:avLst/>
-          </a:prstGeom>
-          <a:noFill/>
-          <a:ln/>
-        </p:spPr>
-        <p:txBody>
-          <a:bodyPr wrap="square" rtlCol="0" anchor="ctr"/>
-          <a:lstStyle/>
-          <a:p>
-            <a:pPr indent="0" marL="0">
-              <a:buNone/>
-            </a:pPr>
-            <a:r>
-              <a:rPr lang="en-US" sz="1000" dirty="0">
+              <a:t>• B2B Korporativ Audit: </a:t>
+            </a:r>
+            <a:pPr indent="0" marL="0">
+              <a:buNone/>
+            </a:pPr>
+            <a:r>
+              <a:rPr lang="en-US" sz="900" dirty="0">
+                <a:solidFill>
+                  <a:srgbClr val="475569"/>
+                </a:solidFill>
+              </a:rPr>
+              <a:t>Banklar va korxonalar uchun fishing simulyatsiyasi.
+</a:t>
+            </a:r>
+            <a:pPr indent="0" marL="0">
+              <a:buNone/>
+            </a:pPr>
+            <a:r>
+              <a:rPr lang="en-US" sz="900" b="1" dirty="0">
                 <a:solidFill>
                   <a:srgbClr val="0F172A"/>
                 </a:solidFill>
               </a:rPr>
-              <a:t>Ona tilimizda yangi avlod kiber-mutaxassislari tayyorlanadi.</a:t>
-            </a:r>
-            <a:endParaRPr lang="en-US" sz="1000" dirty="0"/>
+              <a:t>• Respublika CTF Musobaqasi: </a:t>
+            </a:r>
+            <a:pPr indent="0" marL="0">
+              <a:buNone/>
+            </a:pPr>
+            <a:r>
+              <a:rPr lang="en-US" sz="900" dirty="0">
+                <a:solidFill>
+                  <a:srgbClr val="475569"/>
+                </a:solidFill>
+              </a:rPr>
+              <a:t>Yoshlar o‘rtasida kiber-olimpiada o‘tkazish.</a:t>
+            </a:r>
+            <a:endParaRPr lang="en-US" sz="900" dirty="0"/>
           </a:p>
         </p:txBody>
       </p:sp>
@@ -3317,6 +3503,547 @@
 <file path=ppt/slides/slide12.xml><?xml version="1.0" encoding="utf-8"?>
 <p:sld xmlns:a="http://schemas.openxmlformats.org/drawingml/2006/main" xmlns:r="http://schemas.openxmlformats.org/officeDocument/2006/relationships" xmlns:p="http://schemas.openxmlformats.org/presentationml/2006/main">
   <p:cSld name="Slide 12">
+    <p:bg>
+      <p:bgPr>
+        <a:solidFill>
+          <a:srgbClr val="F4F6F9"/>
+        </a:solidFill>
+      </p:bgPr>
+    </p:bg>
+    <p:spTree>
+      <p:nvGrpSpPr>
+        <p:cNvPr id="1" name=""/>
+        <p:cNvGrpSpPr/>
+        <p:nvPr/>
+      </p:nvGrpSpPr>
+      <p:grpSpPr>
+        <a:xfrm>
+          <a:off x="0" y="0"/>
+          <a:ext cx="0" cy="0"/>
+          <a:chOff x="0" y="0"/>
+          <a:chExt cx="0" cy="0"/>
+        </a:xfrm>
+      </p:grpSpPr>
+      <p:sp>
+        <p:nvSpPr>
+          <p:cNvPr id="2" name="Shape 0"/>
+          <p:cNvSpPr/>
+          <p:nvPr/>
+        </p:nvSpPr>
+        <p:spPr>
+          <a:xfrm>
+            <a:off x="548640" y="228600"/>
+            <a:ext cx="2011680" cy="274320"/>
+          </a:xfrm>
+          <a:prstGeom prst="roundRect">
+            <a:avLst/>
+          </a:prstGeom>
+          <a:solidFill>
+            <a:srgbClr val="ECFDF5"/>
+          </a:solidFill>
+          <a:ln w="12700">
+            <a:solidFill>
+              <a:srgbClr val="10B981"/>
+            </a:solidFill>
+            <a:prstDash val="solid"/>
+          </a:ln>
+        </p:spPr>
+      </p:sp>
+      <p:sp>
+        <p:nvSpPr>
+          <p:cNvPr id="3" name="Text 1"/>
+          <p:cNvSpPr/>
+          <p:nvPr/>
+        </p:nvSpPr>
+        <p:spPr>
+          <a:xfrm>
+            <a:off x="548640" y="228600"/>
+            <a:ext cx="2011680" cy="274320"/>
+          </a:xfrm>
+          <a:prstGeom prst="rect">
+            <a:avLst/>
+          </a:prstGeom>
+          <a:noFill/>
+          <a:ln/>
+        </p:spPr>
+        <p:txBody>
+          <a:bodyPr wrap="square" rtlCol="0" anchor="ctr"/>
+          <a:lstStyle/>
+          <a:p>
+            <a:pPr algn="ctr" indent="0" marL="0">
+              <a:buNone/>
+            </a:pPr>
+            <a:r>
+              <a:rPr lang="en-US" sz="950" b="1" dirty="0">
+                <a:solidFill>
+                  <a:srgbClr val="059669"/>
+                </a:solidFill>
+              </a:rPr>
+              <a:t>SLAYD 12 / 13</a:t>
+            </a:r>
+            <a:endParaRPr lang="en-US" sz="950" dirty="0"/>
+          </a:p>
+        </p:txBody>
+      </p:sp>
+      <p:sp>
+        <p:nvSpPr>
+          <p:cNvPr id="4" name="Text 2"/>
+          <p:cNvSpPr/>
+          <p:nvPr/>
+        </p:nvSpPr>
+        <p:spPr>
+          <a:xfrm>
+            <a:off x="548640" y="548640"/>
+            <a:ext cx="8046720" cy="411480"/>
+          </a:xfrm>
+          <a:prstGeom prst="rect">
+            <a:avLst/>
+          </a:prstGeom>
+          <a:noFill/>
+          <a:ln/>
+        </p:spPr>
+        <p:txBody>
+          <a:bodyPr wrap="square" rtlCol="0" anchor="ctr"/>
+          <a:lstStyle/>
+          <a:p>
+            <a:pPr indent="0" marL="0">
+              <a:buNone/>
+            </a:pPr>
+            <a:r>
+              <a:rPr lang="en-US" sz="2000" b="1" dirty="0">
+                <a:solidFill>
+                  <a:srgbClr val="0F172A"/>
+                </a:solidFill>
+              </a:rPr>
+              <a:t>Xulosa: Loyiha natijasi va jamiyatga foydasi</a:t>
+            </a:r>
+            <a:endParaRPr lang="en-US" sz="2000" dirty="0"/>
+          </a:p>
+        </p:txBody>
+      </p:sp>
+      <p:sp>
+        <p:nvSpPr>
+          <p:cNvPr id="5" name="Text 3"/>
+          <p:cNvSpPr/>
+          <p:nvPr/>
+        </p:nvSpPr>
+        <p:spPr>
+          <a:xfrm>
+            <a:off x="548640" y="960120"/>
+            <a:ext cx="8046720" cy="274320"/>
+          </a:xfrm>
+          <a:prstGeom prst="rect">
+            <a:avLst/>
+          </a:prstGeom>
+          <a:noFill/>
+          <a:ln/>
+        </p:spPr>
+        <p:txBody>
+          <a:bodyPr wrap="square" rtlCol="0" anchor="ctr"/>
+          <a:lstStyle/>
+          <a:p>
+            <a:pPr indent="0" marL="0">
+              <a:buNone/>
+            </a:pPr>
+            <a:r>
+              <a:rPr lang="en-US" sz="1100" dirty="0">
+                <a:solidFill>
+                  <a:srgbClr val="475569"/>
+                </a:solidFill>
+              </a:rPr>
+              <a:t>Kiberxavfsizlik — faqat texnologiya emas, balki to‘g‘ri odatlar va amaliy bilimdir</a:t>
+            </a:r>
+            <a:endParaRPr lang="en-US" sz="1100" dirty="0"/>
+          </a:p>
+        </p:txBody>
+      </p:sp>
+      <p:sp>
+        <p:nvSpPr>
+          <p:cNvPr id="6" name="Shape 4"/>
+          <p:cNvSpPr/>
+          <p:nvPr/>
+        </p:nvSpPr>
+        <p:spPr>
+          <a:xfrm>
+            <a:off x="512064" y="1289304"/>
+            <a:ext cx="4096512" cy="3822192"/>
+          </a:xfrm>
+          <a:prstGeom prst="roundRect">
+            <a:avLst/>
+          </a:prstGeom>
+          <a:solidFill>
+            <a:srgbClr val="0D1A26"/>
+          </a:solidFill>
+          <a:ln w="19050">
+            <a:solidFill>
+              <a:srgbClr val="059669"/>
+            </a:solidFill>
+            <a:prstDash val="solid"/>
+          </a:ln>
+        </p:spPr>
+      </p:sp>
+      <p:pic>
+        <p:nvPicPr>
+          <p:cNvPr id="7" name="Image 0" descr="C:\Users\User\Desktop\kiber xavfsizlik boyicha sayt\public\screenshots\10_login.png">    </p:cNvPr>
+          <p:cNvPicPr>
+            <a:picLocks noChangeAspect="1"/>
+          </p:cNvPicPr>
+          <p:nvPr/>
+        </p:nvPicPr>
+        <p:blipFill>
+          <a:blip r:embed="rId1"/>
+          <a:stretch>
+            <a:fillRect/>
+          </a:stretch>
+        </p:blipFill>
+        <p:spPr>
+          <a:xfrm>
+            <a:off x="548640" y="1325880"/>
+            <a:ext cx="4023360" cy="3474720"/>
+          </a:xfrm>
+          <a:prstGeom prst="rect">
+            <a:avLst/>
+          </a:prstGeom>
+        </p:spPr>
+      </p:pic>
+      <p:sp>
+        <p:nvSpPr>
+          <p:cNvPr id="8" name="Text 5"/>
+          <p:cNvSpPr/>
+          <p:nvPr/>
+        </p:nvSpPr>
+        <p:spPr>
+          <a:xfrm>
+            <a:off x="548640" y="4837176"/>
+            <a:ext cx="4023360" cy="274320"/>
+          </a:xfrm>
+          <a:prstGeom prst="rect">
+            <a:avLst/>
+          </a:prstGeom>
+          <a:noFill/>
+          <a:ln/>
+        </p:spPr>
+        <p:txBody>
+          <a:bodyPr wrap="square" rtlCol="0" anchor="ctr"/>
+          <a:lstStyle/>
+          <a:p>
+            <a:pPr algn="ctr" indent="0" marL="0">
+              <a:buNone/>
+            </a:pPr>
+            <a:r>
+              <a:rPr lang="en-US" sz="900" dirty="0">
+                <a:solidFill>
+                  <a:srgbClr val="BAE6FD"/>
+                </a:solidFill>
+              </a:rPr>
+              <a:t>📸 Ro‘yxatdan o‘tish va shaxsiy kabinet interfeysi</a:t>
+            </a:r>
+            <a:endParaRPr lang="en-US" sz="900" dirty="0"/>
+          </a:p>
+        </p:txBody>
+      </p:sp>
+      <p:sp>
+        <p:nvSpPr>
+          <p:cNvPr id="9" name="Shape 6"/>
+          <p:cNvSpPr/>
+          <p:nvPr/>
+        </p:nvSpPr>
+        <p:spPr>
+          <a:xfrm>
+            <a:off x="4846320" y="1325880"/>
+            <a:ext cx="3749040" cy="1005840"/>
+          </a:xfrm>
+          <a:prstGeom prst="roundRect">
+            <a:avLst/>
+          </a:prstGeom>
+          <a:solidFill>
+            <a:srgbClr val="FFFFFF"/>
+          </a:solidFill>
+          <a:ln w="19050">
+            <a:solidFill>
+              <a:srgbClr val="6EE7B7"/>
+            </a:solidFill>
+            <a:prstDash val="solid"/>
+          </a:ln>
+        </p:spPr>
+      </p:sp>
+      <p:sp>
+        <p:nvSpPr>
+          <p:cNvPr id="10" name="Text 7"/>
+          <p:cNvSpPr/>
+          <p:nvPr/>
+        </p:nvSpPr>
+        <p:spPr>
+          <a:xfrm>
+            <a:off x="5029200" y="1417320"/>
+            <a:ext cx="1280160" cy="731520"/>
+          </a:xfrm>
+          <a:prstGeom prst="rect">
+            <a:avLst/>
+          </a:prstGeom>
+          <a:noFill/>
+          <a:ln/>
+        </p:spPr>
+        <p:txBody>
+          <a:bodyPr wrap="square" rtlCol="0" anchor="ctr"/>
+          <a:lstStyle/>
+          <a:p>
+            <a:pPr algn="ctr" indent="0" marL="0">
+              <a:buNone/>
+            </a:pPr>
+            <a:r>
+              <a:rPr lang="en-US" sz="2600" b="1" dirty="0">
+                <a:solidFill>
+                  <a:srgbClr val="059669"/>
+                </a:solidFill>
+              </a:rPr>
+              <a:t>32M+</a:t>
+            </a:r>
+            <a:endParaRPr lang="en-US" sz="2600" dirty="0"/>
+          </a:p>
+        </p:txBody>
+      </p:sp>
+      <p:sp>
+        <p:nvSpPr>
+          <p:cNvPr id="11" name="Text 8"/>
+          <p:cNvSpPr/>
+          <p:nvPr/>
+        </p:nvSpPr>
+        <p:spPr>
+          <a:xfrm>
+            <a:off x="6400800" y="1463040"/>
+            <a:ext cx="2057400" cy="731520"/>
+          </a:xfrm>
+          <a:prstGeom prst="rect">
+            <a:avLst/>
+          </a:prstGeom>
+          <a:noFill/>
+          <a:ln/>
+        </p:spPr>
+        <p:txBody>
+          <a:bodyPr wrap="square" rtlCol="0" anchor="ctr"/>
+          <a:lstStyle/>
+          <a:p>
+            <a:pPr indent="0" marL="0">
+              <a:buNone/>
+            </a:pPr>
+            <a:r>
+              <a:rPr lang="en-US" sz="1000" dirty="0">
+                <a:solidFill>
+                  <a:srgbClr val="0F172A"/>
+                </a:solidFill>
+              </a:rPr>
+              <a:t>Aholi kiber-xavflardan himoyalanish madaniyatiga ega bo‘ladi.</a:t>
+            </a:r>
+            <a:endParaRPr lang="en-US" sz="1000" dirty="0"/>
+          </a:p>
+        </p:txBody>
+      </p:sp>
+      <p:sp>
+        <p:nvSpPr>
+          <p:cNvPr id="12" name="Shape 9"/>
+          <p:cNvSpPr/>
+          <p:nvPr/>
+        </p:nvSpPr>
+        <p:spPr>
+          <a:xfrm>
+            <a:off x="4846320" y="2468880"/>
+            <a:ext cx="3749040" cy="1005840"/>
+          </a:xfrm>
+          <a:prstGeom prst="roundRect">
+            <a:avLst/>
+          </a:prstGeom>
+          <a:solidFill>
+            <a:srgbClr val="FFFFFF"/>
+          </a:solidFill>
+          <a:ln w="19050">
+            <a:solidFill>
+              <a:srgbClr val="6EE7B7"/>
+            </a:solidFill>
+            <a:prstDash val="solid"/>
+          </a:ln>
+        </p:spPr>
+      </p:sp>
+      <p:sp>
+        <p:nvSpPr>
+          <p:cNvPr id="13" name="Text 10"/>
+          <p:cNvSpPr/>
+          <p:nvPr/>
+        </p:nvSpPr>
+        <p:spPr>
+          <a:xfrm>
+            <a:off x="5029200" y="2560320"/>
+            <a:ext cx="1280160" cy="731520"/>
+          </a:xfrm>
+          <a:prstGeom prst="rect">
+            <a:avLst/>
+          </a:prstGeom>
+          <a:noFill/>
+          <a:ln/>
+        </p:spPr>
+        <p:txBody>
+          <a:bodyPr wrap="square" rtlCol="0" anchor="ctr"/>
+          <a:lstStyle/>
+          <a:p>
+            <a:pPr algn="ctr" indent="0" marL="0">
+              <a:buNone/>
+            </a:pPr>
+            <a:r>
+              <a:rPr lang="en-US" sz="2600" b="1" dirty="0">
+                <a:solidFill>
+                  <a:srgbClr val="059669"/>
+                </a:solidFill>
+              </a:rPr>
+              <a:t>1-Click</a:t>
+            </a:r>
+            <a:endParaRPr lang="en-US" sz="2600" dirty="0"/>
+          </a:p>
+        </p:txBody>
+      </p:sp>
+      <p:sp>
+        <p:nvSpPr>
+          <p:cNvPr id="14" name="Text 11"/>
+          <p:cNvSpPr/>
+          <p:nvPr/>
+        </p:nvSpPr>
+        <p:spPr>
+          <a:xfrm>
+            <a:off x="6400800" y="2606040"/>
+            <a:ext cx="2057400" cy="731520"/>
+          </a:xfrm>
+          <a:prstGeom prst="rect">
+            <a:avLst/>
+          </a:prstGeom>
+          <a:noFill/>
+          <a:ln/>
+        </p:spPr>
+        <p:txBody>
+          <a:bodyPr wrap="square" rtlCol="0" anchor="ctr"/>
+          <a:lstStyle/>
+          <a:p>
+            <a:pPr indent="0" marL="0">
+              <a:buNone/>
+            </a:pPr>
+            <a:r>
+              <a:rPr lang="en-US" sz="1000" dirty="0">
+                <a:solidFill>
+                  <a:srgbClr val="0F172A"/>
+                </a:solidFill>
+              </a:rPr>
+              <a:t>Smartfon va APK xavfsizligini tekshirish uchun oson milliy yechim.</a:t>
+            </a:r>
+            <a:endParaRPr lang="en-US" sz="1000" dirty="0"/>
+          </a:p>
+        </p:txBody>
+      </p:sp>
+      <p:sp>
+        <p:nvSpPr>
+          <p:cNvPr id="15" name="Shape 12"/>
+          <p:cNvSpPr/>
+          <p:nvPr/>
+        </p:nvSpPr>
+        <p:spPr>
+          <a:xfrm>
+            <a:off x="4846320" y="3611880"/>
+            <a:ext cx="3749040" cy="1005840"/>
+          </a:xfrm>
+          <a:prstGeom prst="roundRect">
+            <a:avLst/>
+          </a:prstGeom>
+          <a:solidFill>
+            <a:srgbClr val="FFFFFF"/>
+          </a:solidFill>
+          <a:ln w="19050">
+            <a:solidFill>
+              <a:srgbClr val="6EE7B7"/>
+            </a:solidFill>
+            <a:prstDash val="solid"/>
+          </a:ln>
+        </p:spPr>
+      </p:sp>
+      <p:sp>
+        <p:nvSpPr>
+          <p:cNvPr id="16" name="Text 13"/>
+          <p:cNvSpPr/>
+          <p:nvPr/>
+        </p:nvSpPr>
+        <p:spPr>
+          <a:xfrm>
+            <a:off x="5029200" y="3703320"/>
+            <a:ext cx="1280160" cy="731520"/>
+          </a:xfrm>
+          <a:prstGeom prst="rect">
+            <a:avLst/>
+          </a:prstGeom>
+          <a:noFill/>
+          <a:ln/>
+        </p:spPr>
+        <p:txBody>
+          <a:bodyPr wrap="square" rtlCol="0" anchor="ctr"/>
+          <a:lstStyle/>
+          <a:p>
+            <a:pPr algn="ctr" indent="0" marL="0">
+              <a:buNone/>
+            </a:pPr>
+            <a:r>
+              <a:rPr lang="en-US" sz="2600" b="1" dirty="0">
+                <a:solidFill>
+                  <a:srgbClr val="059669"/>
+                </a:solidFill>
+              </a:rPr>
+              <a:t>100%</a:t>
+            </a:r>
+            <a:endParaRPr lang="en-US" sz="2600" dirty="0"/>
+          </a:p>
+        </p:txBody>
+      </p:sp>
+      <p:sp>
+        <p:nvSpPr>
+          <p:cNvPr id="17" name="Text 14"/>
+          <p:cNvSpPr/>
+          <p:nvPr/>
+        </p:nvSpPr>
+        <p:spPr>
+          <a:xfrm>
+            <a:off x="6400800" y="3749040"/>
+            <a:ext cx="2057400" cy="731520"/>
+          </a:xfrm>
+          <a:prstGeom prst="rect">
+            <a:avLst/>
+          </a:prstGeom>
+          <a:noFill/>
+          <a:ln/>
+        </p:spPr>
+        <p:txBody>
+          <a:bodyPr wrap="square" rtlCol="0" anchor="ctr"/>
+          <a:lstStyle/>
+          <a:p>
+            <a:pPr indent="0" marL="0">
+              <a:buNone/>
+            </a:pPr>
+            <a:r>
+              <a:rPr lang="en-US" sz="1000" dirty="0">
+                <a:solidFill>
+                  <a:srgbClr val="0F172A"/>
+                </a:solidFill>
+              </a:rPr>
+              <a:t>Ona tilimizda yangi avlod kiber-mutaxassislari tayyorlanadi.</a:t>
+            </a:r>
+            <a:endParaRPr lang="en-US" sz="1000" dirty="0"/>
+          </a:p>
+        </p:txBody>
+      </p:sp>
+    </p:spTree>
+  </p:cSld>
+  <p:clrMapOvr>
+    <a:masterClrMapping/>
+  </p:clrMapOvr>
+</p:sld>
+</file>
+
+<file path=ppt/slides/slide13.xml><?xml version="1.0" encoding="utf-8"?>
+<p:sld xmlns:a="http://schemas.openxmlformats.org/drawingml/2006/main" xmlns:r="http://schemas.openxmlformats.org/officeDocument/2006/relationships" xmlns:p="http://schemas.openxmlformats.org/presentationml/2006/main">
+  <p:cSld name="Slide 13">
     <p:bg>
       <p:bgPr>
         <a:solidFill>
@@ -3518,7 +4245,7 @@
                   <a:srgbClr val="10B981"/>
                 </a:solidFill>
               </a:rPr>
-              <a:t>📩 Aloqa va Hamkorlik:
+              <a:t>👤 Loyiha Muallifi:
 </a:t>
             </a:r>
             <a:pPr indent="0" marL="0">
@@ -3533,7 +4260,7 @@
                   <a:srgbClr val="F8FAFC"/>
                 </a:solidFill>
               </a:rPr>
-              <a:t>Telegram: @cybershield_uz  |  Email: contact@cybershield.uz
+              <a:t>Abduraxmonov Bexruz (Muallif, dizayner va dasturchi)
 </a:t>
             </a:r>
             <a:pPr indent="0" marL="0">
@@ -3726,7 +4453,7 @@
                   <a:srgbClr val="059669"/>
                 </a:solidFill>
               </a:rPr>
-              <a:t>SLAYD 02 / 12</a:t>
+              <a:t>SLAYD 02 / 13</a:t>
             </a:r>
             <a:endParaRPr lang="en-US" sz="950" dirty="0"/>
           </a:p>
@@ -4159,7 +4886,7 @@
                   <a:srgbClr val="059669"/>
                 </a:solidFill>
               </a:rPr>
-              <a:t>SLAYD 03 / 12</a:t>
+              <a:t>SLAYD 03 / 13</a:t>
             </a:r>
             <a:endParaRPr lang="en-US" sz="950" dirty="0"/>
           </a:p>
@@ -4797,7 +5524,7 @@
                   <a:srgbClr val="059669"/>
                 </a:solidFill>
               </a:rPr>
-              <a:t>SLAYD 04 / 12</a:t>
+              <a:t>SLAYD 04 / 13</a:t>
             </a:r>
             <a:endParaRPr lang="en-US" sz="950" dirty="0"/>
           </a:p>
@@ -5447,7 +6174,7 @@
                   <a:srgbClr val="059669"/>
                 </a:solidFill>
               </a:rPr>
-              <a:t>SLAYD 05 / 12</a:t>
+              <a:t>SLAYD 05 / 13</a:t>
             </a:r>
             <a:endParaRPr lang="en-US" sz="950" dirty="0"/>
           </a:p>
@@ -5854,7 +6581,7 @@
                   <a:srgbClr val="059669"/>
                 </a:solidFill>
               </a:rPr>
-              <a:t>SLAYD 06 / 12</a:t>
+              <a:t>SLAYD 06 / 13</a:t>
             </a:r>
             <a:endParaRPr lang="en-US" sz="950" dirty="0"/>
           </a:p>
@@ -6333,7 +7060,7 @@
                   <a:srgbClr val="059669"/>
                 </a:solidFill>
               </a:rPr>
-              <a:t>SLAYD 07 / 12</a:t>
+              <a:t>SLAYD 07 / 13</a:t>
             </a:r>
             <a:endParaRPr lang="en-US" sz="950" dirty="0"/>
           </a:p>
@@ -7122,7 +7849,7 @@
     <p:bg>
       <p:bgPr>
         <a:solidFill>
-          <a:srgbClr val="F4F6F9"/>
+          <a:srgbClr val="0A192F"/>
         </a:solidFill>
       </p:bgPr>
     </p:bg>
@@ -7148,14 +7875,14 @@
         </p:nvSpPr>
         <p:spPr>
           <a:xfrm>
-            <a:off x="548640" y="228600"/>
+            <a:off x="548640" y="320040"/>
             <a:ext cx="2011680" cy="274320"/>
           </a:xfrm>
           <a:prstGeom prst="roundRect">
             <a:avLst/>
           </a:prstGeom>
           <a:solidFill>
-            <a:srgbClr val="ECFDF5"/>
+            <a:srgbClr val="064E3B"/>
           </a:solidFill>
           <a:ln w="12700">
             <a:solidFill>
@@ -7173,7 +7900,7 @@
         </p:nvSpPr>
         <p:spPr>
           <a:xfrm>
-            <a:off x="548640" y="228600"/>
+            <a:off x="548640" y="320040"/>
             <a:ext cx="2011680" cy="274320"/>
           </a:xfrm>
           <a:prstGeom prst="rect">
@@ -7190,14 +7917,14 @@
               <a:buNone/>
             </a:pPr>
             <a:r>
-              <a:rPr lang="en-US" sz="950" b="1" dirty="0">
-                <a:solidFill>
-                  <a:srgbClr val="059669"/>
-                </a:solidFill>
-              </a:rPr>
-              <a:t>SLAYD 08 / 12</a:t>
-            </a:r>
-            <a:endParaRPr lang="en-US" sz="950" dirty="0"/>
+              <a:rPr lang="en-US" sz="1000" b="1" dirty="0">
+                <a:solidFill>
+                  <a:srgbClr val="34D399"/>
+                </a:solidFill>
+              </a:rPr>
+              <a:t>08 · MUALLIF</a:t>
+            </a:r>
+            <a:endParaRPr lang="en-US" sz="1000" dirty="0"/>
           </a:p>
         </p:txBody>
       </p:sp>
@@ -7209,29 +7936,68 @@
         </p:nvSpPr>
         <p:spPr>
           <a:xfrm>
-            <a:off x="548640" y="548640"/>
-            <a:ext cx="8046720" cy="411480"/>
-          </a:xfrm>
-          <a:prstGeom prst="rect">
-            <a:avLst/>
-          </a:prstGeom>
-          <a:noFill/>
-          <a:ln/>
-        </p:spPr>
-        <p:txBody>
-          <a:bodyPr wrap="square" rtlCol="0" anchor="ctr"/>
-          <a:lstStyle/>
-          <a:p>
-            <a:pPr indent="0" marL="0">
+            <a:off x="548640" y="685800"/>
+            <a:ext cx="4937760" cy="457200"/>
+          </a:xfrm>
+          <a:prstGeom prst="rect">
+            <a:avLst/>
+          </a:prstGeom>
+          <a:noFill/>
+          <a:ln/>
+        </p:spPr>
+        <p:txBody>
+          <a:bodyPr wrap="square" rtlCol="0" anchor="ctr"/>
+          <a:lstStyle/>
+          <a:p>
+            <a:pPr indent="0" marL="0">
+              <a:buNone/>
+            </a:pPr>
+            <a:r>
+              <a:rPr lang="en-US" sz="2200" b="1" dirty="0">
+                <a:solidFill>
+                  <a:srgbClr val="000000"/>
+                </a:solidFill>
+              </a:rPr>
+              <a:t>Loyihani kim yaratdi?</a:t>
+            </a:r>
+            <a:endParaRPr lang="en-US" sz="2200" dirty="0"/>
+          </a:p>
+        </p:txBody>
+      </p:sp>
+      <p:sp>
+        <p:nvSpPr>
+          <p:cNvPr id="5" name="Text 3"/>
+          <p:cNvSpPr/>
+          <p:nvPr/>
+        </p:nvSpPr>
+        <p:spPr>
+          <a:xfrm>
+            <a:off x="548640" y="1143000"/>
+            <a:ext cx="4937760" cy="822960"/>
+          </a:xfrm>
+          <a:prstGeom prst="rect">
+            <a:avLst/>
+          </a:prstGeom>
+          <a:noFill/>
+          <a:ln/>
+        </p:spPr>
+        <p:txBody>
+          <a:bodyPr wrap="square" rtlCol="0" anchor="ctr"/>
+          <a:lstStyle/>
+          <a:p>
+            <a:pPr indent="0" marL="0">
+              <a:lnSpc>
+                <a:spcPct val="115000"/>
+              </a:lnSpc>
               <a:buNone/>
             </a:pPr>
             <a:r>
               <a:rPr lang="en-US" sz="2000" b="1" dirty="0">
                 <a:solidFill>
-                  <a:srgbClr val="0F172A"/>
-                </a:solidFill>
-              </a:rPr>
-              <a:t>Texnologiyalar: Loyihaning haqiqiy texnik asosi</a:t>
+                  <a:srgbClr val="F8FAFC"/>
+                </a:solidFill>
+              </a:rPr>
+              <a:t>Loyihaning barcha qismlari Abduraxmonov Bexruz tomonidan bajarilgan.</a:t>
             </a:r>
             <a:endParaRPr lang="en-US" sz="2000" dirty="0"/>
           </a:p>
@@ -7239,50 +8005,235 @@
       </p:sp>
       <p:sp>
         <p:nvSpPr>
-          <p:cNvPr id="5" name="Text 3"/>
-          <p:cNvSpPr/>
-          <p:nvPr/>
-        </p:nvSpPr>
-        <p:spPr>
-          <a:xfrm>
-            <a:off x="548640" y="960120"/>
-            <a:ext cx="8046720" cy="274320"/>
-          </a:xfrm>
-          <a:prstGeom prst="rect">
-            <a:avLst/>
-          </a:prstGeom>
-          <a:noFill/>
-          <a:ln/>
-        </p:spPr>
-        <p:txBody>
-          <a:bodyPr wrap="square" rtlCol="0" anchor="ctr"/>
-          <a:lstStyle/>
-          <a:p>
-            <a:pPr indent="0" marL="0">
+          <p:cNvPr id="6" name="Text 4"/>
+          <p:cNvSpPr/>
+          <p:nvPr/>
+        </p:nvSpPr>
+        <p:spPr>
+          <a:xfrm>
+            <a:off x="548640" y="2057400"/>
+            <a:ext cx="4937760" cy="320040"/>
+          </a:xfrm>
+          <a:prstGeom prst="rect">
+            <a:avLst/>
+          </a:prstGeom>
+          <a:noFill/>
+          <a:ln/>
+        </p:spPr>
+        <p:txBody>
+          <a:bodyPr wrap="square" rtlCol="0" anchor="ctr"/>
+          <a:lstStyle/>
+          <a:p>
+            <a:pPr indent="0" marL="0">
+              <a:buNone/>
+            </a:pPr>
+            <a:r>
+              <a:rPr lang="en-US" sz="1200" b="1" dirty="0">
+                <a:solidFill>
+                  <a:srgbClr val="6EE7B7"/>
+                </a:solidFill>
+              </a:rPr>
+              <a:t>ROLI:  Muallif, dizayner va dasturchi</a:t>
+            </a:r>
+            <a:endParaRPr lang="en-US" sz="1200" dirty="0"/>
+          </a:p>
+        </p:txBody>
+      </p:sp>
+      <p:sp>
+        <p:nvSpPr>
+          <p:cNvPr id="7" name="Shape 5"/>
+          <p:cNvSpPr/>
+          <p:nvPr/>
+        </p:nvSpPr>
+        <p:spPr>
+          <a:xfrm>
+            <a:off x="548640" y="2468880"/>
+            <a:ext cx="4937760" cy="2240280"/>
+          </a:xfrm>
+          <a:prstGeom prst="roundRect">
+            <a:avLst/>
+          </a:prstGeom>
+          <a:solidFill>
+            <a:srgbClr val="0F243A"/>
+          </a:solidFill>
+          <a:ln w="19050">
+            <a:solidFill>
+              <a:srgbClr val="1E3A52"/>
+            </a:solidFill>
+            <a:prstDash val="solid"/>
+          </a:ln>
+        </p:spPr>
+      </p:sp>
+      <p:sp>
+        <p:nvSpPr>
+          <p:cNvPr id="8" name="Text 6"/>
+          <p:cNvSpPr/>
+          <p:nvPr/>
+        </p:nvSpPr>
+        <p:spPr>
+          <a:xfrm>
+            <a:off x="731520" y="2560320"/>
+            <a:ext cx="4572000" cy="274320"/>
+          </a:xfrm>
+          <a:prstGeom prst="rect">
+            <a:avLst/>
+          </a:prstGeom>
+          <a:noFill/>
+          <a:ln/>
+        </p:spPr>
+        <p:txBody>
+          <a:bodyPr wrap="square" rtlCol="0" anchor="ctr"/>
+          <a:lstStyle/>
+          <a:p>
+            <a:pPr indent="0" marL="0">
+              <a:buNone/>
+            </a:pPr>
+            <a:r>
+              <a:rPr lang="en-US" sz="1200" b="1" dirty="0">
+                <a:solidFill>
+                  <a:srgbClr val="10B981"/>
+                </a:solidFill>
+              </a:rPr>
+              <a:t>Bajargan ishlari:</a:t>
+            </a:r>
+            <a:endParaRPr lang="en-US" sz="1200" dirty="0"/>
+          </a:p>
+        </p:txBody>
+      </p:sp>
+      <p:sp>
+        <p:nvSpPr>
+          <p:cNvPr id="9" name="Text 7"/>
+          <p:cNvSpPr/>
+          <p:nvPr/>
+        </p:nvSpPr>
+        <p:spPr>
+          <a:xfrm>
+            <a:off x="731520" y="2880360"/>
+            <a:ext cx="4572000" cy="1737360"/>
+          </a:xfrm>
+          <a:prstGeom prst="rect">
+            <a:avLst/>
+          </a:prstGeom>
+          <a:noFill/>
+          <a:ln/>
+        </p:spPr>
+        <p:txBody>
+          <a:bodyPr wrap="square" rtlCol="0" anchor="ctr"/>
+          <a:lstStyle/>
+          <a:p>
+            <a:pPr indent="0" marL="0">
+              <a:lnSpc>
+                <a:spcPct val="125000"/>
+              </a:lnSpc>
               <a:buNone/>
             </a:pPr>
             <a:r>
               <a:rPr lang="en-US" sz="1100" dirty="0">
                 <a:solidFill>
-                  <a:srgbClr val="475569"/>
-                </a:solidFill>
-              </a:rPr>
-              <a:t>Kod bazasi (package.json va arxitektura) orqali 100% tasdiqlangan texnologiyalar</a:t>
+                  <a:srgbClr val="F8FAFC"/>
+                </a:solidFill>
+              </a:rPr>
+              <a:t>• Loyiha g‘oyasi va arxitektura tuzilmasi</a:t>
             </a:r>
             <a:endParaRPr lang="en-US" sz="1100" dirty="0"/>
           </a:p>
-        </p:txBody>
-      </p:sp>
-      <p:sp>
-        <p:nvSpPr>
-          <p:cNvPr id="6" name="Shape 4"/>
-          <p:cNvSpPr/>
-          <p:nvPr/>
-        </p:nvSpPr>
-        <p:spPr>
-          <a:xfrm>
-            <a:off x="512064" y="1289304"/>
-            <a:ext cx="4096512" cy="3822192"/>
+          <a:p>
+            <a:pPr indent="0" marL="0">
+              <a:lnSpc>
+                <a:spcPct val="125000"/>
+              </a:lnSpc>
+              <a:buNone/>
+            </a:pPr>
+            <a:r>
+              <a:rPr lang="en-US" sz="1100" dirty="0">
+                <a:solidFill>
+                  <a:srgbClr val="F8FAFC"/>
+                </a:solidFill>
+              </a:rPr>
+              <a:t>• UI/UX dizayn va vizual interfeys</a:t>
+            </a:r>
+            <a:endParaRPr lang="en-US" sz="1100" dirty="0"/>
+          </a:p>
+          <a:p>
+            <a:pPr indent="0" marL="0">
+              <a:lnSpc>
+                <a:spcPct val="125000"/>
+              </a:lnSpc>
+              <a:buNone/>
+            </a:pPr>
+            <a:r>
+              <a:rPr lang="en-US" sz="1100" dirty="0">
+                <a:solidFill>
+                  <a:srgbClr val="F8FAFC"/>
+                </a:solidFill>
+              </a:rPr>
+              <a:t>• React, Vite va Tailwind CSS bilan dasturlash</a:t>
+            </a:r>
+            <a:endParaRPr lang="en-US" sz="1100" dirty="0"/>
+          </a:p>
+          <a:p>
+            <a:pPr indent="0" marL="0">
+              <a:lnSpc>
+                <a:spcPct val="125000"/>
+              </a:lnSpc>
+              <a:buNone/>
+            </a:pPr>
+            <a:r>
+              <a:rPr lang="en-US" sz="1100" dirty="0">
+                <a:solidFill>
+                  <a:srgbClr val="F8FAFC"/>
+                </a:solidFill>
+              </a:rPr>
+              <a:t>• O‘quv modullari, laboratoriyalar va Sezar shifri</a:t>
+            </a:r>
+            <a:endParaRPr lang="en-US" sz="1100" dirty="0"/>
+          </a:p>
+          <a:p>
+            <a:pPr indent="0" marL="0">
+              <a:lnSpc>
+                <a:spcPct val="125000"/>
+              </a:lnSpc>
+              <a:buNone/>
+            </a:pPr>
+            <a:r>
+              <a:rPr lang="en-US" sz="1100" dirty="0">
+                <a:solidFill>
+                  <a:srgbClr val="F8FAFC"/>
+                </a:solidFill>
+              </a:rPr>
+              <a:t>• Vercel bulutiga joylashtirish va CI/CD</a:t>
+            </a:r>
+            <a:endParaRPr lang="en-US" sz="1100" dirty="0"/>
+          </a:p>
+          <a:p>
+            <a:pPr indent="0" marL="0">
+              <a:lnSpc>
+                <a:spcPct val="125000"/>
+              </a:lnSpc>
+              <a:buNone/>
+            </a:pPr>
+            <a:r>
+              <a:rPr lang="en-US" sz="1100" dirty="0">
+                <a:solidFill>
+                  <a:srgbClr val="F8FAFC"/>
+                </a:solidFill>
+              </a:rPr>
+              <a:t>• Sinov va taqdimotga to‘liq tayyorlash</a:t>
+            </a:r>
+            <a:endParaRPr lang="en-US" sz="1100" dirty="0"/>
+          </a:p>
+        </p:txBody>
+      </p:sp>
+      <p:sp>
+        <p:nvSpPr>
+          <p:cNvPr id="10" name="Shape 8"/>
+          <p:cNvSpPr/>
+          <p:nvPr/>
+        </p:nvSpPr>
+        <p:spPr>
+          <a:xfrm>
+            <a:off x="5806440" y="640080"/>
+            <a:ext cx="2834640" cy="4069080"/>
           </a:xfrm>
           <a:prstGeom prst="roundRect">
             <a:avLst/>
@@ -7290,9 +8241,9 @@
           <a:solidFill>
             <a:srgbClr val="0D1A26"/>
           </a:solidFill>
-          <a:ln w="19050">
+          <a:ln w="25400">
             <a:solidFill>
-              <a:srgbClr val="059669"/>
+              <a:srgbClr val="10B981"/>
             </a:solidFill>
             <a:prstDash val="solid"/>
           </a:ln>
@@ -7300,7 +8251,7 @@
       </p:sp>
       <p:pic>
         <p:nvPicPr>
-          <p:cNvPr id="7" name="Image 0" descr="C:\Users\User\Desktop\kiber xavfsizlik boyicha sayt\public\screenshots\08_cyberguard_ai.png">    </p:cNvPr>
+          <p:cNvPr id="11" name="Image 0" descr="C:\Users\User\Desktop\kiber xavfsizlik boyicha sayt\public\screenshots\author_portrait.png">    </p:cNvPr>
           <p:cNvPicPr>
             <a:picLocks noChangeAspect="1"/>
           </p:cNvPicPr>
@@ -7314,438 +8265,14 @@
         </p:blipFill>
         <p:spPr>
           <a:xfrm>
-            <a:off x="548640" y="1325880"/>
-            <a:ext cx="4023360" cy="3474720"/>
+            <a:off x="5852160" y="685800"/>
+            <a:ext cx="2743200" cy="3977640"/>
           </a:xfrm>
           <a:prstGeom prst="rect">
             <a:avLst/>
           </a:prstGeom>
         </p:spPr>
       </p:pic>
-      <p:sp>
-        <p:nvSpPr>
-          <p:cNvPr id="8" name="Text 5"/>
-          <p:cNvSpPr/>
-          <p:nvPr/>
-        </p:nvSpPr>
-        <p:spPr>
-          <a:xfrm>
-            <a:off x="548640" y="4837176"/>
-            <a:ext cx="4023360" cy="274320"/>
-          </a:xfrm>
-          <a:prstGeom prst="rect">
-            <a:avLst/>
-          </a:prstGeom>
-          <a:noFill/>
-          <a:ln/>
-        </p:spPr>
-        <p:txBody>
-          <a:bodyPr wrap="square" rtlCol="0" anchor="ctr"/>
-          <a:lstStyle/>
-          <a:p>
-            <a:pPr algn="ctr" indent="0" marL="0">
-              <a:buNone/>
-            </a:pPr>
-            <a:r>
-              <a:rPr lang="en-US" sz="900" dirty="0">
-                <a:solidFill>
-                  <a:srgbClr val="BAE6FD"/>
-                </a:solidFill>
-              </a:rPr>
-              <a:t>📸 CyberGuard AI — o‘zbek tilidagi kiberxavfsizlik assistenti</a:t>
-            </a:r>
-            <a:endParaRPr lang="en-US" sz="900" dirty="0"/>
-          </a:p>
-        </p:txBody>
-      </p:sp>
-      <p:sp>
-        <p:nvSpPr>
-          <p:cNvPr id="9" name="Shape 6"/>
-          <p:cNvSpPr/>
-          <p:nvPr/>
-        </p:nvSpPr>
-        <p:spPr>
-          <a:xfrm>
-            <a:off x="4846320" y="1325880"/>
-            <a:ext cx="3749040" cy="749808"/>
-          </a:xfrm>
-          <a:prstGeom prst="roundRect">
-            <a:avLst/>
-          </a:prstGeom>
-          <a:solidFill>
-            <a:srgbClr val="FFFFFF"/>
-          </a:solidFill>
-          <a:ln w="12700">
-            <a:solidFill>
-              <a:srgbClr val="E2E8F0"/>
-            </a:solidFill>
-            <a:prstDash val="solid"/>
-          </a:ln>
-        </p:spPr>
-      </p:sp>
-      <p:sp>
-        <p:nvSpPr>
-          <p:cNvPr id="10" name="Text 7"/>
-          <p:cNvSpPr/>
-          <p:nvPr/>
-        </p:nvSpPr>
-        <p:spPr>
-          <a:xfrm>
-            <a:off x="4983480" y="1399032"/>
-            <a:ext cx="3474720" cy="274320"/>
-          </a:xfrm>
-          <a:prstGeom prst="rect">
-            <a:avLst/>
-          </a:prstGeom>
-          <a:noFill/>
-          <a:ln/>
-        </p:spPr>
-        <p:txBody>
-          <a:bodyPr wrap="square" rtlCol="0" anchor="ctr"/>
-          <a:lstStyle/>
-          <a:p>
-            <a:pPr indent="0" marL="0">
-              <a:buNone/>
-            </a:pPr>
-            <a:r>
-              <a:rPr lang="en-US" sz="1200" b="1" dirty="0">
-                <a:solidFill>
-                  <a:srgbClr val="0284C7"/>
-                </a:solidFill>
-              </a:rPr>
-              <a:t>React 18 &amp; Vite</a:t>
-            </a:r>
-            <a:endParaRPr lang="en-US" sz="1200" dirty="0"/>
-          </a:p>
-        </p:txBody>
-      </p:sp>
-      <p:sp>
-        <p:nvSpPr>
-          <p:cNvPr id="11" name="Text 8"/>
-          <p:cNvSpPr/>
-          <p:nvPr/>
-        </p:nvSpPr>
-        <p:spPr>
-          <a:xfrm>
-            <a:off x="4983480" y="1673352"/>
-            <a:ext cx="3474720" cy="347472"/>
-          </a:xfrm>
-          <a:prstGeom prst="rect">
-            <a:avLst/>
-          </a:prstGeom>
-          <a:noFill/>
-          <a:ln/>
-        </p:spPr>
-        <p:txBody>
-          <a:bodyPr wrap="square" rtlCol="0" anchor="ctr"/>
-          <a:lstStyle/>
-          <a:p>
-            <a:pPr indent="0" marL="0">
-              <a:buNone/>
-            </a:pPr>
-            <a:r>
-              <a:rPr lang="en-US" sz="950" dirty="0">
-                <a:solidFill>
-                  <a:srgbClr val="475569"/>
-                </a:solidFill>
-              </a:rPr>
-              <a:t>Tezkor SPA arxitekturasi va modulli frontend.</a:t>
-            </a:r>
-            <a:endParaRPr lang="en-US" sz="950" dirty="0"/>
-          </a:p>
-        </p:txBody>
-      </p:sp>
-      <p:sp>
-        <p:nvSpPr>
-          <p:cNvPr id="12" name="Shape 9"/>
-          <p:cNvSpPr/>
-          <p:nvPr/>
-        </p:nvSpPr>
-        <p:spPr>
-          <a:xfrm>
-            <a:off x="4846320" y="2194560"/>
-            <a:ext cx="3749040" cy="749808"/>
-          </a:xfrm>
-          <a:prstGeom prst="roundRect">
-            <a:avLst/>
-          </a:prstGeom>
-          <a:solidFill>
-            <a:srgbClr val="FFFFFF"/>
-          </a:solidFill>
-          <a:ln w="12700">
-            <a:solidFill>
-              <a:srgbClr val="E2E8F0"/>
-            </a:solidFill>
-            <a:prstDash val="solid"/>
-          </a:ln>
-        </p:spPr>
-      </p:sp>
-      <p:sp>
-        <p:nvSpPr>
-          <p:cNvPr id="13" name="Text 10"/>
-          <p:cNvSpPr/>
-          <p:nvPr/>
-        </p:nvSpPr>
-        <p:spPr>
-          <a:xfrm>
-            <a:off x="4983480" y="2267712"/>
-            <a:ext cx="3474720" cy="274320"/>
-          </a:xfrm>
-          <a:prstGeom prst="rect">
-            <a:avLst/>
-          </a:prstGeom>
-          <a:noFill/>
-          <a:ln/>
-        </p:spPr>
-        <p:txBody>
-          <a:bodyPr wrap="square" rtlCol="0" anchor="ctr"/>
-          <a:lstStyle/>
-          <a:p>
-            <a:pPr indent="0" marL="0">
-              <a:buNone/>
-            </a:pPr>
-            <a:r>
-              <a:rPr lang="en-US" sz="1200" b="1" dirty="0">
-                <a:solidFill>
-                  <a:srgbClr val="059669"/>
-                </a:solidFill>
-              </a:rPr>
-              <a:t>Tailwind CSS</a:t>
-            </a:r>
-            <a:endParaRPr lang="en-US" sz="1200" dirty="0"/>
-          </a:p>
-        </p:txBody>
-      </p:sp>
-      <p:sp>
-        <p:nvSpPr>
-          <p:cNvPr id="14" name="Text 11"/>
-          <p:cNvSpPr/>
-          <p:nvPr/>
-        </p:nvSpPr>
-        <p:spPr>
-          <a:xfrm>
-            <a:off x="4983480" y="2542032"/>
-            <a:ext cx="3474720" cy="347472"/>
-          </a:xfrm>
-          <a:prstGeom prst="rect">
-            <a:avLst/>
-          </a:prstGeom>
-          <a:noFill/>
-          <a:ln/>
-        </p:spPr>
-        <p:txBody>
-          <a:bodyPr wrap="square" rtlCol="0" anchor="ctr"/>
-          <a:lstStyle/>
-          <a:p>
-            <a:pPr indent="0" marL="0">
-              <a:buNone/>
-            </a:pPr>
-            <a:r>
-              <a:rPr lang="en-US" sz="950" dirty="0">
-                <a:solidFill>
-                  <a:srgbClr val="475569"/>
-                </a:solidFill>
-              </a:rPr>
-              <a:t>To‘liq moslashuvchan (responsive) qorong‘i kiber-interfeys.</a:t>
-            </a:r>
-            <a:endParaRPr lang="en-US" sz="950" dirty="0"/>
-          </a:p>
-        </p:txBody>
-      </p:sp>
-      <p:sp>
-        <p:nvSpPr>
-          <p:cNvPr id="15" name="Shape 12"/>
-          <p:cNvSpPr/>
-          <p:nvPr/>
-        </p:nvSpPr>
-        <p:spPr>
-          <a:xfrm>
-            <a:off x="4846320" y="3063240"/>
-            <a:ext cx="3749040" cy="749808"/>
-          </a:xfrm>
-          <a:prstGeom prst="roundRect">
-            <a:avLst/>
-          </a:prstGeom>
-          <a:solidFill>
-            <a:srgbClr val="FFFFFF"/>
-          </a:solidFill>
-          <a:ln w="12700">
-            <a:solidFill>
-              <a:srgbClr val="E2E8F0"/>
-            </a:solidFill>
-            <a:prstDash val="solid"/>
-          </a:ln>
-        </p:spPr>
-      </p:sp>
-      <p:sp>
-        <p:nvSpPr>
-          <p:cNvPr id="16" name="Text 13"/>
-          <p:cNvSpPr/>
-          <p:nvPr/>
-        </p:nvSpPr>
-        <p:spPr>
-          <a:xfrm>
-            <a:off x="4983480" y="3136392"/>
-            <a:ext cx="3474720" cy="274320"/>
-          </a:xfrm>
-          <a:prstGeom prst="rect">
-            <a:avLst/>
-          </a:prstGeom>
-          <a:noFill/>
-          <a:ln/>
-        </p:spPr>
-        <p:txBody>
-          <a:bodyPr wrap="square" rtlCol="0" anchor="ctr"/>
-          <a:lstStyle/>
-          <a:p>
-            <a:pPr indent="0" marL="0">
-              <a:buNone/>
-            </a:pPr>
-            <a:r>
-              <a:rPr lang="en-US" sz="1200" b="1" dirty="0">
-                <a:solidFill>
-                  <a:srgbClr val="F59E0B"/>
-                </a:solidFill>
-              </a:rPr>
-              <a:t>Lucide Icons &amp; Confetti</a:t>
-            </a:r>
-            <a:endParaRPr lang="en-US" sz="1200" dirty="0"/>
-          </a:p>
-        </p:txBody>
-      </p:sp>
-      <p:sp>
-        <p:nvSpPr>
-          <p:cNvPr id="17" name="Text 14"/>
-          <p:cNvSpPr/>
-          <p:nvPr/>
-        </p:nvSpPr>
-        <p:spPr>
-          <a:xfrm>
-            <a:off x="4983480" y="3410712"/>
-            <a:ext cx="3474720" cy="347472"/>
-          </a:xfrm>
-          <a:prstGeom prst="rect">
-            <a:avLst/>
-          </a:prstGeom>
-          <a:noFill/>
-          <a:ln/>
-        </p:spPr>
-        <p:txBody>
-          <a:bodyPr wrap="square" rtlCol="0" anchor="ctr"/>
-          <a:lstStyle/>
-          <a:p>
-            <a:pPr indent="0" marL="0">
-              <a:buNone/>
-            </a:pPr>
-            <a:r>
-              <a:rPr lang="en-US" sz="950" dirty="0">
-                <a:solidFill>
-                  <a:srgbClr val="475569"/>
-                </a:solidFill>
-              </a:rPr>
-              <a:t>Kiber piktogrammalar va gamifikatsiya effektlari.</a:t>
-            </a:r>
-            <a:endParaRPr lang="en-US" sz="950" dirty="0"/>
-          </a:p>
-        </p:txBody>
-      </p:sp>
-      <p:sp>
-        <p:nvSpPr>
-          <p:cNvPr id="18" name="Shape 15"/>
-          <p:cNvSpPr/>
-          <p:nvPr/>
-        </p:nvSpPr>
-        <p:spPr>
-          <a:xfrm>
-            <a:off x="4846320" y="3931920"/>
-            <a:ext cx="3749040" cy="749808"/>
-          </a:xfrm>
-          <a:prstGeom prst="roundRect">
-            <a:avLst/>
-          </a:prstGeom>
-          <a:solidFill>
-            <a:srgbClr val="FFFFFF"/>
-          </a:solidFill>
-          <a:ln w="12700">
-            <a:solidFill>
-              <a:srgbClr val="E2E8F0"/>
-            </a:solidFill>
-            <a:prstDash val="solid"/>
-          </a:ln>
-        </p:spPr>
-      </p:sp>
-      <p:sp>
-        <p:nvSpPr>
-          <p:cNvPr id="19" name="Text 16"/>
-          <p:cNvSpPr/>
-          <p:nvPr/>
-        </p:nvSpPr>
-        <p:spPr>
-          <a:xfrm>
-            <a:off x="4983480" y="4005072"/>
-            <a:ext cx="3474720" cy="274320"/>
-          </a:xfrm>
-          <a:prstGeom prst="rect">
-            <a:avLst/>
-          </a:prstGeom>
-          <a:noFill/>
-          <a:ln/>
-        </p:spPr>
-        <p:txBody>
-          <a:bodyPr wrap="square" rtlCol="0" anchor="ctr"/>
-          <a:lstStyle/>
-          <a:p>
-            <a:pPr indent="0" marL="0">
-              <a:buNone/>
-            </a:pPr>
-            <a:r>
-              <a:rPr lang="en-US" sz="1200" b="1" dirty="0">
-                <a:solidFill>
-                  <a:srgbClr val="0F172A"/>
-                </a:solidFill>
-              </a:rPr>
-              <a:t>Vercel Edge Cloud</a:t>
-            </a:r>
-            <a:endParaRPr lang="en-US" sz="1200" dirty="0"/>
-          </a:p>
-        </p:txBody>
-      </p:sp>
-      <p:sp>
-        <p:nvSpPr>
-          <p:cNvPr id="20" name="Text 17"/>
-          <p:cNvSpPr/>
-          <p:nvPr/>
-        </p:nvSpPr>
-        <p:spPr>
-          <a:xfrm>
-            <a:off x="4983480" y="4279392"/>
-            <a:ext cx="3474720" cy="347472"/>
-          </a:xfrm>
-          <a:prstGeom prst="rect">
-            <a:avLst/>
-          </a:prstGeom>
-          <a:noFill/>
-          <a:ln/>
-        </p:spPr>
-        <p:txBody>
-          <a:bodyPr wrap="square" rtlCol="0" anchor="ctr"/>
-          <a:lstStyle/>
-          <a:p>
-            <a:pPr indent="0" marL="0">
-              <a:buNone/>
-            </a:pPr>
-            <a:r>
-              <a:rPr lang="en-US" sz="950" dirty="0">
-                <a:solidFill>
-                  <a:srgbClr val="475569"/>
-                </a:solidFill>
-              </a:rPr>
-              <a:t>Global CDN, 24/7 uzluksiz ishlovchi bulutli serverlar.</a:t>
-            </a:r>
-            <a:endParaRPr lang="en-US" sz="950" dirty="0"/>
-          </a:p>
-        </p:txBody>
-      </p:sp>
     </p:spTree>
   </p:cSld>
   <p:clrMapOvr>
@@ -7833,7 +8360,7 @@
                   <a:srgbClr val="059669"/>
                 </a:solidFill>
               </a:rPr>
-              <a:t>SLAYD 09 / 12</a:t>
+              <a:t>SLAYD 09 / 13</a:t>
             </a:r>
             <a:endParaRPr lang="en-US" sz="950" dirty="0"/>
           </a:p>
@@ -7869,7 +8396,7 @@
                   <a:srgbClr val="0F172A"/>
                 </a:solidFill>
               </a:rPr>
-              <a:t>Afzalliklari: KiberQoriqchi nega ustun?</a:t>
+              <a:t>Texnologiyalar: Loyihaning haqiqiy texnik asosi</a:t>
             </a:r>
             <a:endParaRPr lang="en-US" sz="2000" dirty="0"/>
           </a:p>
@@ -7905,7 +8432,7 @@
                   <a:srgbClr val="475569"/>
                 </a:solidFill>
               </a:rPr>
-              <a:t>Saytning haqiqiy imkoniyatlariga asoslangan asosiy raqobat ustunliklari</a:t>
+              <a:t>Kod bazasi (package.json va arxitektura) orqali 100% tasdiqlangan texnologiyalar</a:t>
             </a:r>
             <a:endParaRPr lang="en-US" sz="1100" dirty="0"/>
           </a:p>
@@ -7938,7 +8465,7 @@
       </p:sp>
       <p:pic>
         <p:nvPicPr>
-          <p:cNvPr id="7" name="Image 0" descr="C:\Users\User\Desktop\kiber xavfsizlik boyicha sayt\public\screenshots\07_leaderboard.png">    </p:cNvPr>
+          <p:cNvPr id="7" name="Image 0" descr="C:\Users\User\Desktop\kiber xavfsizlik boyicha sayt\public\screenshots\08_cyberguard_ai.png">    </p:cNvPr>
           <p:cNvPicPr>
             <a:picLocks noChangeAspect="1"/>
           </p:cNvPicPr>
@@ -7990,7 +8517,7 @@
                   <a:srgbClr val="BAE6FD"/>
                 </a:solidFill>
               </a:rPr>
-              <a:t>📸 "Leaderboard" — jonli reyting va musobaqa tizimi</a:t>
+              <a:t>📸 CyberGuard AI — o‘zbek tilidagi kiberxavfsizlik assistenti</a:t>
             </a:r>
             <a:endParaRPr lang="en-US" sz="900" dirty="0"/>
           </a:p>
@@ -8013,9 +8540,9 @@
           <a:solidFill>
             <a:srgbClr val="FFFFFF"/>
           </a:solidFill>
-          <a:ln w="19050">
+          <a:ln w="12700">
             <a:solidFill>
-              <a:srgbClr val="6EE7B7"/>
+              <a:srgbClr val="E2E8F0"/>
             </a:solidFill>
             <a:prstDash val="solid"/>
           </a:ln>
@@ -8046,14 +8573,14 @@
               <a:buNone/>
             </a:pPr>
             <a:r>
-              <a:rPr lang="en-US" sz="1100" b="1" dirty="0">
-                <a:solidFill>
-                  <a:srgbClr val="059669"/>
-                </a:solidFill>
-              </a:rPr>
-              <a:t>1. 100% Ona Tilimizda</a:t>
-            </a:r>
-            <a:endParaRPr lang="en-US" sz="1100" dirty="0"/>
+              <a:rPr lang="en-US" sz="1200" b="1" dirty="0">
+                <a:solidFill>
+                  <a:srgbClr val="0284C7"/>
+                </a:solidFill>
+              </a:rPr>
+              <a:t>React 18 &amp; Vite</a:t>
+            </a:r>
+            <a:endParaRPr lang="en-US" sz="1200" dirty="0"/>
           </a:p>
         </p:txBody>
       </p:sp>
@@ -8087,7 +8614,7 @@
                   <a:srgbClr val="475569"/>
                 </a:solidFill>
               </a:rPr>
-              <a:t>O‘zbekiston to‘lov tizimlari (Click, Payme, Uzcard) kiber-xavflariga moslangan.</a:t>
+              <a:t>Tezkor SPA arxitekturasi va modulli frontend.</a:t>
             </a:r>
             <a:endParaRPr lang="en-US" sz="950" dirty="0"/>
           </a:p>
@@ -8110,9 +8637,9 @@
           <a:solidFill>
             <a:srgbClr val="FFFFFF"/>
           </a:solidFill>
-          <a:ln w="19050">
+          <a:ln w="12700">
             <a:solidFill>
-              <a:srgbClr val="6EE7B7"/>
+              <a:srgbClr val="E2E8F0"/>
             </a:solidFill>
             <a:prstDash val="solid"/>
           </a:ln>
@@ -8143,14 +8670,14 @@
               <a:buNone/>
             </a:pPr>
             <a:r>
-              <a:rPr lang="en-US" sz="1100" b="1" dirty="0">
+              <a:rPr lang="en-US" sz="1200" b="1" dirty="0">
                 <a:solidFill>
                   <a:srgbClr val="059669"/>
                 </a:solidFill>
               </a:rPr>
-              <a:t>2. Ta'lim + Jonli Himoya</a:t>
-            </a:r>
-            <a:endParaRPr lang="en-US" sz="1100" dirty="0"/>
+              <a:t>Tailwind CSS</a:t>
+            </a:r>
+            <a:endParaRPr lang="en-US" sz="1200" dirty="0"/>
           </a:p>
         </p:txBody>
       </p:sp>
@@ -8184,7 +8711,7 @@
                   <a:srgbClr val="475569"/>
                 </a:solidFill>
               </a:rPr>
-              <a:t>Faqat ma'ruza emas — smartfon va fayllarni amalda tekshirish qurollari bor.</a:t>
+              <a:t>To‘liq moslashuvchan (responsive) qorong‘i kiber-interfeys.</a:t>
             </a:r>
             <a:endParaRPr lang="en-US" sz="950" dirty="0"/>
           </a:p>
@@ -8207,9 +8734,9 @@
           <a:solidFill>
             <a:srgbClr val="FFFFFF"/>
           </a:solidFill>
-          <a:ln w="19050">
+          <a:ln w="12700">
             <a:solidFill>
-              <a:srgbClr val="6EE7B7"/>
+              <a:srgbClr val="E2E8F0"/>
             </a:solidFill>
             <a:prstDash val="solid"/>
           </a:ln>
@@ -8240,14 +8767,14 @@
               <a:buNone/>
             </a:pPr>
             <a:r>
-              <a:rPr lang="en-US" sz="1100" b="1" dirty="0">
-                <a:solidFill>
-                  <a:srgbClr val="059669"/>
-                </a:solidFill>
-              </a:rPr>
-              <a:t>3. Gamifikatsiya va Musobaqa</a:t>
-            </a:r>
-            <a:endParaRPr lang="en-US" sz="1100" dirty="0"/>
+              <a:rPr lang="en-US" sz="1200" b="1" dirty="0">
+                <a:solidFill>
+                  <a:srgbClr val="F59E0B"/>
+                </a:solidFill>
+              </a:rPr>
+              <a:t>Lucide Icons &amp; Confetti</a:t>
+            </a:r>
+            <a:endParaRPr lang="en-US" sz="1200" dirty="0"/>
           </a:p>
         </p:txBody>
       </p:sp>
@@ -8281,7 +8808,7 @@
                   <a:srgbClr val="475569"/>
                 </a:solidFill>
               </a:rPr>
-              <a:t>Topshiriqlarni bajarish orqali ballar to‘plab umumiy reytingda ko‘tarilish.</a:t>
+              <a:t>Kiber piktogrammalar va gamifikatsiya effektlari.</a:t>
             </a:r>
             <a:endParaRPr lang="en-US" sz="950" dirty="0"/>
           </a:p>
@@ -8304,9 +8831,9 @@
           <a:solidFill>
             <a:srgbClr val="FFFFFF"/>
           </a:solidFill>
-          <a:ln w="19050">
+          <a:ln w="12700">
             <a:solidFill>
-              <a:srgbClr val="6EE7B7"/>
+              <a:srgbClr val="E2E8F0"/>
             </a:solidFill>
             <a:prstDash val="solid"/>
           </a:ln>
@@ -8337,14 +8864,14 @@
               <a:buNone/>
             </a:pPr>
             <a:r>
-              <a:rPr lang="en-US" sz="1100" b="1" dirty="0">
-                <a:solidFill>
-                  <a:srgbClr val="059669"/>
-                </a:solidFill>
-              </a:rPr>
-              <a:t>4. CyberGuard AI Maslahatchi</a:t>
-            </a:r>
-            <a:endParaRPr lang="en-US" sz="1100" dirty="0"/>
+              <a:rPr lang="en-US" sz="1200" b="1" dirty="0">
+                <a:solidFill>
+                  <a:srgbClr val="0F172A"/>
+                </a:solidFill>
+              </a:rPr>
+              <a:t>Vercel Edge Cloud</a:t>
+            </a:r>
+            <a:endParaRPr lang="en-US" sz="1200" dirty="0"/>
           </a:p>
         </p:txBody>
       </p:sp>
@@ -8378,7 +8905,7 @@
                   <a:srgbClr val="475569"/>
                 </a:solidFill>
               </a:rPr>
-              <a:t>Har qanday kiber-savolga o‘zbek tilida 24/7 tezkor va tushunarli javob.</a:t>
+              <a:t>Global CDN, 24/7 uzluksiz ishlovchi bulutli serverlar.</a:t>
             </a:r>
             <a:endParaRPr lang="en-US" sz="950" dirty="0"/>
           </a:p>

</xml_diff>

<commit_message>
Update presentation: 100% Uzbek screenshots and author slide placed at slide 11
</commit_message>
<xml_diff>
--- a/KiberQoriqchi_Prezentatsiya.pptx
+++ b/KiberQoriqchi_Prezentatsiya.pptx
@@ -2419,7 +2419,7 @@
                   <a:srgbClr val="0F172A"/>
                 </a:solidFill>
               </a:rPr>
-              <a:t>Afzalliklari: KiberQoriqchi nega ustun?</a:t>
+              <a:t>Kamchiliklar va Rivojlantirish Rejalari</a:t>
             </a:r>
             <a:endParaRPr lang="en-US" sz="2000" dirty="0"/>
           </a:p>
@@ -2455,7 +2455,7 @@
                   <a:srgbClr val="475569"/>
                 </a:solidFill>
               </a:rPr>
-              <a:t>Saytning haqiqiy imkoniyatlariga asoslangan asosiy raqobat ustunliklari</a:t>
+              <a:t>Haqiqiy holatni ochiq baholash va kelajakdagi takomillashtirish bosqichlari</a:t>
             </a:r>
             <a:endParaRPr lang="en-US" sz="1100" dirty="0"/>
           </a:p>
@@ -2488,7 +2488,7 @@
       </p:sp>
       <p:pic>
         <p:nvPicPr>
-          <p:cNvPr id="7" name="Image 0" descr="C:\Users\User\Desktop\kiber xavfsizlik boyicha sayt\public\screenshots\07_leaderboard.png">    </p:cNvPr>
+          <p:cNvPr id="7" name="Image 0" descr="C:\Users\User\Desktop\kiber xavfsizlik boyicha sayt\public\screenshots\12_casestudy.png">    </p:cNvPr>
           <p:cNvPicPr>
             <a:picLocks noChangeAspect="1"/>
           </p:cNvPicPr>
@@ -2540,7 +2540,7 @@
                   <a:srgbClr val="BAE6FD"/>
                 </a:solidFill>
               </a:rPr>
-              <a:t>📸 "Leaderboard" — jonli reyting va musobaqa tizimi</a:t>
+              <a:t>📸 "Hodisalar Tahlili" (Case Study) — real kiber-hujumlar tahlili</a:t>
             </a:r>
             <a:endParaRPr lang="en-US" sz="900" dirty="0"/>
           </a:p>
@@ -2555,7 +2555,161 @@
         <p:spPr>
           <a:xfrm>
             <a:off x="4846320" y="1325880"/>
-            <a:ext cx="3749040" cy="749808"/>
+            <a:ext cx="3749040" cy="1645920"/>
+          </a:xfrm>
+          <a:prstGeom prst="roundRect">
+            <a:avLst/>
+          </a:prstGeom>
+          <a:solidFill>
+            <a:srgbClr val="FFFFFF"/>
+          </a:solidFill>
+          <a:ln w="19050">
+            <a:solidFill>
+              <a:srgbClr val="FCD34D"/>
+            </a:solidFill>
+            <a:prstDash val="solid"/>
+          </a:ln>
+        </p:spPr>
+      </p:sp>
+      <p:sp>
+        <p:nvSpPr>
+          <p:cNvPr id="10" name="Text 7"/>
+          <p:cNvSpPr/>
+          <p:nvPr/>
+        </p:nvSpPr>
+        <p:spPr>
+          <a:xfrm>
+            <a:off x="4983480" y="1417320"/>
+            <a:ext cx="3474720" cy="274320"/>
+          </a:xfrm>
+          <a:prstGeom prst="rect">
+            <a:avLst/>
+          </a:prstGeom>
+          <a:noFill/>
+          <a:ln/>
+        </p:spPr>
+        <p:txBody>
+          <a:bodyPr wrap="square" rtlCol="0" anchor="ctr"/>
+          <a:lstStyle/>
+          <a:p>
+            <a:pPr indent="0" marL="0">
+              <a:buNone/>
+            </a:pPr>
+            <a:r>
+              <a:rPr lang="en-US" sz="1100" b="1" dirty="0">
+                <a:solidFill>
+                  <a:srgbClr val="B45309"/>
+                </a:solidFill>
+              </a:rPr>
+              <a:t>⚠️ Aniqlangan Kamchiliklar (MVP):</a:t>
+            </a:r>
+            <a:endParaRPr lang="en-US" sz="1100" dirty="0"/>
+          </a:p>
+        </p:txBody>
+      </p:sp>
+      <p:sp>
+        <p:nvSpPr>
+          <p:cNvPr id="11" name="Text 8"/>
+          <p:cNvSpPr/>
+          <p:nvPr/>
+        </p:nvSpPr>
+        <p:spPr>
+          <a:xfrm>
+            <a:off x="4983480" y="1737360"/>
+            <a:ext cx="3474720" cy="1143000"/>
+          </a:xfrm>
+          <a:prstGeom prst="rect">
+            <a:avLst/>
+          </a:prstGeom>
+          <a:noFill/>
+          <a:ln/>
+        </p:spPr>
+        <p:txBody>
+          <a:bodyPr wrap="square" rtlCol="0" anchor="ctr"/>
+          <a:lstStyle/>
+          <a:p>
+            <a:pPr indent="0" marL="0">
+              <a:buNone/>
+            </a:pPr>
+            <a:r>
+              <a:rPr lang="en-US" sz="900" b="1" dirty="0">
+                <a:solidFill>
+                  <a:srgbClr val="0F172A"/>
+                </a:solidFill>
+              </a:rPr>
+              <a:t>• Dinamik Server Sandboxing: </a:t>
+            </a:r>
+            <a:pPr indent="0" marL="0">
+              <a:buNone/>
+            </a:pPr>
+            <a:r>
+              <a:rPr lang="en-US" sz="900" dirty="0">
+                <a:solidFill>
+                  <a:srgbClr val="475569"/>
+                </a:solidFill>
+              </a:rPr>
+              <a:t>Hozircha veb-simulyatsiya; to‘liq Docker muhiti zarur.
+</a:t>
+            </a:r>
+            <a:pPr indent="0" marL="0">
+              <a:buNone/>
+            </a:pPr>
+            <a:r>
+              <a:rPr lang="en-US" sz="900" b="1" dirty="0">
+                <a:solidFill>
+                  <a:srgbClr val="0F172A"/>
+                </a:solidFill>
+              </a:rPr>
+              <a:t>• Mahalliy ilova yo‘qligi: </a:t>
+            </a:r>
+            <a:pPr indent="0" marL="0">
+              <a:buNone/>
+            </a:pPr>
+            <a:r>
+              <a:rPr lang="en-US" sz="900" dirty="0">
+                <a:solidFill>
+                  <a:srgbClr val="475569"/>
+                </a:solidFill>
+              </a:rPr>
+              <a:t>Android/iOS ilovasi ishlab chiqilmoqda.
+</a:t>
+            </a:r>
+            <a:pPr indent="0" marL="0">
+              <a:buNone/>
+            </a:pPr>
+            <a:r>
+              <a:rPr lang="en-US" sz="900" b="1" dirty="0">
+                <a:solidFill>
+                  <a:srgbClr val="0F172A"/>
+                </a:solidFill>
+              </a:rPr>
+              <a:t>• Telegram bot: </a:t>
+            </a:r>
+            <a:pPr indent="0" marL="0">
+              <a:buNone/>
+            </a:pPr>
+            <a:r>
+              <a:rPr lang="en-US" sz="900" dirty="0">
+                <a:solidFill>
+                  <a:srgbClr val="475569"/>
+                </a:solidFill>
+              </a:rPr>
+              <a:t>Avtomatik APK tekshiruvchi bot ulanmoqda.</a:t>
+            </a:r>
+            <a:endParaRPr lang="en-US" sz="900" dirty="0"/>
+          </a:p>
+        </p:txBody>
+      </p:sp>
+      <p:sp>
+        <p:nvSpPr>
+          <p:cNvPr id="12" name="Shape 9"/>
+          <p:cNvSpPr/>
+          <p:nvPr/>
+        </p:nvSpPr>
+        <p:spPr>
+          <a:xfrm>
+            <a:off x="4846320" y="3154680"/>
+            <a:ext cx="3749040" cy="1645920"/>
           </a:xfrm>
           <a:prstGeom prst="roundRect">
             <a:avLst/>
@@ -2573,13 +2727,13 @@
       </p:sp>
       <p:sp>
         <p:nvSpPr>
-          <p:cNvPr id="10" name="Text 7"/>
-          <p:cNvSpPr/>
-          <p:nvPr/>
-        </p:nvSpPr>
-        <p:spPr>
-          <a:xfrm>
-            <a:off x="4983480" y="1399032"/>
+          <p:cNvPr id="13" name="Text 10"/>
+          <p:cNvSpPr/>
+          <p:nvPr/>
+        </p:nvSpPr>
+        <p:spPr>
+          <a:xfrm>
+            <a:off x="4983480" y="3246120"/>
             <a:ext cx="3474720" cy="274320"/>
           </a:xfrm>
           <a:prstGeom prst="rect">
@@ -2601,7 +2755,7 @@
                   <a:srgbClr val="059669"/>
                 </a:solidFill>
               </a:rPr>
-              <a:t>1. 100% Ona Tilimizda</a:t>
+              <a:t>🚀 Kelajakdagi Rivojlantirish:</a:t>
             </a:r>
             <a:endParaRPr lang="en-US" sz="1100" dirty="0"/>
           </a:p>
@@ -2609,328 +2763,94 @@
       </p:sp>
       <p:sp>
         <p:nvSpPr>
-          <p:cNvPr id="11" name="Text 8"/>
-          <p:cNvSpPr/>
-          <p:nvPr/>
-        </p:nvSpPr>
-        <p:spPr>
-          <a:xfrm>
-            <a:off x="4983480" y="1673352"/>
-            <a:ext cx="3474720" cy="347472"/>
-          </a:xfrm>
-          <a:prstGeom prst="rect">
-            <a:avLst/>
-          </a:prstGeom>
-          <a:noFill/>
-          <a:ln/>
-        </p:spPr>
-        <p:txBody>
-          <a:bodyPr wrap="square" rtlCol="0" anchor="ctr"/>
-          <a:lstStyle/>
-          <a:p>
-            <a:pPr indent="0" marL="0">
-              <a:buNone/>
-            </a:pPr>
-            <a:r>
-              <a:rPr lang="en-US" sz="950" dirty="0">
+          <p:cNvPr id="14" name="Text 11"/>
+          <p:cNvSpPr/>
+          <p:nvPr/>
+        </p:nvSpPr>
+        <p:spPr>
+          <a:xfrm>
+            <a:off x="4983480" y="3566160"/>
+            <a:ext cx="3474720" cy="1143000"/>
+          </a:xfrm>
+          <a:prstGeom prst="rect">
+            <a:avLst/>
+          </a:prstGeom>
+          <a:noFill/>
+          <a:ln/>
+        </p:spPr>
+        <p:txBody>
+          <a:bodyPr wrap="square" rtlCol="0" anchor="ctr"/>
+          <a:lstStyle/>
+          <a:p>
+            <a:pPr indent="0" marL="0">
+              <a:buNone/>
+            </a:pPr>
+            <a:r>
+              <a:rPr lang="en-US" sz="900" b="1" dirty="0">
+                <a:solidFill>
+                  <a:srgbClr val="0F172A"/>
+                </a:solidFill>
+              </a:rPr>
+              <a:t>• Telegram Xavfsizlik Boti: </a:t>
+            </a:r>
+            <a:pPr indent="0" marL="0">
+              <a:buNone/>
+            </a:pPr>
+            <a:r>
+              <a:rPr lang="en-US" sz="900" dirty="0">
                 <a:solidFill>
                   <a:srgbClr val="475569"/>
                 </a:solidFill>
               </a:rPr>
-              <a:t>O‘zbekiston to‘lov tizimlari (Click, Payme, Uzcard) kiber-xavflariga moslangan.</a:t>
-            </a:r>
-            <a:endParaRPr lang="en-US" sz="950" dirty="0"/>
-          </a:p>
-        </p:txBody>
-      </p:sp>
-      <p:sp>
-        <p:nvSpPr>
-          <p:cNvPr id="12" name="Shape 9"/>
-          <p:cNvSpPr/>
-          <p:nvPr/>
-        </p:nvSpPr>
-        <p:spPr>
-          <a:xfrm>
-            <a:off x="4846320" y="2194560"/>
-            <a:ext cx="3749040" cy="749808"/>
-          </a:xfrm>
-          <a:prstGeom prst="roundRect">
-            <a:avLst/>
-          </a:prstGeom>
-          <a:solidFill>
-            <a:srgbClr val="FFFFFF"/>
-          </a:solidFill>
-          <a:ln w="19050">
-            <a:solidFill>
-              <a:srgbClr val="6EE7B7"/>
-            </a:solidFill>
-            <a:prstDash val="solid"/>
-          </a:ln>
-        </p:spPr>
-      </p:sp>
-      <p:sp>
-        <p:nvSpPr>
-          <p:cNvPr id="13" name="Text 10"/>
-          <p:cNvSpPr/>
-          <p:nvPr/>
-        </p:nvSpPr>
-        <p:spPr>
-          <a:xfrm>
-            <a:off x="4983480" y="2267712"/>
-            <a:ext cx="3474720" cy="274320"/>
-          </a:xfrm>
-          <a:prstGeom prst="rect">
-            <a:avLst/>
-          </a:prstGeom>
-          <a:noFill/>
-          <a:ln/>
-        </p:spPr>
-        <p:txBody>
-          <a:bodyPr wrap="square" rtlCol="0" anchor="ctr"/>
-          <a:lstStyle/>
-          <a:p>
-            <a:pPr indent="0" marL="0">
-              <a:buNone/>
-            </a:pPr>
-            <a:r>
-              <a:rPr lang="en-US" sz="1100" b="1" dirty="0">
-                <a:solidFill>
-                  <a:srgbClr val="059669"/>
-                </a:solidFill>
-              </a:rPr>
-              <a:t>2. Ta'lim + Jonli Himoya</a:t>
-            </a:r>
-            <a:endParaRPr lang="en-US" sz="1100" dirty="0"/>
-          </a:p>
-        </p:txBody>
-      </p:sp>
-      <p:sp>
-        <p:nvSpPr>
-          <p:cNvPr id="14" name="Text 11"/>
-          <p:cNvSpPr/>
-          <p:nvPr/>
-        </p:nvSpPr>
-        <p:spPr>
-          <a:xfrm>
-            <a:off x="4983480" y="2542032"/>
-            <a:ext cx="3474720" cy="347472"/>
-          </a:xfrm>
-          <a:prstGeom prst="rect">
-            <a:avLst/>
-          </a:prstGeom>
-          <a:noFill/>
-          <a:ln/>
-        </p:spPr>
-        <p:txBody>
-          <a:bodyPr wrap="square" rtlCol="0" anchor="ctr"/>
-          <a:lstStyle/>
-          <a:p>
-            <a:pPr indent="0" marL="0">
-              <a:buNone/>
-            </a:pPr>
-            <a:r>
-              <a:rPr lang="en-US" sz="950" dirty="0">
+              <a:t>Shubhali faylni botga yuborib 2 soniyada natija olish.
+</a:t>
+            </a:r>
+            <a:pPr indent="0" marL="0">
+              <a:buNone/>
+            </a:pPr>
+            <a:r>
+              <a:rPr lang="en-US" sz="900" b="1" dirty="0">
+                <a:solidFill>
+                  <a:srgbClr val="0F172A"/>
+                </a:solidFill>
+              </a:rPr>
+              <a:t>• B2B Korporativ Audit: </a:t>
+            </a:r>
+            <a:pPr indent="0" marL="0">
+              <a:buNone/>
+            </a:pPr>
+            <a:r>
+              <a:rPr lang="en-US" sz="900" dirty="0">
                 <a:solidFill>
                   <a:srgbClr val="475569"/>
                 </a:solidFill>
               </a:rPr>
-              <a:t>Faqat ma'ruza emas — smartfon va fayllarni amalda tekshirish qurollari bor.</a:t>
-            </a:r>
-            <a:endParaRPr lang="en-US" sz="950" dirty="0"/>
-          </a:p>
-        </p:txBody>
-      </p:sp>
-      <p:sp>
-        <p:nvSpPr>
-          <p:cNvPr id="15" name="Shape 12"/>
-          <p:cNvSpPr/>
-          <p:nvPr/>
-        </p:nvSpPr>
-        <p:spPr>
-          <a:xfrm>
-            <a:off x="4846320" y="3063240"/>
-            <a:ext cx="3749040" cy="749808"/>
-          </a:xfrm>
-          <a:prstGeom prst="roundRect">
-            <a:avLst/>
-          </a:prstGeom>
-          <a:solidFill>
-            <a:srgbClr val="FFFFFF"/>
-          </a:solidFill>
-          <a:ln w="19050">
-            <a:solidFill>
-              <a:srgbClr val="6EE7B7"/>
-            </a:solidFill>
-            <a:prstDash val="solid"/>
-          </a:ln>
-        </p:spPr>
-      </p:sp>
-      <p:sp>
-        <p:nvSpPr>
-          <p:cNvPr id="16" name="Text 13"/>
-          <p:cNvSpPr/>
-          <p:nvPr/>
-        </p:nvSpPr>
-        <p:spPr>
-          <a:xfrm>
-            <a:off x="4983480" y="3136392"/>
-            <a:ext cx="3474720" cy="274320"/>
-          </a:xfrm>
-          <a:prstGeom prst="rect">
-            <a:avLst/>
-          </a:prstGeom>
-          <a:noFill/>
-          <a:ln/>
-        </p:spPr>
-        <p:txBody>
-          <a:bodyPr wrap="square" rtlCol="0" anchor="ctr"/>
-          <a:lstStyle/>
-          <a:p>
-            <a:pPr indent="0" marL="0">
-              <a:buNone/>
-            </a:pPr>
-            <a:r>
-              <a:rPr lang="en-US" sz="1100" b="1" dirty="0">
-                <a:solidFill>
-                  <a:srgbClr val="059669"/>
-                </a:solidFill>
-              </a:rPr>
-              <a:t>3. Gamifikatsiya va Musobaqa</a:t>
-            </a:r>
-            <a:endParaRPr lang="en-US" sz="1100" dirty="0"/>
-          </a:p>
-        </p:txBody>
-      </p:sp>
-      <p:sp>
-        <p:nvSpPr>
-          <p:cNvPr id="17" name="Text 14"/>
-          <p:cNvSpPr/>
-          <p:nvPr/>
-        </p:nvSpPr>
-        <p:spPr>
-          <a:xfrm>
-            <a:off x="4983480" y="3410712"/>
-            <a:ext cx="3474720" cy="347472"/>
-          </a:xfrm>
-          <a:prstGeom prst="rect">
-            <a:avLst/>
-          </a:prstGeom>
-          <a:noFill/>
-          <a:ln/>
-        </p:spPr>
-        <p:txBody>
-          <a:bodyPr wrap="square" rtlCol="0" anchor="ctr"/>
-          <a:lstStyle/>
-          <a:p>
-            <a:pPr indent="0" marL="0">
-              <a:buNone/>
-            </a:pPr>
-            <a:r>
-              <a:rPr lang="en-US" sz="950" dirty="0">
+              <a:t>Banklar va korxonalar uchun fishing simulyatsiyasi.
+</a:t>
+            </a:r>
+            <a:pPr indent="0" marL="0">
+              <a:buNone/>
+            </a:pPr>
+            <a:r>
+              <a:rPr lang="en-US" sz="900" b="1" dirty="0">
+                <a:solidFill>
+                  <a:srgbClr val="0F172A"/>
+                </a:solidFill>
+              </a:rPr>
+              <a:t>• Respublika CTF Musobaqasi: </a:t>
+            </a:r>
+            <a:pPr indent="0" marL="0">
+              <a:buNone/>
+            </a:pPr>
+            <a:r>
+              <a:rPr lang="en-US" sz="900" dirty="0">
                 <a:solidFill>
                   <a:srgbClr val="475569"/>
                 </a:solidFill>
               </a:rPr>
-              <a:t>Topshiriqlarni bajarish orqali ballar to‘plab umumiy reytingda ko‘tarilish.</a:t>
-            </a:r>
-            <a:endParaRPr lang="en-US" sz="950" dirty="0"/>
-          </a:p>
-        </p:txBody>
-      </p:sp>
-      <p:sp>
-        <p:nvSpPr>
-          <p:cNvPr id="18" name="Shape 15"/>
-          <p:cNvSpPr/>
-          <p:nvPr/>
-        </p:nvSpPr>
-        <p:spPr>
-          <a:xfrm>
-            <a:off x="4846320" y="3931920"/>
-            <a:ext cx="3749040" cy="749808"/>
-          </a:xfrm>
-          <a:prstGeom prst="roundRect">
-            <a:avLst/>
-          </a:prstGeom>
-          <a:solidFill>
-            <a:srgbClr val="FFFFFF"/>
-          </a:solidFill>
-          <a:ln w="19050">
-            <a:solidFill>
-              <a:srgbClr val="6EE7B7"/>
-            </a:solidFill>
-            <a:prstDash val="solid"/>
-          </a:ln>
-        </p:spPr>
-      </p:sp>
-      <p:sp>
-        <p:nvSpPr>
-          <p:cNvPr id="19" name="Text 16"/>
-          <p:cNvSpPr/>
-          <p:nvPr/>
-        </p:nvSpPr>
-        <p:spPr>
-          <a:xfrm>
-            <a:off x="4983480" y="4005072"/>
-            <a:ext cx="3474720" cy="274320"/>
-          </a:xfrm>
-          <a:prstGeom prst="rect">
-            <a:avLst/>
-          </a:prstGeom>
-          <a:noFill/>
-          <a:ln/>
-        </p:spPr>
-        <p:txBody>
-          <a:bodyPr wrap="square" rtlCol="0" anchor="ctr"/>
-          <a:lstStyle/>
-          <a:p>
-            <a:pPr indent="0" marL="0">
-              <a:buNone/>
-            </a:pPr>
-            <a:r>
-              <a:rPr lang="en-US" sz="1100" b="1" dirty="0">
-                <a:solidFill>
-                  <a:srgbClr val="059669"/>
-                </a:solidFill>
-              </a:rPr>
-              <a:t>4. CyberGuard AI Maslahatchi</a:t>
-            </a:r>
-            <a:endParaRPr lang="en-US" sz="1100" dirty="0"/>
-          </a:p>
-        </p:txBody>
-      </p:sp>
-      <p:sp>
-        <p:nvSpPr>
-          <p:cNvPr id="20" name="Text 17"/>
-          <p:cNvSpPr/>
-          <p:nvPr/>
-        </p:nvSpPr>
-        <p:spPr>
-          <a:xfrm>
-            <a:off x="4983480" y="4279392"/>
-            <a:ext cx="3474720" cy="347472"/>
-          </a:xfrm>
-          <a:prstGeom prst="rect">
-            <a:avLst/>
-          </a:prstGeom>
-          <a:noFill/>
-          <a:ln/>
-        </p:spPr>
-        <p:txBody>
-          <a:bodyPr wrap="square" rtlCol="0" anchor="ctr"/>
-          <a:lstStyle/>
-          <a:p>
-            <a:pPr indent="0" marL="0">
-              <a:buNone/>
-            </a:pPr>
-            <a:r>
-              <a:rPr lang="en-US" sz="950" dirty="0">
-                <a:solidFill>
-                  <a:srgbClr val="475569"/>
-                </a:solidFill>
-              </a:rPr>
-              <a:t>Har qanday kiber-savolga o‘zbek tilida 24/7 tezkor va tushunarli javob.</a:t>
-            </a:r>
-            <a:endParaRPr lang="en-US" sz="950" dirty="0"/>
+              <a:t>Yoshlar o‘rtasida kiber-olimpiada o‘tkazish.</a:t>
+            </a:r>
+            <a:endParaRPr lang="en-US" sz="900" dirty="0"/>
           </a:p>
         </p:txBody>
       </p:sp>
@@ -2948,7 +2868,7 @@
     <p:bg>
       <p:bgPr>
         <a:solidFill>
-          <a:srgbClr val="F4F6F9"/>
+          <a:srgbClr val="0A192F"/>
         </a:solidFill>
       </p:bgPr>
     </p:bg>
@@ -2974,14 +2894,14 @@
         </p:nvSpPr>
         <p:spPr>
           <a:xfrm>
-            <a:off x="548640" y="228600"/>
+            <a:off x="548640" y="320040"/>
             <a:ext cx="2011680" cy="274320"/>
           </a:xfrm>
           <a:prstGeom prst="roundRect">
             <a:avLst/>
           </a:prstGeom>
           <a:solidFill>
-            <a:srgbClr val="ECFDF5"/>
+            <a:srgbClr val="064E3B"/>
           </a:solidFill>
           <a:ln w="12700">
             <a:solidFill>
@@ -2999,7 +2919,7 @@
         </p:nvSpPr>
         <p:spPr>
           <a:xfrm>
-            <a:off x="548640" y="228600"/>
+            <a:off x="548640" y="320040"/>
             <a:ext cx="2011680" cy="274320"/>
           </a:xfrm>
           <a:prstGeom prst="rect">
@@ -3016,14 +2936,14 @@
               <a:buNone/>
             </a:pPr>
             <a:r>
-              <a:rPr lang="en-US" sz="950" b="1" dirty="0">
-                <a:solidFill>
-                  <a:srgbClr val="059669"/>
-                </a:solidFill>
-              </a:rPr>
-              <a:t>SLAYD 11 / 13</a:t>
-            </a:r>
-            <a:endParaRPr lang="en-US" sz="950" dirty="0"/>
+              <a:rPr lang="en-US" sz="1000" b="1" dirty="0">
+                <a:solidFill>
+                  <a:srgbClr val="34D399"/>
+                </a:solidFill>
+              </a:rPr>
+              <a:t>11 · MUALLIF</a:t>
+            </a:r>
+            <a:endParaRPr lang="en-US" sz="1000" dirty="0"/>
           </a:p>
         </p:txBody>
       </p:sp>
@@ -3035,29 +2955,68 @@
         </p:nvSpPr>
         <p:spPr>
           <a:xfrm>
-            <a:off x="548640" y="548640"/>
-            <a:ext cx="8046720" cy="411480"/>
-          </a:xfrm>
-          <a:prstGeom prst="rect">
-            <a:avLst/>
-          </a:prstGeom>
-          <a:noFill/>
-          <a:ln/>
-        </p:spPr>
-        <p:txBody>
-          <a:bodyPr wrap="square" rtlCol="0" anchor="ctr"/>
-          <a:lstStyle/>
-          <a:p>
-            <a:pPr indent="0" marL="0">
+            <a:off x="548640" y="685800"/>
+            <a:ext cx="4937760" cy="457200"/>
+          </a:xfrm>
+          <a:prstGeom prst="rect">
+            <a:avLst/>
+          </a:prstGeom>
+          <a:noFill/>
+          <a:ln/>
+        </p:spPr>
+        <p:txBody>
+          <a:bodyPr wrap="square" rtlCol="0" anchor="ctr"/>
+          <a:lstStyle/>
+          <a:p>
+            <a:pPr indent="0" marL="0">
+              <a:buNone/>
+            </a:pPr>
+            <a:r>
+              <a:rPr lang="en-US" sz="2200" b="1" dirty="0">
+                <a:solidFill>
+                  <a:srgbClr val="000000"/>
+                </a:solidFill>
+              </a:rPr>
+              <a:t>Loyihani kim yaratdi?</a:t>
+            </a:r>
+            <a:endParaRPr lang="en-US" sz="2200" dirty="0"/>
+          </a:p>
+        </p:txBody>
+      </p:sp>
+      <p:sp>
+        <p:nvSpPr>
+          <p:cNvPr id="5" name="Text 3"/>
+          <p:cNvSpPr/>
+          <p:nvPr/>
+        </p:nvSpPr>
+        <p:spPr>
+          <a:xfrm>
+            <a:off x="548640" y="1143000"/>
+            <a:ext cx="4937760" cy="822960"/>
+          </a:xfrm>
+          <a:prstGeom prst="rect">
+            <a:avLst/>
+          </a:prstGeom>
+          <a:noFill/>
+          <a:ln/>
+        </p:spPr>
+        <p:txBody>
+          <a:bodyPr wrap="square" rtlCol="0" anchor="ctr"/>
+          <a:lstStyle/>
+          <a:p>
+            <a:pPr indent="0" marL="0">
+              <a:lnSpc>
+                <a:spcPct val="115000"/>
+              </a:lnSpc>
               <a:buNone/>
             </a:pPr>
             <a:r>
               <a:rPr lang="en-US" sz="2000" b="1" dirty="0">
                 <a:solidFill>
-                  <a:srgbClr val="0F172A"/>
-                </a:solidFill>
-              </a:rPr>
-              <a:t>Kamchiliklar va Rivojlantirish Rejalari</a:t>
+                  <a:srgbClr val="F8FAFC"/>
+                </a:solidFill>
+              </a:rPr>
+              <a:t>Loyihaning barcha qismlari Abduraxmonov Bexruz tomonidan bajarilgan.</a:t>
             </a:r>
             <a:endParaRPr lang="en-US" sz="2000" dirty="0"/>
           </a:p>
@@ -3065,50 +3024,235 @@
       </p:sp>
       <p:sp>
         <p:nvSpPr>
-          <p:cNvPr id="5" name="Text 3"/>
-          <p:cNvSpPr/>
-          <p:nvPr/>
-        </p:nvSpPr>
-        <p:spPr>
-          <a:xfrm>
-            <a:off x="548640" y="960120"/>
-            <a:ext cx="8046720" cy="274320"/>
-          </a:xfrm>
-          <a:prstGeom prst="rect">
-            <a:avLst/>
-          </a:prstGeom>
-          <a:noFill/>
-          <a:ln/>
-        </p:spPr>
-        <p:txBody>
-          <a:bodyPr wrap="square" rtlCol="0" anchor="ctr"/>
-          <a:lstStyle/>
-          <a:p>
-            <a:pPr indent="0" marL="0">
+          <p:cNvPr id="6" name="Text 4"/>
+          <p:cNvSpPr/>
+          <p:nvPr/>
+        </p:nvSpPr>
+        <p:spPr>
+          <a:xfrm>
+            <a:off x="548640" y="2057400"/>
+            <a:ext cx="4937760" cy="320040"/>
+          </a:xfrm>
+          <a:prstGeom prst="rect">
+            <a:avLst/>
+          </a:prstGeom>
+          <a:noFill/>
+          <a:ln/>
+        </p:spPr>
+        <p:txBody>
+          <a:bodyPr wrap="square" rtlCol="0" anchor="ctr"/>
+          <a:lstStyle/>
+          <a:p>
+            <a:pPr indent="0" marL="0">
+              <a:buNone/>
+            </a:pPr>
+            <a:r>
+              <a:rPr lang="en-US" sz="1200" b="1" dirty="0">
+                <a:solidFill>
+                  <a:srgbClr val="6EE7B7"/>
+                </a:solidFill>
+              </a:rPr>
+              <a:t>ROLI:  Muallif, dizayner va dasturchi</a:t>
+            </a:r>
+            <a:endParaRPr lang="en-US" sz="1200" dirty="0"/>
+          </a:p>
+        </p:txBody>
+      </p:sp>
+      <p:sp>
+        <p:nvSpPr>
+          <p:cNvPr id="7" name="Shape 5"/>
+          <p:cNvSpPr/>
+          <p:nvPr/>
+        </p:nvSpPr>
+        <p:spPr>
+          <a:xfrm>
+            <a:off x="548640" y="2468880"/>
+            <a:ext cx="4937760" cy="2240280"/>
+          </a:xfrm>
+          <a:prstGeom prst="roundRect">
+            <a:avLst/>
+          </a:prstGeom>
+          <a:solidFill>
+            <a:srgbClr val="0F243A"/>
+          </a:solidFill>
+          <a:ln w="19050">
+            <a:solidFill>
+              <a:srgbClr val="1E3A52"/>
+            </a:solidFill>
+            <a:prstDash val="solid"/>
+          </a:ln>
+        </p:spPr>
+      </p:sp>
+      <p:sp>
+        <p:nvSpPr>
+          <p:cNvPr id="8" name="Text 6"/>
+          <p:cNvSpPr/>
+          <p:nvPr/>
+        </p:nvSpPr>
+        <p:spPr>
+          <a:xfrm>
+            <a:off x="731520" y="2560320"/>
+            <a:ext cx="4572000" cy="274320"/>
+          </a:xfrm>
+          <a:prstGeom prst="rect">
+            <a:avLst/>
+          </a:prstGeom>
+          <a:noFill/>
+          <a:ln/>
+        </p:spPr>
+        <p:txBody>
+          <a:bodyPr wrap="square" rtlCol="0" anchor="ctr"/>
+          <a:lstStyle/>
+          <a:p>
+            <a:pPr indent="0" marL="0">
+              <a:buNone/>
+            </a:pPr>
+            <a:r>
+              <a:rPr lang="en-US" sz="1200" b="1" dirty="0">
+                <a:solidFill>
+                  <a:srgbClr val="10B981"/>
+                </a:solidFill>
+              </a:rPr>
+              <a:t>Bajargan ishlari:</a:t>
+            </a:r>
+            <a:endParaRPr lang="en-US" sz="1200" dirty="0"/>
+          </a:p>
+        </p:txBody>
+      </p:sp>
+      <p:sp>
+        <p:nvSpPr>
+          <p:cNvPr id="9" name="Text 7"/>
+          <p:cNvSpPr/>
+          <p:nvPr/>
+        </p:nvSpPr>
+        <p:spPr>
+          <a:xfrm>
+            <a:off x="731520" y="2880360"/>
+            <a:ext cx="4572000" cy="1737360"/>
+          </a:xfrm>
+          <a:prstGeom prst="rect">
+            <a:avLst/>
+          </a:prstGeom>
+          <a:noFill/>
+          <a:ln/>
+        </p:spPr>
+        <p:txBody>
+          <a:bodyPr wrap="square" rtlCol="0" anchor="ctr"/>
+          <a:lstStyle/>
+          <a:p>
+            <a:pPr indent="0" marL="0">
+              <a:lnSpc>
+                <a:spcPct val="125000"/>
+              </a:lnSpc>
               <a:buNone/>
             </a:pPr>
             <a:r>
               <a:rPr lang="en-US" sz="1100" dirty="0">
                 <a:solidFill>
-                  <a:srgbClr val="475569"/>
-                </a:solidFill>
-              </a:rPr>
-              <a:t>Haqiqiy holatni ochiq baholash va kelajakdagi takomillashtirish bosqichlari</a:t>
+                  <a:srgbClr val="F8FAFC"/>
+                </a:solidFill>
+              </a:rPr>
+              <a:t>• Loyiha g‘oyasi va arxitektura tuzilmasi</a:t>
             </a:r>
             <a:endParaRPr lang="en-US" sz="1100" dirty="0"/>
           </a:p>
-        </p:txBody>
-      </p:sp>
-      <p:sp>
-        <p:nvSpPr>
-          <p:cNvPr id="6" name="Shape 4"/>
-          <p:cNvSpPr/>
-          <p:nvPr/>
-        </p:nvSpPr>
-        <p:spPr>
-          <a:xfrm>
-            <a:off x="512064" y="1289304"/>
-            <a:ext cx="4096512" cy="3822192"/>
+          <a:p>
+            <a:pPr indent="0" marL="0">
+              <a:lnSpc>
+                <a:spcPct val="125000"/>
+              </a:lnSpc>
+              <a:buNone/>
+            </a:pPr>
+            <a:r>
+              <a:rPr lang="en-US" sz="1100" dirty="0">
+                <a:solidFill>
+                  <a:srgbClr val="F8FAFC"/>
+                </a:solidFill>
+              </a:rPr>
+              <a:t>• UI/UX dizayn va vizual interfeys</a:t>
+            </a:r>
+            <a:endParaRPr lang="en-US" sz="1100" dirty="0"/>
+          </a:p>
+          <a:p>
+            <a:pPr indent="0" marL="0">
+              <a:lnSpc>
+                <a:spcPct val="125000"/>
+              </a:lnSpc>
+              <a:buNone/>
+            </a:pPr>
+            <a:r>
+              <a:rPr lang="en-US" sz="1100" dirty="0">
+                <a:solidFill>
+                  <a:srgbClr val="F8FAFC"/>
+                </a:solidFill>
+              </a:rPr>
+              <a:t>• React, Vite va Tailwind CSS bilan dasturlash</a:t>
+            </a:r>
+            <a:endParaRPr lang="en-US" sz="1100" dirty="0"/>
+          </a:p>
+          <a:p>
+            <a:pPr indent="0" marL="0">
+              <a:lnSpc>
+                <a:spcPct val="125000"/>
+              </a:lnSpc>
+              <a:buNone/>
+            </a:pPr>
+            <a:r>
+              <a:rPr lang="en-US" sz="1100" dirty="0">
+                <a:solidFill>
+                  <a:srgbClr val="F8FAFC"/>
+                </a:solidFill>
+              </a:rPr>
+              <a:t>• O‘quv modullari, laboratoriyalar va Sezar shifri</a:t>
+            </a:r>
+            <a:endParaRPr lang="en-US" sz="1100" dirty="0"/>
+          </a:p>
+          <a:p>
+            <a:pPr indent="0" marL="0">
+              <a:lnSpc>
+                <a:spcPct val="125000"/>
+              </a:lnSpc>
+              <a:buNone/>
+            </a:pPr>
+            <a:r>
+              <a:rPr lang="en-US" sz="1100" dirty="0">
+                <a:solidFill>
+                  <a:srgbClr val="F8FAFC"/>
+                </a:solidFill>
+              </a:rPr>
+              <a:t>• Vercel bulutiga joylashtirish va CI/CD</a:t>
+            </a:r>
+            <a:endParaRPr lang="en-US" sz="1100" dirty="0"/>
+          </a:p>
+          <a:p>
+            <a:pPr indent="0" marL="0">
+              <a:lnSpc>
+                <a:spcPct val="125000"/>
+              </a:lnSpc>
+              <a:buNone/>
+            </a:pPr>
+            <a:r>
+              <a:rPr lang="en-US" sz="1100" dirty="0">
+                <a:solidFill>
+                  <a:srgbClr val="F8FAFC"/>
+                </a:solidFill>
+              </a:rPr>
+              <a:t>• Sinov va taqdimotga to‘liq tayyorlash</a:t>
+            </a:r>
+            <a:endParaRPr lang="en-US" sz="1100" dirty="0"/>
+          </a:p>
+        </p:txBody>
+      </p:sp>
+      <p:sp>
+        <p:nvSpPr>
+          <p:cNvPr id="10" name="Shape 8"/>
+          <p:cNvSpPr/>
+          <p:nvPr/>
+        </p:nvSpPr>
+        <p:spPr>
+          <a:xfrm>
+            <a:off x="5806440" y="640080"/>
+            <a:ext cx="2834640" cy="4069080"/>
           </a:xfrm>
           <a:prstGeom prst="roundRect">
             <a:avLst/>
@@ -3116,9 +3260,9 @@
           <a:solidFill>
             <a:srgbClr val="0D1A26"/>
           </a:solidFill>
-          <a:ln w="19050">
+          <a:ln w="25400">
             <a:solidFill>
-              <a:srgbClr val="059669"/>
+              <a:srgbClr val="10B981"/>
             </a:solidFill>
             <a:prstDash val="solid"/>
           </a:ln>
@@ -3126,7 +3270,7 @@
       </p:sp>
       <p:pic>
         <p:nvPicPr>
-          <p:cNvPr id="7" name="Image 0" descr="C:\Users\User\Desktop\kiber xavfsizlik boyicha sayt\public\screenshots\12_casestudy.png">    </p:cNvPr>
+          <p:cNvPr id="11" name="Image 0" descr="C:\Users\User\Desktop\kiber xavfsizlik boyicha sayt\public\screenshots\author_portrait.png">    </p:cNvPr>
           <p:cNvPicPr>
             <a:picLocks noChangeAspect="1"/>
           </p:cNvPicPr>
@@ -3140,358 +3284,14 @@
         </p:blipFill>
         <p:spPr>
           <a:xfrm>
-            <a:off x="548640" y="1325880"/>
-            <a:ext cx="4023360" cy="3474720"/>
+            <a:off x="5852160" y="685800"/>
+            <a:ext cx="2743200" cy="3977640"/>
           </a:xfrm>
           <a:prstGeom prst="rect">
             <a:avLst/>
           </a:prstGeom>
         </p:spPr>
       </p:pic>
-      <p:sp>
-        <p:nvSpPr>
-          <p:cNvPr id="8" name="Text 5"/>
-          <p:cNvSpPr/>
-          <p:nvPr/>
-        </p:nvSpPr>
-        <p:spPr>
-          <a:xfrm>
-            <a:off x="548640" y="4837176"/>
-            <a:ext cx="4023360" cy="274320"/>
-          </a:xfrm>
-          <a:prstGeom prst="rect">
-            <a:avLst/>
-          </a:prstGeom>
-          <a:noFill/>
-          <a:ln/>
-        </p:spPr>
-        <p:txBody>
-          <a:bodyPr wrap="square" rtlCol="0" anchor="ctr"/>
-          <a:lstStyle/>
-          <a:p>
-            <a:pPr algn="ctr" indent="0" marL="0">
-              <a:buNone/>
-            </a:pPr>
-            <a:r>
-              <a:rPr lang="en-US" sz="900" dirty="0">
-                <a:solidFill>
-                  <a:srgbClr val="BAE6FD"/>
-                </a:solidFill>
-              </a:rPr>
-              <a:t>📸 "Hodisalar Tahlili" (Case Study) — real kiber-hujumlar tahlili</a:t>
-            </a:r>
-            <a:endParaRPr lang="en-US" sz="900" dirty="0"/>
-          </a:p>
-        </p:txBody>
-      </p:sp>
-      <p:sp>
-        <p:nvSpPr>
-          <p:cNvPr id="9" name="Shape 6"/>
-          <p:cNvSpPr/>
-          <p:nvPr/>
-        </p:nvSpPr>
-        <p:spPr>
-          <a:xfrm>
-            <a:off x="4846320" y="1325880"/>
-            <a:ext cx="3749040" cy="1645920"/>
-          </a:xfrm>
-          <a:prstGeom prst="roundRect">
-            <a:avLst/>
-          </a:prstGeom>
-          <a:solidFill>
-            <a:srgbClr val="FFFFFF"/>
-          </a:solidFill>
-          <a:ln w="19050">
-            <a:solidFill>
-              <a:srgbClr val="FCD34D"/>
-            </a:solidFill>
-            <a:prstDash val="solid"/>
-          </a:ln>
-        </p:spPr>
-      </p:sp>
-      <p:sp>
-        <p:nvSpPr>
-          <p:cNvPr id="10" name="Text 7"/>
-          <p:cNvSpPr/>
-          <p:nvPr/>
-        </p:nvSpPr>
-        <p:spPr>
-          <a:xfrm>
-            <a:off x="4983480" y="1417320"/>
-            <a:ext cx="3474720" cy="274320"/>
-          </a:xfrm>
-          <a:prstGeom prst="rect">
-            <a:avLst/>
-          </a:prstGeom>
-          <a:noFill/>
-          <a:ln/>
-        </p:spPr>
-        <p:txBody>
-          <a:bodyPr wrap="square" rtlCol="0" anchor="ctr"/>
-          <a:lstStyle/>
-          <a:p>
-            <a:pPr indent="0" marL="0">
-              <a:buNone/>
-            </a:pPr>
-            <a:r>
-              <a:rPr lang="en-US" sz="1100" b="1" dirty="0">
-                <a:solidFill>
-                  <a:srgbClr val="B45309"/>
-                </a:solidFill>
-              </a:rPr>
-              <a:t>⚠️ Aniqlangan Kamchiliklar (MVP):</a:t>
-            </a:r>
-            <a:endParaRPr lang="en-US" sz="1100" dirty="0"/>
-          </a:p>
-        </p:txBody>
-      </p:sp>
-      <p:sp>
-        <p:nvSpPr>
-          <p:cNvPr id="11" name="Text 8"/>
-          <p:cNvSpPr/>
-          <p:nvPr/>
-        </p:nvSpPr>
-        <p:spPr>
-          <a:xfrm>
-            <a:off x="4983480" y="1737360"/>
-            <a:ext cx="3474720" cy="1143000"/>
-          </a:xfrm>
-          <a:prstGeom prst="rect">
-            <a:avLst/>
-          </a:prstGeom>
-          <a:noFill/>
-          <a:ln/>
-        </p:spPr>
-        <p:txBody>
-          <a:bodyPr wrap="square" rtlCol="0" anchor="ctr"/>
-          <a:lstStyle/>
-          <a:p>
-            <a:pPr indent="0" marL="0">
-              <a:buNone/>
-            </a:pPr>
-            <a:r>
-              <a:rPr lang="en-US" sz="900" b="1" dirty="0">
-                <a:solidFill>
-                  <a:srgbClr val="0F172A"/>
-                </a:solidFill>
-              </a:rPr>
-              <a:t>• Dinamik Server Sandboxing: </a:t>
-            </a:r>
-            <a:pPr indent="0" marL="0">
-              <a:buNone/>
-            </a:pPr>
-            <a:r>
-              <a:rPr lang="en-US" sz="900" dirty="0">
-                <a:solidFill>
-                  <a:srgbClr val="475569"/>
-                </a:solidFill>
-              </a:rPr>
-              <a:t>Hozircha veb-simulyatsiya; to‘liq Docker muhiti zarur.
-</a:t>
-            </a:r>
-            <a:pPr indent="0" marL="0">
-              <a:buNone/>
-            </a:pPr>
-            <a:r>
-              <a:rPr lang="en-US" sz="900" b="1" dirty="0">
-                <a:solidFill>
-                  <a:srgbClr val="0F172A"/>
-                </a:solidFill>
-              </a:rPr>
-              <a:t>• Mahalliy ilova yo‘qligi: </a:t>
-            </a:r>
-            <a:pPr indent="0" marL="0">
-              <a:buNone/>
-            </a:pPr>
-            <a:r>
-              <a:rPr lang="en-US" sz="900" dirty="0">
-                <a:solidFill>
-                  <a:srgbClr val="475569"/>
-                </a:solidFill>
-              </a:rPr>
-              <a:t>Android/iOS ilovasi ishlab chiqilmoqda.
-</a:t>
-            </a:r>
-            <a:pPr indent="0" marL="0">
-              <a:buNone/>
-            </a:pPr>
-            <a:r>
-              <a:rPr lang="en-US" sz="900" b="1" dirty="0">
-                <a:solidFill>
-                  <a:srgbClr val="0F172A"/>
-                </a:solidFill>
-              </a:rPr>
-              <a:t>• Telegram bot: </a:t>
-            </a:r>
-            <a:pPr indent="0" marL="0">
-              <a:buNone/>
-            </a:pPr>
-            <a:r>
-              <a:rPr lang="en-US" sz="900" dirty="0">
-                <a:solidFill>
-                  <a:srgbClr val="475569"/>
-                </a:solidFill>
-              </a:rPr>
-              <a:t>Avtomatik APK tekshiruvchi bot ulanmoqda.</a:t>
-            </a:r>
-            <a:endParaRPr lang="en-US" sz="900" dirty="0"/>
-          </a:p>
-        </p:txBody>
-      </p:sp>
-      <p:sp>
-        <p:nvSpPr>
-          <p:cNvPr id="12" name="Shape 9"/>
-          <p:cNvSpPr/>
-          <p:nvPr/>
-        </p:nvSpPr>
-        <p:spPr>
-          <a:xfrm>
-            <a:off x="4846320" y="3154680"/>
-            <a:ext cx="3749040" cy="1645920"/>
-          </a:xfrm>
-          <a:prstGeom prst="roundRect">
-            <a:avLst/>
-          </a:prstGeom>
-          <a:solidFill>
-            <a:srgbClr val="FFFFFF"/>
-          </a:solidFill>
-          <a:ln w="19050">
-            <a:solidFill>
-              <a:srgbClr val="6EE7B7"/>
-            </a:solidFill>
-            <a:prstDash val="solid"/>
-          </a:ln>
-        </p:spPr>
-      </p:sp>
-      <p:sp>
-        <p:nvSpPr>
-          <p:cNvPr id="13" name="Text 10"/>
-          <p:cNvSpPr/>
-          <p:nvPr/>
-        </p:nvSpPr>
-        <p:spPr>
-          <a:xfrm>
-            <a:off x="4983480" y="3246120"/>
-            <a:ext cx="3474720" cy="274320"/>
-          </a:xfrm>
-          <a:prstGeom prst="rect">
-            <a:avLst/>
-          </a:prstGeom>
-          <a:noFill/>
-          <a:ln/>
-        </p:spPr>
-        <p:txBody>
-          <a:bodyPr wrap="square" rtlCol="0" anchor="ctr"/>
-          <a:lstStyle/>
-          <a:p>
-            <a:pPr indent="0" marL="0">
-              <a:buNone/>
-            </a:pPr>
-            <a:r>
-              <a:rPr lang="en-US" sz="1100" b="1" dirty="0">
-                <a:solidFill>
-                  <a:srgbClr val="059669"/>
-                </a:solidFill>
-              </a:rPr>
-              <a:t>🚀 Kelajakdagi Rivojlantirish:</a:t>
-            </a:r>
-            <a:endParaRPr lang="en-US" sz="1100" dirty="0"/>
-          </a:p>
-        </p:txBody>
-      </p:sp>
-      <p:sp>
-        <p:nvSpPr>
-          <p:cNvPr id="14" name="Text 11"/>
-          <p:cNvSpPr/>
-          <p:nvPr/>
-        </p:nvSpPr>
-        <p:spPr>
-          <a:xfrm>
-            <a:off x="4983480" y="3566160"/>
-            <a:ext cx="3474720" cy="1143000"/>
-          </a:xfrm>
-          <a:prstGeom prst="rect">
-            <a:avLst/>
-          </a:prstGeom>
-          <a:noFill/>
-          <a:ln/>
-        </p:spPr>
-        <p:txBody>
-          <a:bodyPr wrap="square" rtlCol="0" anchor="ctr"/>
-          <a:lstStyle/>
-          <a:p>
-            <a:pPr indent="0" marL="0">
-              <a:buNone/>
-            </a:pPr>
-            <a:r>
-              <a:rPr lang="en-US" sz="900" b="1" dirty="0">
-                <a:solidFill>
-                  <a:srgbClr val="0F172A"/>
-                </a:solidFill>
-              </a:rPr>
-              <a:t>• Telegram Xavfsizlik Boti: </a:t>
-            </a:r>
-            <a:pPr indent="0" marL="0">
-              <a:buNone/>
-            </a:pPr>
-            <a:r>
-              <a:rPr lang="en-US" sz="900" dirty="0">
-                <a:solidFill>
-                  <a:srgbClr val="475569"/>
-                </a:solidFill>
-              </a:rPr>
-              <a:t>Shubhali faylni botga yuborib 2 soniyada natija olish.
-</a:t>
-            </a:r>
-            <a:pPr indent="0" marL="0">
-              <a:buNone/>
-            </a:pPr>
-            <a:r>
-              <a:rPr lang="en-US" sz="900" b="1" dirty="0">
-                <a:solidFill>
-                  <a:srgbClr val="0F172A"/>
-                </a:solidFill>
-              </a:rPr>
-              <a:t>• B2B Korporativ Audit: </a:t>
-            </a:r>
-            <a:pPr indent="0" marL="0">
-              <a:buNone/>
-            </a:pPr>
-            <a:r>
-              <a:rPr lang="en-US" sz="900" dirty="0">
-                <a:solidFill>
-                  <a:srgbClr val="475569"/>
-                </a:solidFill>
-              </a:rPr>
-              <a:t>Banklar va korxonalar uchun fishing simulyatsiyasi.
-</a:t>
-            </a:r>
-            <a:pPr indent="0" marL="0">
-              <a:buNone/>
-            </a:pPr>
-            <a:r>
-              <a:rPr lang="en-US" sz="900" b="1" dirty="0">
-                <a:solidFill>
-                  <a:srgbClr val="0F172A"/>
-                </a:solidFill>
-              </a:rPr>
-              <a:t>• Respublika CTF Musobaqasi: </a:t>
-            </a:r>
-            <a:pPr indent="0" marL="0">
-              <a:buNone/>
-            </a:pPr>
-            <a:r>
-              <a:rPr lang="en-US" sz="900" dirty="0">
-                <a:solidFill>
-                  <a:srgbClr val="475569"/>
-                </a:solidFill>
-              </a:rPr>
-              <a:t>Yoshlar o‘rtasida kiber-olimpiada o‘tkazish.</a:t>
-            </a:r>
-            <a:endParaRPr lang="en-US" sz="900" dirty="0"/>
-          </a:p>
-        </p:txBody>
-      </p:sp>
     </p:spTree>
   </p:cSld>
   <p:clrMapOvr>
@@ -7849,7 +7649,7 @@
     <p:bg>
       <p:bgPr>
         <a:solidFill>
-          <a:srgbClr val="0A192F"/>
+          <a:srgbClr val="F4F6F9"/>
         </a:solidFill>
       </p:bgPr>
     </p:bg>
@@ -7875,14 +7675,14 @@
         </p:nvSpPr>
         <p:spPr>
           <a:xfrm>
-            <a:off x="548640" y="320040"/>
+            <a:off x="548640" y="228600"/>
             <a:ext cx="2011680" cy="274320"/>
           </a:xfrm>
           <a:prstGeom prst="roundRect">
             <a:avLst/>
           </a:prstGeom>
           <a:solidFill>
-            <a:srgbClr val="064E3B"/>
+            <a:srgbClr val="ECFDF5"/>
           </a:solidFill>
           <a:ln w="12700">
             <a:solidFill>
@@ -7900,7 +7700,7 @@
         </p:nvSpPr>
         <p:spPr>
           <a:xfrm>
-            <a:off x="548640" y="320040"/>
+            <a:off x="548640" y="228600"/>
             <a:ext cx="2011680" cy="274320"/>
           </a:xfrm>
           <a:prstGeom prst="rect">
@@ -7917,14 +7717,14 @@
               <a:buNone/>
             </a:pPr>
             <a:r>
-              <a:rPr lang="en-US" sz="1000" b="1" dirty="0">
-                <a:solidFill>
-                  <a:srgbClr val="34D399"/>
-                </a:solidFill>
-              </a:rPr>
-              <a:t>08 · MUALLIF</a:t>
-            </a:r>
-            <a:endParaRPr lang="en-US" sz="1000" dirty="0"/>
+              <a:rPr lang="en-US" sz="950" b="1" dirty="0">
+                <a:solidFill>
+                  <a:srgbClr val="059669"/>
+                </a:solidFill>
+              </a:rPr>
+              <a:t>SLAYD 08 / 13</a:t>
+            </a:r>
+            <a:endParaRPr lang="en-US" sz="950" dirty="0"/>
           </a:p>
         </p:txBody>
       </p:sp>
@@ -7936,31 +7736,31 @@
         </p:nvSpPr>
         <p:spPr>
           <a:xfrm>
-            <a:off x="548640" y="685800"/>
-            <a:ext cx="4937760" cy="457200"/>
-          </a:xfrm>
-          <a:prstGeom prst="rect">
-            <a:avLst/>
-          </a:prstGeom>
-          <a:noFill/>
-          <a:ln/>
-        </p:spPr>
-        <p:txBody>
-          <a:bodyPr wrap="square" rtlCol="0" anchor="ctr"/>
-          <a:lstStyle/>
-          <a:p>
-            <a:pPr indent="0" marL="0">
-              <a:buNone/>
-            </a:pPr>
-            <a:r>
-              <a:rPr lang="en-US" sz="2200" b="1" dirty="0">
-                <a:solidFill>
-                  <a:srgbClr val="000000"/>
-                </a:solidFill>
-              </a:rPr>
-              <a:t>Loyihani kim yaratdi?</a:t>
-            </a:r>
-            <a:endParaRPr lang="en-US" sz="2200" dirty="0"/>
+            <a:off x="548640" y="548640"/>
+            <a:ext cx="8046720" cy="411480"/>
+          </a:xfrm>
+          <a:prstGeom prst="rect">
+            <a:avLst/>
+          </a:prstGeom>
+          <a:noFill/>
+          <a:ln/>
+        </p:spPr>
+        <p:txBody>
+          <a:bodyPr wrap="square" rtlCol="0" anchor="ctr"/>
+          <a:lstStyle/>
+          <a:p>
+            <a:pPr indent="0" marL="0">
+              <a:buNone/>
+            </a:pPr>
+            <a:r>
+              <a:rPr lang="en-US" sz="2000" b="1" dirty="0">
+                <a:solidFill>
+                  <a:srgbClr val="0F172A"/>
+                </a:solidFill>
+              </a:rPr>
+              <a:t>Texnologiyalar: Loyihaning haqiqiy texnik asosi</a:t>
+            </a:r>
+            <a:endParaRPr lang="en-US" sz="2000" dirty="0"/>
           </a:p>
         </p:txBody>
       </p:sp>
@@ -7972,286 +7772,62 @@
         </p:nvSpPr>
         <p:spPr>
           <a:xfrm>
-            <a:off x="548640" y="1143000"/>
-            <a:ext cx="4937760" cy="822960"/>
-          </a:xfrm>
-          <a:prstGeom prst="rect">
-            <a:avLst/>
-          </a:prstGeom>
-          <a:noFill/>
-          <a:ln/>
-        </p:spPr>
-        <p:txBody>
-          <a:bodyPr wrap="square" rtlCol="0" anchor="ctr"/>
-          <a:lstStyle/>
-          <a:p>
-            <a:pPr indent="0" marL="0">
-              <a:lnSpc>
-                <a:spcPct val="115000"/>
-              </a:lnSpc>
-              <a:buNone/>
-            </a:pPr>
-            <a:r>
-              <a:rPr lang="en-US" sz="2000" b="1" dirty="0">
-                <a:solidFill>
-                  <a:srgbClr val="F8FAFC"/>
-                </a:solidFill>
-              </a:rPr>
-              <a:t>Loyihaning barcha qismlari Abduraxmonov Bexruz tomonidan bajarilgan.</a:t>
-            </a:r>
-            <a:endParaRPr lang="en-US" sz="2000" dirty="0"/>
-          </a:p>
-        </p:txBody>
-      </p:sp>
-      <p:sp>
-        <p:nvSpPr>
-          <p:cNvPr id="6" name="Text 4"/>
-          <p:cNvSpPr/>
-          <p:nvPr/>
-        </p:nvSpPr>
-        <p:spPr>
-          <a:xfrm>
-            <a:off x="548640" y="2057400"/>
-            <a:ext cx="4937760" cy="320040"/>
-          </a:xfrm>
-          <a:prstGeom prst="rect">
-            <a:avLst/>
-          </a:prstGeom>
-          <a:noFill/>
-          <a:ln/>
-        </p:spPr>
-        <p:txBody>
-          <a:bodyPr wrap="square" rtlCol="0" anchor="ctr"/>
-          <a:lstStyle/>
-          <a:p>
-            <a:pPr indent="0" marL="0">
-              <a:buNone/>
-            </a:pPr>
-            <a:r>
-              <a:rPr lang="en-US" sz="1200" b="1" dirty="0">
-                <a:solidFill>
-                  <a:srgbClr val="6EE7B7"/>
-                </a:solidFill>
-              </a:rPr>
-              <a:t>ROLI:  Muallif, dizayner va dasturchi</a:t>
-            </a:r>
-            <a:endParaRPr lang="en-US" sz="1200" dirty="0"/>
-          </a:p>
-        </p:txBody>
-      </p:sp>
-      <p:sp>
-        <p:nvSpPr>
-          <p:cNvPr id="7" name="Shape 5"/>
-          <p:cNvSpPr/>
-          <p:nvPr/>
-        </p:nvSpPr>
-        <p:spPr>
-          <a:xfrm>
-            <a:off x="548640" y="2468880"/>
-            <a:ext cx="4937760" cy="2240280"/>
+            <a:off x="548640" y="960120"/>
+            <a:ext cx="8046720" cy="274320"/>
+          </a:xfrm>
+          <a:prstGeom prst="rect">
+            <a:avLst/>
+          </a:prstGeom>
+          <a:noFill/>
+          <a:ln/>
+        </p:spPr>
+        <p:txBody>
+          <a:bodyPr wrap="square" rtlCol="0" anchor="ctr"/>
+          <a:lstStyle/>
+          <a:p>
+            <a:pPr indent="0" marL="0">
+              <a:buNone/>
+            </a:pPr>
+            <a:r>
+              <a:rPr lang="en-US" sz="1100" dirty="0">
+                <a:solidFill>
+                  <a:srgbClr val="475569"/>
+                </a:solidFill>
+              </a:rPr>
+              <a:t>Kod bazasi (package.json va arxitektura) orqali 100% tasdiqlangan texnologiyalar</a:t>
+            </a:r>
+            <a:endParaRPr lang="en-US" sz="1100" dirty="0"/>
+          </a:p>
+        </p:txBody>
+      </p:sp>
+      <p:sp>
+        <p:nvSpPr>
+          <p:cNvPr id="6" name="Shape 4"/>
+          <p:cNvSpPr/>
+          <p:nvPr/>
+        </p:nvSpPr>
+        <p:spPr>
+          <a:xfrm>
+            <a:off x="512064" y="1289304"/>
+            <a:ext cx="4096512" cy="3822192"/>
           </a:xfrm>
           <a:prstGeom prst="roundRect">
             <a:avLst/>
           </a:prstGeom>
           <a:solidFill>
-            <a:srgbClr val="0F243A"/>
+            <a:srgbClr val="0D1A26"/>
           </a:solidFill>
           <a:ln w="19050">
             <a:solidFill>
-              <a:srgbClr val="1E3A52"/>
+              <a:srgbClr val="059669"/>
             </a:solidFill>
             <a:prstDash val="solid"/>
           </a:ln>
         </p:spPr>
       </p:sp>
-      <p:sp>
-        <p:nvSpPr>
-          <p:cNvPr id="8" name="Text 6"/>
-          <p:cNvSpPr/>
-          <p:nvPr/>
-        </p:nvSpPr>
-        <p:spPr>
-          <a:xfrm>
-            <a:off x="731520" y="2560320"/>
-            <a:ext cx="4572000" cy="274320"/>
-          </a:xfrm>
-          <a:prstGeom prst="rect">
-            <a:avLst/>
-          </a:prstGeom>
-          <a:noFill/>
-          <a:ln/>
-        </p:spPr>
-        <p:txBody>
-          <a:bodyPr wrap="square" rtlCol="0" anchor="ctr"/>
-          <a:lstStyle/>
-          <a:p>
-            <a:pPr indent="0" marL="0">
-              <a:buNone/>
-            </a:pPr>
-            <a:r>
-              <a:rPr lang="en-US" sz="1200" b="1" dirty="0">
-                <a:solidFill>
-                  <a:srgbClr val="10B981"/>
-                </a:solidFill>
-              </a:rPr>
-              <a:t>Bajargan ishlari:</a:t>
-            </a:r>
-            <a:endParaRPr lang="en-US" sz="1200" dirty="0"/>
-          </a:p>
-        </p:txBody>
-      </p:sp>
-      <p:sp>
-        <p:nvSpPr>
-          <p:cNvPr id="9" name="Text 7"/>
-          <p:cNvSpPr/>
-          <p:nvPr/>
-        </p:nvSpPr>
-        <p:spPr>
-          <a:xfrm>
-            <a:off x="731520" y="2880360"/>
-            <a:ext cx="4572000" cy="1737360"/>
-          </a:xfrm>
-          <a:prstGeom prst="rect">
-            <a:avLst/>
-          </a:prstGeom>
-          <a:noFill/>
-          <a:ln/>
-        </p:spPr>
-        <p:txBody>
-          <a:bodyPr wrap="square" rtlCol="0" anchor="ctr"/>
-          <a:lstStyle/>
-          <a:p>
-            <a:pPr indent="0" marL="0">
-              <a:lnSpc>
-                <a:spcPct val="125000"/>
-              </a:lnSpc>
-              <a:buNone/>
-            </a:pPr>
-            <a:r>
-              <a:rPr lang="en-US" sz="1100" dirty="0">
-                <a:solidFill>
-                  <a:srgbClr val="F8FAFC"/>
-                </a:solidFill>
-              </a:rPr>
-              <a:t>• Loyiha g‘oyasi va arxitektura tuzilmasi</a:t>
-            </a:r>
-            <a:endParaRPr lang="en-US" sz="1100" dirty="0"/>
-          </a:p>
-          <a:p>
-            <a:pPr indent="0" marL="0">
-              <a:lnSpc>
-                <a:spcPct val="125000"/>
-              </a:lnSpc>
-              <a:buNone/>
-            </a:pPr>
-            <a:r>
-              <a:rPr lang="en-US" sz="1100" dirty="0">
-                <a:solidFill>
-                  <a:srgbClr val="F8FAFC"/>
-                </a:solidFill>
-              </a:rPr>
-              <a:t>• UI/UX dizayn va vizual interfeys</a:t>
-            </a:r>
-            <a:endParaRPr lang="en-US" sz="1100" dirty="0"/>
-          </a:p>
-          <a:p>
-            <a:pPr indent="0" marL="0">
-              <a:lnSpc>
-                <a:spcPct val="125000"/>
-              </a:lnSpc>
-              <a:buNone/>
-            </a:pPr>
-            <a:r>
-              <a:rPr lang="en-US" sz="1100" dirty="0">
-                <a:solidFill>
-                  <a:srgbClr val="F8FAFC"/>
-                </a:solidFill>
-              </a:rPr>
-              <a:t>• React, Vite va Tailwind CSS bilan dasturlash</a:t>
-            </a:r>
-            <a:endParaRPr lang="en-US" sz="1100" dirty="0"/>
-          </a:p>
-          <a:p>
-            <a:pPr indent="0" marL="0">
-              <a:lnSpc>
-                <a:spcPct val="125000"/>
-              </a:lnSpc>
-              <a:buNone/>
-            </a:pPr>
-            <a:r>
-              <a:rPr lang="en-US" sz="1100" dirty="0">
-                <a:solidFill>
-                  <a:srgbClr val="F8FAFC"/>
-                </a:solidFill>
-              </a:rPr>
-              <a:t>• O‘quv modullari, laboratoriyalar va Sezar shifri</a:t>
-            </a:r>
-            <a:endParaRPr lang="en-US" sz="1100" dirty="0"/>
-          </a:p>
-          <a:p>
-            <a:pPr indent="0" marL="0">
-              <a:lnSpc>
-                <a:spcPct val="125000"/>
-              </a:lnSpc>
-              <a:buNone/>
-            </a:pPr>
-            <a:r>
-              <a:rPr lang="en-US" sz="1100" dirty="0">
-                <a:solidFill>
-                  <a:srgbClr val="F8FAFC"/>
-                </a:solidFill>
-              </a:rPr>
-              <a:t>• Vercel bulutiga joylashtirish va CI/CD</a:t>
-            </a:r>
-            <a:endParaRPr lang="en-US" sz="1100" dirty="0"/>
-          </a:p>
-          <a:p>
-            <a:pPr indent="0" marL="0">
-              <a:lnSpc>
-                <a:spcPct val="125000"/>
-              </a:lnSpc>
-              <a:buNone/>
-            </a:pPr>
-            <a:r>
-              <a:rPr lang="en-US" sz="1100" dirty="0">
-                <a:solidFill>
-                  <a:srgbClr val="F8FAFC"/>
-                </a:solidFill>
-              </a:rPr>
-              <a:t>• Sinov va taqdimotga to‘liq tayyorlash</a:t>
-            </a:r>
-            <a:endParaRPr lang="en-US" sz="1100" dirty="0"/>
-          </a:p>
-        </p:txBody>
-      </p:sp>
-      <p:sp>
-        <p:nvSpPr>
-          <p:cNvPr id="10" name="Shape 8"/>
-          <p:cNvSpPr/>
-          <p:nvPr/>
-        </p:nvSpPr>
-        <p:spPr>
-          <a:xfrm>
-            <a:off x="5806440" y="640080"/>
-            <a:ext cx="2834640" cy="4069080"/>
-          </a:xfrm>
-          <a:prstGeom prst="roundRect">
-            <a:avLst/>
-          </a:prstGeom>
-          <a:solidFill>
-            <a:srgbClr val="0D1A26"/>
-          </a:solidFill>
-          <a:ln w="25400">
-            <a:solidFill>
-              <a:srgbClr val="10B981"/>
-            </a:solidFill>
-            <a:prstDash val="solid"/>
-          </a:ln>
-        </p:spPr>
-      </p:sp>
       <p:pic>
         <p:nvPicPr>
-          <p:cNvPr id="11" name="Image 0" descr="C:\Users\User\Desktop\kiber xavfsizlik boyicha sayt\public\screenshots\author_portrait.png">    </p:cNvPr>
+          <p:cNvPr id="7" name="Image 0" descr="C:\Users\User\Desktop\kiber xavfsizlik boyicha sayt\public\screenshots\08_cyberguard_ai.png">    </p:cNvPr>
           <p:cNvPicPr>
             <a:picLocks noChangeAspect="1"/>
           </p:cNvPicPr>
@@ -8265,14 +7841,438 @@
         </p:blipFill>
         <p:spPr>
           <a:xfrm>
-            <a:off x="5852160" y="685800"/>
-            <a:ext cx="2743200" cy="3977640"/>
+            <a:off x="548640" y="1325880"/>
+            <a:ext cx="4023360" cy="3474720"/>
           </a:xfrm>
           <a:prstGeom prst="rect">
             <a:avLst/>
           </a:prstGeom>
         </p:spPr>
       </p:pic>
+      <p:sp>
+        <p:nvSpPr>
+          <p:cNvPr id="8" name="Text 5"/>
+          <p:cNvSpPr/>
+          <p:nvPr/>
+        </p:nvSpPr>
+        <p:spPr>
+          <a:xfrm>
+            <a:off x="548640" y="4837176"/>
+            <a:ext cx="4023360" cy="274320"/>
+          </a:xfrm>
+          <a:prstGeom prst="rect">
+            <a:avLst/>
+          </a:prstGeom>
+          <a:noFill/>
+          <a:ln/>
+        </p:spPr>
+        <p:txBody>
+          <a:bodyPr wrap="square" rtlCol="0" anchor="ctr"/>
+          <a:lstStyle/>
+          <a:p>
+            <a:pPr algn="ctr" indent="0" marL="0">
+              <a:buNone/>
+            </a:pPr>
+            <a:r>
+              <a:rPr lang="en-US" sz="900" dirty="0">
+                <a:solidFill>
+                  <a:srgbClr val="BAE6FD"/>
+                </a:solidFill>
+              </a:rPr>
+              <a:t>📸 CyberGuard AI — o‘zbek tilidagi kiberxavfsizlik assistenti</a:t>
+            </a:r>
+            <a:endParaRPr lang="en-US" sz="900" dirty="0"/>
+          </a:p>
+        </p:txBody>
+      </p:sp>
+      <p:sp>
+        <p:nvSpPr>
+          <p:cNvPr id="9" name="Shape 6"/>
+          <p:cNvSpPr/>
+          <p:nvPr/>
+        </p:nvSpPr>
+        <p:spPr>
+          <a:xfrm>
+            <a:off x="4846320" y="1325880"/>
+            <a:ext cx="3749040" cy="749808"/>
+          </a:xfrm>
+          <a:prstGeom prst="roundRect">
+            <a:avLst/>
+          </a:prstGeom>
+          <a:solidFill>
+            <a:srgbClr val="FFFFFF"/>
+          </a:solidFill>
+          <a:ln w="12700">
+            <a:solidFill>
+              <a:srgbClr val="E2E8F0"/>
+            </a:solidFill>
+            <a:prstDash val="solid"/>
+          </a:ln>
+        </p:spPr>
+      </p:sp>
+      <p:sp>
+        <p:nvSpPr>
+          <p:cNvPr id="10" name="Text 7"/>
+          <p:cNvSpPr/>
+          <p:nvPr/>
+        </p:nvSpPr>
+        <p:spPr>
+          <a:xfrm>
+            <a:off x="4983480" y="1399032"/>
+            <a:ext cx="3474720" cy="274320"/>
+          </a:xfrm>
+          <a:prstGeom prst="rect">
+            <a:avLst/>
+          </a:prstGeom>
+          <a:noFill/>
+          <a:ln/>
+        </p:spPr>
+        <p:txBody>
+          <a:bodyPr wrap="square" rtlCol="0" anchor="ctr"/>
+          <a:lstStyle/>
+          <a:p>
+            <a:pPr indent="0" marL="0">
+              <a:buNone/>
+            </a:pPr>
+            <a:r>
+              <a:rPr lang="en-US" sz="1200" b="1" dirty="0">
+                <a:solidFill>
+                  <a:srgbClr val="0284C7"/>
+                </a:solidFill>
+              </a:rPr>
+              <a:t>React 18 &amp; Vite</a:t>
+            </a:r>
+            <a:endParaRPr lang="en-US" sz="1200" dirty="0"/>
+          </a:p>
+        </p:txBody>
+      </p:sp>
+      <p:sp>
+        <p:nvSpPr>
+          <p:cNvPr id="11" name="Text 8"/>
+          <p:cNvSpPr/>
+          <p:nvPr/>
+        </p:nvSpPr>
+        <p:spPr>
+          <a:xfrm>
+            <a:off x="4983480" y="1673352"/>
+            <a:ext cx="3474720" cy="347472"/>
+          </a:xfrm>
+          <a:prstGeom prst="rect">
+            <a:avLst/>
+          </a:prstGeom>
+          <a:noFill/>
+          <a:ln/>
+        </p:spPr>
+        <p:txBody>
+          <a:bodyPr wrap="square" rtlCol="0" anchor="ctr"/>
+          <a:lstStyle/>
+          <a:p>
+            <a:pPr indent="0" marL="0">
+              <a:buNone/>
+            </a:pPr>
+            <a:r>
+              <a:rPr lang="en-US" sz="950" dirty="0">
+                <a:solidFill>
+                  <a:srgbClr val="475569"/>
+                </a:solidFill>
+              </a:rPr>
+              <a:t>Tezkor SPA arxitekturasi va modulli frontend.</a:t>
+            </a:r>
+            <a:endParaRPr lang="en-US" sz="950" dirty="0"/>
+          </a:p>
+        </p:txBody>
+      </p:sp>
+      <p:sp>
+        <p:nvSpPr>
+          <p:cNvPr id="12" name="Shape 9"/>
+          <p:cNvSpPr/>
+          <p:nvPr/>
+        </p:nvSpPr>
+        <p:spPr>
+          <a:xfrm>
+            <a:off x="4846320" y="2194560"/>
+            <a:ext cx="3749040" cy="749808"/>
+          </a:xfrm>
+          <a:prstGeom prst="roundRect">
+            <a:avLst/>
+          </a:prstGeom>
+          <a:solidFill>
+            <a:srgbClr val="FFFFFF"/>
+          </a:solidFill>
+          <a:ln w="12700">
+            <a:solidFill>
+              <a:srgbClr val="E2E8F0"/>
+            </a:solidFill>
+            <a:prstDash val="solid"/>
+          </a:ln>
+        </p:spPr>
+      </p:sp>
+      <p:sp>
+        <p:nvSpPr>
+          <p:cNvPr id="13" name="Text 10"/>
+          <p:cNvSpPr/>
+          <p:nvPr/>
+        </p:nvSpPr>
+        <p:spPr>
+          <a:xfrm>
+            <a:off x="4983480" y="2267712"/>
+            <a:ext cx="3474720" cy="274320"/>
+          </a:xfrm>
+          <a:prstGeom prst="rect">
+            <a:avLst/>
+          </a:prstGeom>
+          <a:noFill/>
+          <a:ln/>
+        </p:spPr>
+        <p:txBody>
+          <a:bodyPr wrap="square" rtlCol="0" anchor="ctr"/>
+          <a:lstStyle/>
+          <a:p>
+            <a:pPr indent="0" marL="0">
+              <a:buNone/>
+            </a:pPr>
+            <a:r>
+              <a:rPr lang="en-US" sz="1200" b="1" dirty="0">
+                <a:solidFill>
+                  <a:srgbClr val="059669"/>
+                </a:solidFill>
+              </a:rPr>
+              <a:t>Tailwind CSS</a:t>
+            </a:r>
+            <a:endParaRPr lang="en-US" sz="1200" dirty="0"/>
+          </a:p>
+        </p:txBody>
+      </p:sp>
+      <p:sp>
+        <p:nvSpPr>
+          <p:cNvPr id="14" name="Text 11"/>
+          <p:cNvSpPr/>
+          <p:nvPr/>
+        </p:nvSpPr>
+        <p:spPr>
+          <a:xfrm>
+            <a:off x="4983480" y="2542032"/>
+            <a:ext cx="3474720" cy="347472"/>
+          </a:xfrm>
+          <a:prstGeom prst="rect">
+            <a:avLst/>
+          </a:prstGeom>
+          <a:noFill/>
+          <a:ln/>
+        </p:spPr>
+        <p:txBody>
+          <a:bodyPr wrap="square" rtlCol="0" anchor="ctr"/>
+          <a:lstStyle/>
+          <a:p>
+            <a:pPr indent="0" marL="0">
+              <a:buNone/>
+            </a:pPr>
+            <a:r>
+              <a:rPr lang="en-US" sz="950" dirty="0">
+                <a:solidFill>
+                  <a:srgbClr val="475569"/>
+                </a:solidFill>
+              </a:rPr>
+              <a:t>To‘liq moslashuvchan (responsive) qorong‘i kiber-interfeys.</a:t>
+            </a:r>
+            <a:endParaRPr lang="en-US" sz="950" dirty="0"/>
+          </a:p>
+        </p:txBody>
+      </p:sp>
+      <p:sp>
+        <p:nvSpPr>
+          <p:cNvPr id="15" name="Shape 12"/>
+          <p:cNvSpPr/>
+          <p:nvPr/>
+        </p:nvSpPr>
+        <p:spPr>
+          <a:xfrm>
+            <a:off x="4846320" y="3063240"/>
+            <a:ext cx="3749040" cy="749808"/>
+          </a:xfrm>
+          <a:prstGeom prst="roundRect">
+            <a:avLst/>
+          </a:prstGeom>
+          <a:solidFill>
+            <a:srgbClr val="FFFFFF"/>
+          </a:solidFill>
+          <a:ln w="12700">
+            <a:solidFill>
+              <a:srgbClr val="E2E8F0"/>
+            </a:solidFill>
+            <a:prstDash val="solid"/>
+          </a:ln>
+        </p:spPr>
+      </p:sp>
+      <p:sp>
+        <p:nvSpPr>
+          <p:cNvPr id="16" name="Text 13"/>
+          <p:cNvSpPr/>
+          <p:nvPr/>
+        </p:nvSpPr>
+        <p:spPr>
+          <a:xfrm>
+            <a:off x="4983480" y="3136392"/>
+            <a:ext cx="3474720" cy="274320"/>
+          </a:xfrm>
+          <a:prstGeom prst="rect">
+            <a:avLst/>
+          </a:prstGeom>
+          <a:noFill/>
+          <a:ln/>
+        </p:spPr>
+        <p:txBody>
+          <a:bodyPr wrap="square" rtlCol="0" anchor="ctr"/>
+          <a:lstStyle/>
+          <a:p>
+            <a:pPr indent="0" marL="0">
+              <a:buNone/>
+            </a:pPr>
+            <a:r>
+              <a:rPr lang="en-US" sz="1200" b="1" dirty="0">
+                <a:solidFill>
+                  <a:srgbClr val="F59E0B"/>
+                </a:solidFill>
+              </a:rPr>
+              <a:t>Lucide Icons &amp; Confetti</a:t>
+            </a:r>
+            <a:endParaRPr lang="en-US" sz="1200" dirty="0"/>
+          </a:p>
+        </p:txBody>
+      </p:sp>
+      <p:sp>
+        <p:nvSpPr>
+          <p:cNvPr id="17" name="Text 14"/>
+          <p:cNvSpPr/>
+          <p:nvPr/>
+        </p:nvSpPr>
+        <p:spPr>
+          <a:xfrm>
+            <a:off x="4983480" y="3410712"/>
+            <a:ext cx="3474720" cy="347472"/>
+          </a:xfrm>
+          <a:prstGeom prst="rect">
+            <a:avLst/>
+          </a:prstGeom>
+          <a:noFill/>
+          <a:ln/>
+        </p:spPr>
+        <p:txBody>
+          <a:bodyPr wrap="square" rtlCol="0" anchor="ctr"/>
+          <a:lstStyle/>
+          <a:p>
+            <a:pPr indent="0" marL="0">
+              <a:buNone/>
+            </a:pPr>
+            <a:r>
+              <a:rPr lang="en-US" sz="950" dirty="0">
+                <a:solidFill>
+                  <a:srgbClr val="475569"/>
+                </a:solidFill>
+              </a:rPr>
+              <a:t>Kiber piktogrammalar va gamifikatsiya effektlari.</a:t>
+            </a:r>
+            <a:endParaRPr lang="en-US" sz="950" dirty="0"/>
+          </a:p>
+        </p:txBody>
+      </p:sp>
+      <p:sp>
+        <p:nvSpPr>
+          <p:cNvPr id="18" name="Shape 15"/>
+          <p:cNvSpPr/>
+          <p:nvPr/>
+        </p:nvSpPr>
+        <p:spPr>
+          <a:xfrm>
+            <a:off x="4846320" y="3931920"/>
+            <a:ext cx="3749040" cy="749808"/>
+          </a:xfrm>
+          <a:prstGeom prst="roundRect">
+            <a:avLst/>
+          </a:prstGeom>
+          <a:solidFill>
+            <a:srgbClr val="FFFFFF"/>
+          </a:solidFill>
+          <a:ln w="12700">
+            <a:solidFill>
+              <a:srgbClr val="E2E8F0"/>
+            </a:solidFill>
+            <a:prstDash val="solid"/>
+          </a:ln>
+        </p:spPr>
+      </p:sp>
+      <p:sp>
+        <p:nvSpPr>
+          <p:cNvPr id="19" name="Text 16"/>
+          <p:cNvSpPr/>
+          <p:nvPr/>
+        </p:nvSpPr>
+        <p:spPr>
+          <a:xfrm>
+            <a:off x="4983480" y="4005072"/>
+            <a:ext cx="3474720" cy="274320"/>
+          </a:xfrm>
+          <a:prstGeom prst="rect">
+            <a:avLst/>
+          </a:prstGeom>
+          <a:noFill/>
+          <a:ln/>
+        </p:spPr>
+        <p:txBody>
+          <a:bodyPr wrap="square" rtlCol="0" anchor="ctr"/>
+          <a:lstStyle/>
+          <a:p>
+            <a:pPr indent="0" marL="0">
+              <a:buNone/>
+            </a:pPr>
+            <a:r>
+              <a:rPr lang="en-US" sz="1200" b="1" dirty="0">
+                <a:solidFill>
+                  <a:srgbClr val="0F172A"/>
+                </a:solidFill>
+              </a:rPr>
+              <a:t>Vercel Edge Cloud</a:t>
+            </a:r>
+            <a:endParaRPr lang="en-US" sz="1200" dirty="0"/>
+          </a:p>
+        </p:txBody>
+      </p:sp>
+      <p:sp>
+        <p:nvSpPr>
+          <p:cNvPr id="20" name="Text 17"/>
+          <p:cNvSpPr/>
+          <p:nvPr/>
+        </p:nvSpPr>
+        <p:spPr>
+          <a:xfrm>
+            <a:off x="4983480" y="4279392"/>
+            <a:ext cx="3474720" cy="347472"/>
+          </a:xfrm>
+          <a:prstGeom prst="rect">
+            <a:avLst/>
+          </a:prstGeom>
+          <a:noFill/>
+          <a:ln/>
+        </p:spPr>
+        <p:txBody>
+          <a:bodyPr wrap="square" rtlCol="0" anchor="ctr"/>
+          <a:lstStyle/>
+          <a:p>
+            <a:pPr indent="0" marL="0">
+              <a:buNone/>
+            </a:pPr>
+            <a:r>
+              <a:rPr lang="en-US" sz="950" dirty="0">
+                <a:solidFill>
+                  <a:srgbClr val="475569"/>
+                </a:solidFill>
+              </a:rPr>
+              <a:t>Global CDN, 24/7 uzluksiz ishlovchi bulutli serverlar.</a:t>
+            </a:r>
+            <a:endParaRPr lang="en-US" sz="950" dirty="0"/>
+          </a:p>
+        </p:txBody>
+      </p:sp>
     </p:spTree>
   </p:cSld>
   <p:clrMapOvr>
@@ -8396,7 +8396,7 @@
                   <a:srgbClr val="0F172A"/>
                 </a:solidFill>
               </a:rPr>
-              <a:t>Texnologiyalar: Loyihaning haqiqiy texnik asosi</a:t>
+              <a:t>Afzalliklari: KiberQoriqchi nega ustun?</a:t>
             </a:r>
             <a:endParaRPr lang="en-US" sz="2000" dirty="0"/>
           </a:p>
@@ -8432,7 +8432,7 @@
                   <a:srgbClr val="475569"/>
                 </a:solidFill>
               </a:rPr>
-              <a:t>Kod bazasi (package.json va arxitektura) orqali 100% tasdiqlangan texnologiyalar</a:t>
+              <a:t>Saytning haqiqiy imkoniyatlariga asoslangan asosiy raqobat ustunliklari</a:t>
             </a:r>
             <a:endParaRPr lang="en-US" sz="1100" dirty="0"/>
           </a:p>
@@ -8465,7 +8465,7 @@
       </p:sp>
       <p:pic>
         <p:nvPicPr>
-          <p:cNvPr id="7" name="Image 0" descr="C:\Users\User\Desktop\kiber xavfsizlik boyicha sayt\public\screenshots\08_cyberguard_ai.png">    </p:cNvPr>
+          <p:cNvPr id="7" name="Image 0" descr="C:\Users\User\Desktop\kiber xavfsizlik boyicha sayt\public\screenshots\07_leaderboard.png">    </p:cNvPr>
           <p:cNvPicPr>
             <a:picLocks noChangeAspect="1"/>
           </p:cNvPicPr>
@@ -8517,7 +8517,7 @@
                   <a:srgbClr val="BAE6FD"/>
                 </a:solidFill>
               </a:rPr>
-              <a:t>📸 CyberGuard AI — o‘zbek tilidagi kiberxavfsizlik assistenti</a:t>
+              <a:t>📸 "Leaderboard" — jonli reyting va musobaqa tizimi</a:t>
             </a:r>
             <a:endParaRPr lang="en-US" sz="900" dirty="0"/>
           </a:p>
@@ -8540,9 +8540,9 @@
           <a:solidFill>
             <a:srgbClr val="FFFFFF"/>
           </a:solidFill>
-          <a:ln w="12700">
+          <a:ln w="19050">
             <a:solidFill>
-              <a:srgbClr val="E2E8F0"/>
+              <a:srgbClr val="6EE7B7"/>
             </a:solidFill>
             <a:prstDash val="solid"/>
           </a:ln>
@@ -8573,14 +8573,14 @@
               <a:buNone/>
             </a:pPr>
             <a:r>
-              <a:rPr lang="en-US" sz="1200" b="1" dirty="0">
-                <a:solidFill>
-                  <a:srgbClr val="0284C7"/>
-                </a:solidFill>
-              </a:rPr>
-              <a:t>React 18 &amp; Vite</a:t>
-            </a:r>
-            <a:endParaRPr lang="en-US" sz="1200" dirty="0"/>
+              <a:rPr lang="en-US" sz="1100" b="1" dirty="0">
+                <a:solidFill>
+                  <a:srgbClr val="059669"/>
+                </a:solidFill>
+              </a:rPr>
+              <a:t>1. 100% Ona Tilimizda</a:t>
+            </a:r>
+            <a:endParaRPr lang="en-US" sz="1100" dirty="0"/>
           </a:p>
         </p:txBody>
       </p:sp>
@@ -8614,7 +8614,7 @@
                   <a:srgbClr val="475569"/>
                 </a:solidFill>
               </a:rPr>
-              <a:t>Tezkor SPA arxitekturasi va modulli frontend.</a:t>
+              <a:t>O‘zbekiston to‘lov tizimlari (Click, Payme, Uzcard) kiber-xavflariga moslangan.</a:t>
             </a:r>
             <a:endParaRPr lang="en-US" sz="950" dirty="0"/>
           </a:p>
@@ -8637,9 +8637,9 @@
           <a:solidFill>
             <a:srgbClr val="FFFFFF"/>
           </a:solidFill>
-          <a:ln w="12700">
+          <a:ln w="19050">
             <a:solidFill>
-              <a:srgbClr val="E2E8F0"/>
+              <a:srgbClr val="6EE7B7"/>
             </a:solidFill>
             <a:prstDash val="solid"/>
           </a:ln>
@@ -8670,14 +8670,14 @@
               <a:buNone/>
             </a:pPr>
             <a:r>
-              <a:rPr lang="en-US" sz="1200" b="1" dirty="0">
+              <a:rPr lang="en-US" sz="1100" b="1" dirty="0">
                 <a:solidFill>
                   <a:srgbClr val="059669"/>
                 </a:solidFill>
               </a:rPr>
-              <a:t>Tailwind CSS</a:t>
-            </a:r>
-            <a:endParaRPr lang="en-US" sz="1200" dirty="0"/>
+              <a:t>2. Ta'lim + Jonli Himoya</a:t>
+            </a:r>
+            <a:endParaRPr lang="en-US" sz="1100" dirty="0"/>
           </a:p>
         </p:txBody>
       </p:sp>
@@ -8711,7 +8711,7 @@
                   <a:srgbClr val="475569"/>
                 </a:solidFill>
               </a:rPr>
-              <a:t>To‘liq moslashuvchan (responsive) qorong‘i kiber-interfeys.</a:t>
+              <a:t>Faqat ma'ruza emas — smartfon va fayllarni amalda tekshirish qurollari bor.</a:t>
             </a:r>
             <a:endParaRPr lang="en-US" sz="950" dirty="0"/>
           </a:p>
@@ -8734,9 +8734,9 @@
           <a:solidFill>
             <a:srgbClr val="FFFFFF"/>
           </a:solidFill>
-          <a:ln w="12700">
+          <a:ln w="19050">
             <a:solidFill>
-              <a:srgbClr val="E2E8F0"/>
+              <a:srgbClr val="6EE7B7"/>
             </a:solidFill>
             <a:prstDash val="solid"/>
           </a:ln>
@@ -8767,14 +8767,14 @@
               <a:buNone/>
             </a:pPr>
             <a:r>
-              <a:rPr lang="en-US" sz="1200" b="1" dirty="0">
-                <a:solidFill>
-                  <a:srgbClr val="F59E0B"/>
-                </a:solidFill>
-              </a:rPr>
-              <a:t>Lucide Icons &amp; Confetti</a:t>
-            </a:r>
-            <a:endParaRPr lang="en-US" sz="1200" dirty="0"/>
+              <a:rPr lang="en-US" sz="1100" b="1" dirty="0">
+                <a:solidFill>
+                  <a:srgbClr val="059669"/>
+                </a:solidFill>
+              </a:rPr>
+              <a:t>3. Gamifikatsiya va Musobaqa</a:t>
+            </a:r>
+            <a:endParaRPr lang="en-US" sz="1100" dirty="0"/>
           </a:p>
         </p:txBody>
       </p:sp>
@@ -8808,7 +8808,7 @@
                   <a:srgbClr val="475569"/>
                 </a:solidFill>
               </a:rPr>
-              <a:t>Kiber piktogrammalar va gamifikatsiya effektlari.</a:t>
+              <a:t>Topshiriqlarni bajarish orqali ballar to‘plab umumiy reytingda ko‘tarilish.</a:t>
             </a:r>
             <a:endParaRPr lang="en-US" sz="950" dirty="0"/>
           </a:p>
@@ -8831,9 +8831,9 @@
           <a:solidFill>
             <a:srgbClr val="FFFFFF"/>
           </a:solidFill>
-          <a:ln w="12700">
+          <a:ln w="19050">
             <a:solidFill>
-              <a:srgbClr val="E2E8F0"/>
+              <a:srgbClr val="6EE7B7"/>
             </a:solidFill>
             <a:prstDash val="solid"/>
           </a:ln>
@@ -8864,14 +8864,14 @@
               <a:buNone/>
             </a:pPr>
             <a:r>
-              <a:rPr lang="en-US" sz="1200" b="1" dirty="0">
-                <a:solidFill>
-                  <a:srgbClr val="0F172A"/>
-                </a:solidFill>
-              </a:rPr>
-              <a:t>Vercel Edge Cloud</a:t>
-            </a:r>
-            <a:endParaRPr lang="en-US" sz="1200" dirty="0"/>
+              <a:rPr lang="en-US" sz="1100" b="1" dirty="0">
+                <a:solidFill>
+                  <a:srgbClr val="059669"/>
+                </a:solidFill>
+              </a:rPr>
+              <a:t>4. CyberGuard AI Maslahatchi</a:t>
+            </a:r>
+            <a:endParaRPr lang="en-US" sz="1100" dirty="0"/>
           </a:p>
         </p:txBody>
       </p:sp>
@@ -8905,7 +8905,7 @@
                   <a:srgbClr val="475569"/>
                 </a:solidFill>
               </a:rPr>
-              <a:t>Global CDN, 24/7 uzluksiz ishlovchi bulutli serverlar.</a:t>
+              <a:t>Har qanday kiber-savolga o‘zbek tilida 24/7 tezkor va tushunarli javob.</a:t>
             </a:r>
             <a:endParaRPr lang="en-US" sz="950" dirty="0"/>
           </a:p>

</xml_diff>